<commit_message>
Deck polish: hanging-indent wrapped bullets + lift Slide 3
Reviewed the rendered slides and fixed the two visual nits: multi-line bullets
now hang-indent under the text (not under the marker), and the demo-question
slide is lifted for better vertical balance. Regenerated the PPTX.

Co-Authored-By: Claude Opus 4.8 (1M context) <noreply@anthropic.com>
</commit_message>
<xml_diff>
--- a/deck/Evidence-Intelligence-Agent.pptx
+++ b/deck/Evidence-Intelligence-Agent.pptx
@@ -3427,7 +3427,7 @@
           </a:bodyPr>
           <a:lstStyle/>
           <a:p>
-            <a:pPr>
+            <a:pPr marL="301752" indent="-301752">
               <a:spcAft>
                 <a:spcPts val="1200"/>
               </a:spcAft>
@@ -3461,7 +3461,7 @@
             </a:r>
           </a:p>
           <a:p>
-            <a:pPr>
+            <a:pPr marL="301752" indent="-301752">
               <a:spcAft>
                 <a:spcPts val="1200"/>
               </a:spcAft>
@@ -3495,7 +3495,7 @@
             </a:r>
           </a:p>
           <a:p>
-            <a:pPr>
+            <a:pPr marL="301752" indent="-301752">
               <a:spcAft>
                 <a:spcPts val="1200"/>
               </a:spcAft>
@@ -3768,7 +3768,7 @@
           </a:bodyPr>
           <a:lstStyle/>
           <a:p>
-            <a:pPr>
+            <a:pPr marL="301752" indent="-301752">
               <a:spcAft>
                 <a:spcPts val="1200"/>
               </a:spcAft>
@@ -3802,7 +3802,7 @@
             </a:r>
           </a:p>
           <a:p>
-            <a:pPr>
+            <a:pPr marL="301752" indent="-301752">
               <a:spcAft>
                 <a:spcPts val="1200"/>
               </a:spcAft>
@@ -3836,7 +3836,7 @@
             </a:r>
           </a:p>
           <a:p>
-            <a:pPr>
+            <a:pPr marL="301752" indent="-301752">
               <a:spcAft>
                 <a:spcPts val="1200"/>
               </a:spcAft>
@@ -3870,7 +3870,7 @@
             </a:r>
           </a:p>
           <a:p>
-            <a:pPr>
+            <a:pPr marL="301752" indent="-301752">
               <a:spcAft>
                 <a:spcPts val="1200"/>
               </a:spcAft>
@@ -4095,8 +4095,8 @@
         </p:nvSpPr>
         <p:spPr>
           <a:xfrm>
-            <a:off x="822960" y="2286000"/>
-            <a:ext cx="10515600" cy="2194560"/>
+            <a:off x="822960" y="1783080"/>
+            <a:ext cx="10515600" cy="1828800"/>
           </a:xfrm>
           <a:prstGeom prst="rect">
             <a:avLst/>
@@ -4129,7 +4129,7 @@
         </p:nvSpPr>
         <p:spPr>
           <a:xfrm>
-            <a:off x="822960" y="4754880"/>
+            <a:off x="822960" y="3886200"/>
             <a:ext cx="10515600" cy="914400"/>
           </a:xfrm>
           <a:prstGeom prst="rect">
@@ -4393,7 +4393,7 @@
           </a:bodyPr>
           <a:lstStyle/>
           <a:p>
-            <a:pPr>
+            <a:pPr marL="301752" indent="-301752">
               <a:spcAft>
                 <a:spcPts val="1200"/>
               </a:spcAft>
@@ -4427,7 +4427,7 @@
             </a:r>
           </a:p>
           <a:p>
-            <a:pPr>
+            <a:pPr marL="301752" indent="-301752">
               <a:spcAft>
                 <a:spcPts val="1200"/>
               </a:spcAft>
@@ -4461,7 +4461,7 @@
             </a:r>
           </a:p>
           <a:p>
-            <a:pPr>
+            <a:pPr marL="301752" indent="-301752">
               <a:spcAft>
                 <a:spcPts val="1200"/>
               </a:spcAft>
@@ -6122,7 +6122,7 @@
           </a:bodyPr>
           <a:lstStyle/>
           <a:p>
-            <a:pPr>
+            <a:pPr marL="301752" indent="-301752">
               <a:spcAft>
                 <a:spcPts val="1200"/>
               </a:spcAft>
@@ -6156,7 +6156,7 @@
             </a:r>
           </a:p>
           <a:p>
-            <a:pPr>
+            <a:pPr marL="301752" indent="-301752">
               <a:spcAft>
                 <a:spcPts val="1200"/>
               </a:spcAft>
@@ -6190,7 +6190,7 @@
             </a:r>
           </a:p>
           <a:p>
-            <a:pPr>
+            <a:pPr marL="301752" indent="-301752">
               <a:spcAft>
                 <a:spcPts val="1200"/>
               </a:spcAft>
@@ -6463,7 +6463,7 @@
           </a:bodyPr>
           <a:lstStyle/>
           <a:p>
-            <a:pPr>
+            <a:pPr marL="301752" indent="-301752">
               <a:spcAft>
                 <a:spcPts val="1200"/>
               </a:spcAft>
@@ -6497,7 +6497,7 @@
             </a:r>
           </a:p>
           <a:p>
-            <a:pPr>
+            <a:pPr marL="301752" indent="-301752">
               <a:spcAft>
                 <a:spcPts val="1200"/>
               </a:spcAft>
@@ -6531,7 +6531,7 @@
             </a:r>
           </a:p>
           <a:p>
-            <a:pPr>
+            <a:pPr marL="301752" indent="-301752">
               <a:spcAft>
                 <a:spcPts val="1200"/>
               </a:spcAft>
@@ -6565,7 +6565,7 @@
             </a:r>
           </a:p>
           <a:p>
-            <a:pPr>
+            <a:pPr marL="301752" indent="-301752">
               <a:spcAft>
                 <a:spcPts val="1200"/>
               </a:spcAft>
@@ -6599,7 +6599,7 @@
             </a:r>
           </a:p>
           <a:p>
-            <a:pPr>
+            <a:pPr marL="301752" indent="-301752">
               <a:spcAft>
                 <a:spcPts val="1200"/>
               </a:spcAft>
@@ -6872,7 +6872,7 @@
           </a:bodyPr>
           <a:lstStyle/>
           <a:p>
-            <a:pPr>
+            <a:pPr marL="301752" indent="-301752">
               <a:spcAft>
                 <a:spcPts val="1200"/>
               </a:spcAft>
@@ -6906,7 +6906,7 @@
             </a:r>
           </a:p>
           <a:p>
-            <a:pPr>
+            <a:pPr marL="301752" indent="-301752">
               <a:spcAft>
                 <a:spcPts val="1200"/>
               </a:spcAft>
@@ -6940,7 +6940,7 @@
             </a:r>
           </a:p>
           <a:p>
-            <a:pPr>
+            <a:pPr marL="301752" indent="-301752">
               <a:spcAft>
                 <a:spcPts val="1200"/>
               </a:spcAft>
@@ -6974,7 +6974,7 @@
             </a:r>
           </a:p>
           <a:p>
-            <a:pPr>
+            <a:pPr marL="301752" indent="-301752">
               <a:spcAft>
                 <a:spcPts val="1200"/>
               </a:spcAft>

</xml_diff>

<commit_message>
Deck visuals: embed real UI screenshots on Slides 4 & 7
Captured the running UI's SAMPLE replay via Playwright (deck/capture_ui.py):
- Slide 4 (Solution): hero shot — receipts chips + green cited answer + red
  rejected panel — the "shows its receipts" proof; text left, image right.
- Slide 7 (Integrity): a crop of the actual Rejected-by-the-Evaluator panel
  with the Evaluator's reasons (incl. the rTMS overclaim).
build_deck.py embeds them when deck/assets/*.png exist, else falls back to text.

Co-Authored-By: Claude Opus 4.8 (1M context) <noreply@anthropic.com>
</commit_message>
<xml_diff>
--- a/deck/Evidence-Intelligence-Agent.pptx
+++ b/deck/Evidence-Intelligence-Agent.pptx
@@ -4379,8 +4379,8 @@
         </p:nvSpPr>
         <p:spPr>
           <a:xfrm>
-            <a:off x="640080" y="2103120"/>
-            <a:ext cx="10881360" cy="4114800"/>
+            <a:off x="640080" y="2148840"/>
+            <a:ext cx="5440680" cy="4114800"/>
           </a:xfrm>
           <a:prstGeom prst="rect">
             <a:avLst/>
@@ -4395,11 +4395,11 @@
           <a:p>
             <a:pPr marL="301752" indent="-301752">
               <a:spcAft>
-                <a:spcPts val="1200"/>
+                <a:spcPts val="1600"/>
               </a:spcAft>
             </a:pPr>
             <a:r>
-              <a:rPr sz="1800" b="1" i="0">
+              <a:rPr sz="1700" b="1" i="0">
                 <a:solidFill>
                   <a:srgbClr val="128A98"/>
                 </a:solidFill>
@@ -4408,7 +4408,7 @@
               <a:t>▸  </a:t>
             </a:r>
             <a:r>
-              <a:rPr sz="1800" b="1" i="0">
+              <a:rPr sz="1700" b="1" i="0">
                 <a:solidFill>
                   <a:srgbClr val="14202B"/>
                 </a:solidFill>
@@ -4417,7 +4417,7 @@
               <a:t>Grounded, not guessed.</a:t>
             </a:r>
             <a:r>
-              <a:rPr sz="1800" b="0" i="0">
+              <a:rPr sz="1700" b="0" i="0">
                 <a:solidFill>
                   <a:srgbClr val="5B6B7A"/>
                 </a:solidFill>
@@ -4429,11 +4429,11 @@
           <a:p>
             <a:pPr marL="301752" indent="-301752">
               <a:spcAft>
-                <a:spcPts val="1200"/>
+                <a:spcPts val="1600"/>
               </a:spcAft>
             </a:pPr>
             <a:r>
-              <a:rPr sz="1800" b="1" i="0">
+              <a:rPr sz="1700" b="1" i="0">
                 <a:solidFill>
                   <a:srgbClr val="128A98"/>
                 </a:solidFill>
@@ -4442,7 +4442,7 @@
               <a:t>▸  </a:t>
             </a:r>
             <a:r>
-              <a:rPr sz="1800" b="1" i="0">
+              <a:rPr sz="1700" b="1" i="0">
                 <a:solidFill>
                   <a:srgbClr val="14202B"/>
                 </a:solidFill>
@@ -4451,7 +4451,7 @@
               <a:t>An Evaluator that deletes what it can't back.</a:t>
             </a:r>
             <a:r>
-              <a:rPr sz="1800" b="0" i="0">
+              <a:rPr sz="1700" b="0" i="0">
                 <a:solidFill>
                   <a:srgbClr val="5B6B7A"/>
                 </a:solidFill>
@@ -4463,11 +4463,11 @@
           <a:p>
             <a:pPr marL="301752" indent="-301752">
               <a:spcAft>
-                <a:spcPts val="1200"/>
+                <a:spcPts val="1600"/>
               </a:spcAft>
             </a:pPr>
             <a:r>
-              <a:rPr sz="1800" b="1" i="0">
+              <a:rPr sz="1700" b="1" i="0">
                 <a:solidFill>
                   <a:srgbClr val="128A98"/>
                 </a:solidFill>
@@ -4476,7 +4476,7 @@
               <a:t>▸  </a:t>
             </a:r>
             <a:r>
-              <a:rPr sz="1800" b="1" i="0">
+              <a:rPr sz="1700" b="1" i="0">
                 <a:solidFill>
                   <a:srgbClr val="14202B"/>
                 </a:solidFill>
@@ -4485,7 +4485,7 @@
               <a:t>Honest scope.</a:t>
             </a:r>
             <a:r>
-              <a:rPr sz="1800" b="0" i="0">
+              <a:rPr sz="1700" b="0" i="0">
                 <a:solidFill>
                   <a:srgbClr val="5B6B7A"/>
                 </a:solidFill>
@@ -4496,9 +4496,38 @@
           </a:p>
         </p:txBody>
       </p:sp>
-      <p:sp>
-        <p:nvSpPr>
-          <p:cNvPr id="6" name="Rectangle 5"/>
+      <p:pic>
+        <p:nvPicPr>
+          <p:cNvPr id="6" name="Picture 5" descr="ui_full.png"/>
+          <p:cNvPicPr>
+            <a:picLocks noChangeAspect="1"/>
+          </p:cNvPicPr>
+          <p:nvPr/>
+        </p:nvPicPr>
+        <p:blipFill>
+          <a:blip r:embed="rId2"/>
+          <a:stretch>
+            <a:fillRect/>
+          </a:stretch>
+        </p:blipFill>
+        <p:spPr>
+          <a:xfrm>
+            <a:off x="6446520" y="2011680"/>
+            <a:ext cx="3384331" cy="4160520"/>
+          </a:xfrm>
+          <a:prstGeom prst="rect">
+            <a:avLst/>
+          </a:prstGeom>
+          <a:ln w="12700">
+            <a:solidFill>
+              <a:srgbClr val="E3E9EF"/>
+            </a:solidFill>
+          </a:ln>
+        </p:spPr>
+      </p:pic>
+      <p:sp>
+        <p:nvSpPr>
+          <p:cNvPr id="7" name="Rectangle 6"/>
           <p:cNvSpPr/>
           <p:nvPr/>
         </p:nvSpPr>
@@ -4542,7 +4571,7 @@
       </p:sp>
       <p:sp>
         <p:nvSpPr>
-          <p:cNvPr id="7" name="TextBox 6"/>
+          <p:cNvPr id="8" name="TextBox 7"/>
           <p:cNvSpPr txBox="1"/>
           <p:nvPr/>
         </p:nvSpPr>
@@ -6108,8 +6137,8 @@
         </p:nvSpPr>
         <p:spPr>
           <a:xfrm>
-            <a:off x="640080" y="2103120"/>
-            <a:ext cx="10881360" cy="4114800"/>
+            <a:off x="640080" y="2148840"/>
+            <a:ext cx="5440680" cy="4114800"/>
           </a:xfrm>
           <a:prstGeom prst="rect">
             <a:avLst/>
@@ -6124,11 +6153,11 @@
           <a:p>
             <a:pPr marL="301752" indent="-301752">
               <a:spcAft>
-                <a:spcPts val="1200"/>
+                <a:spcPts val="1400"/>
               </a:spcAft>
             </a:pPr>
             <a:r>
-              <a:rPr sz="1800" b="1" i="0">
+              <a:rPr sz="1600" b="1" i="0">
                 <a:solidFill>
                   <a:srgbClr val="C0392B"/>
                 </a:solidFill>
@@ -6137,7 +6166,7 @@
               <a:t>▸  </a:t>
             </a:r>
             <a:r>
-              <a:rPr sz="1800" b="1" i="0">
+              <a:rPr sz="1600" b="1" i="0">
                 <a:solidFill>
                   <a:srgbClr val="14202B"/>
                 </a:solidFill>
@@ -6146,7 +6175,7 @@
               <a:t>Rejected:</a:t>
             </a:r>
             <a:r>
-              <a:rPr sz="1800" b="0" i="0">
+              <a:rPr sz="1600" b="0" i="0">
                 <a:solidFill>
                   <a:srgbClr val="5B6B7A"/>
                 </a:solidFill>
@@ -6158,11 +6187,11 @@
           <a:p>
             <a:pPr marL="301752" indent="-301752">
               <a:spcAft>
-                <a:spcPts val="1200"/>
+                <a:spcPts val="1400"/>
               </a:spcAft>
             </a:pPr>
             <a:r>
-              <a:rPr sz="1800" b="1" i="0">
+              <a:rPr sz="1600" b="1" i="0">
                 <a:solidFill>
                   <a:srgbClr val="C0392B"/>
                 </a:solidFill>
@@ -6171,7 +6200,7 @@
               <a:t>▸  </a:t>
             </a:r>
             <a:r>
-              <a:rPr sz="1800" b="1" i="0">
+              <a:rPr sz="1600" b="1" i="0">
                 <a:solidFill>
                   <a:srgbClr val="14202B"/>
                 </a:solidFill>
@@ -6180,7 +6209,7 @@
               <a:t>Rejected:</a:t>
             </a:r>
             <a:r>
-              <a:rPr sz="1800" b="0" i="0">
+              <a:rPr sz="1600" b="0" i="0">
                 <a:solidFill>
                   <a:srgbClr val="5B6B7A"/>
                 </a:solidFill>
@@ -6192,11 +6221,11 @@
           <a:p>
             <a:pPr marL="301752" indent="-301752">
               <a:spcAft>
-                <a:spcPts val="1200"/>
+                <a:spcPts val="1400"/>
               </a:spcAft>
             </a:pPr>
             <a:r>
-              <a:rPr sz="1800" b="1" i="0">
+              <a:rPr sz="1600" b="1" i="0">
                 <a:solidFill>
                   <a:srgbClr val="C0392B"/>
                 </a:solidFill>
@@ -6205,7 +6234,7 @@
               <a:t>▸  </a:t>
             </a:r>
             <a:r>
-              <a:rPr sz="1800" b="1" i="0">
+              <a:rPr sz="1600" b="1" i="0">
                 <a:solidFill>
                   <a:srgbClr val="14202B"/>
                 </a:solidFill>
@@ -6214,7 +6243,7 @@
               <a:t>Every rejection carries the Evaluator's reason.</a:t>
             </a:r>
             <a:r>
-              <a:rPr sz="1800" b="0" i="0">
+              <a:rPr sz="1600" b="0" i="0">
                 <a:solidFill>
                   <a:srgbClr val="5B6B7A"/>
                 </a:solidFill>
@@ -6227,7 +6256,70 @@
       </p:sp>
       <p:sp>
         <p:nvSpPr>
-          <p:cNvPr id="6" name="Rectangle 5"/>
+          <p:cNvPr id="6" name="TextBox 5"/>
+          <p:cNvSpPr txBox="1"/>
+          <p:nvPr/>
+        </p:nvSpPr>
+        <p:spPr>
+          <a:xfrm>
+            <a:off x="6446520" y="2011680"/>
+            <a:ext cx="5120640" cy="274320"/>
+          </a:xfrm>
+          <a:prstGeom prst="rect">
+            <a:avLst/>
+          </a:prstGeom>
+          <a:noFill/>
+        </p:spPr>
+        <p:txBody>
+          <a:bodyPr wrap="square" anchor="t">
+            <a:spAutoFit/>
+          </a:bodyPr>
+          <a:lstStyle/>
+          <a:p>
+            <a:r>
+              <a:rPr sz="1100" b="0" i="1">
+                <a:solidFill>
+                  <a:srgbClr val="5B6B7A"/>
+                </a:solidFill>
+                <a:latin typeface="Segoe UI"/>
+              </a:rPr>
+              <a:t>The Evaluator's actual output (live UI):</a:t>
+            </a:r>
+          </a:p>
+        </p:txBody>
+      </p:sp>
+      <p:pic>
+        <p:nvPicPr>
+          <p:cNvPr id="7" name="Picture 6" descr="ui_rejected.png"/>
+          <p:cNvPicPr>
+            <a:picLocks noChangeAspect="1"/>
+          </p:cNvPicPr>
+          <p:nvPr/>
+        </p:nvPicPr>
+        <p:blipFill>
+          <a:blip r:embed="rId2"/>
+          <a:stretch>
+            <a:fillRect/>
+          </a:stretch>
+        </p:blipFill>
+        <p:spPr>
+          <a:xfrm>
+            <a:off x="6446520" y="2331720"/>
+            <a:ext cx="5120640" cy="2309853"/>
+          </a:xfrm>
+          <a:prstGeom prst="rect">
+            <a:avLst/>
+          </a:prstGeom>
+          <a:ln w="12700">
+            <a:solidFill>
+              <a:srgbClr val="E3E9EF"/>
+            </a:solidFill>
+          </a:ln>
+        </p:spPr>
+      </p:pic>
+      <p:sp>
+        <p:nvSpPr>
+          <p:cNvPr id="8" name="Rectangle 7"/>
           <p:cNvSpPr/>
           <p:nvPr/>
         </p:nvSpPr>
@@ -6271,7 +6363,7 @@
       </p:sp>
       <p:sp>
         <p:nvSpPr>
-          <p:cNvPr id="7" name="TextBox 6"/>
+          <p:cNvPr id="9" name="TextBox 8"/>
           <p:cNvSpPr txBox="1"/>
           <p:nvPr/>
         </p:nvSpPr>

</xml_diff>

<commit_message>
Slide 5: draw the feedback loop so it reads as a cycle, not a pipeline
The diagram was a straight Planner->...->Evaluator row — visually the "weak
agent" pipeline the title disclaims. Added the real return edge
Evaluator -> Reporter (the rounds loop re-runs the Reporter with the rejections,
loops <= MAX_ROUNDS) plus the supported-branch labels. Also corrected
docs/architecture.md, which showed the loop returning to the Analyst (the code
returns to the Reporter; the Analyst gathers evidence once up front).

Co-Authored-By: Claude Opus 4.8 (1M context) <noreply@anthropic.com>
</commit_message>
<xml_diff>
--- a/deck/Evidence-Intelligence-Agent.pptx
+++ b/deck/Evidence-Intelligence-Agent.pptx
@@ -4749,8 +4749,8 @@
         </p:nvSpPr>
         <p:spPr>
           <a:xfrm>
-            <a:off x="640080" y="2514600"/>
-            <a:ext cx="1875068" cy="1143000"/>
+            <a:off x="640080" y="2286000"/>
+            <a:ext cx="1875068" cy="1051560"/>
           </a:xfrm>
           <a:prstGeom prst="roundRect">
             <a:avLst/>
@@ -4816,7 +4816,7 @@
         </p:nvSpPr>
         <p:spPr>
           <a:xfrm>
-            <a:off x="2533436" y="2994660"/>
+            <a:off x="2533436" y="2720340"/>
             <a:ext cx="347472" cy="182880"/>
           </a:xfrm>
           <a:prstGeom prst="rightArrow">
@@ -4860,8 +4860,8 @@
         </p:nvSpPr>
         <p:spPr>
           <a:xfrm>
-            <a:off x="2899196" y="2514600"/>
-            <a:ext cx="1875068" cy="1143000"/>
+            <a:off x="2899196" y="2286000"/>
+            <a:ext cx="1875068" cy="1051560"/>
           </a:xfrm>
           <a:prstGeom prst="roundRect">
             <a:avLst/>
@@ -4927,7 +4927,7 @@
         </p:nvSpPr>
         <p:spPr>
           <a:xfrm>
-            <a:off x="4792553" y="2994660"/>
+            <a:off x="4792553" y="2720340"/>
             <a:ext cx="347472" cy="182880"/>
           </a:xfrm>
           <a:prstGeom prst="rightArrow">
@@ -4971,8 +4971,8 @@
         </p:nvSpPr>
         <p:spPr>
           <a:xfrm>
-            <a:off x="5158313" y="2514600"/>
-            <a:ext cx="1875068" cy="1143000"/>
+            <a:off x="5158313" y="2286000"/>
+            <a:ext cx="1875068" cy="1051560"/>
           </a:xfrm>
           <a:prstGeom prst="roundRect">
             <a:avLst/>
@@ -5038,7 +5038,7 @@
         </p:nvSpPr>
         <p:spPr>
           <a:xfrm>
-            <a:off x="7051669" y="2994660"/>
+            <a:off x="7051669" y="2720340"/>
             <a:ext cx="347472" cy="182880"/>
           </a:xfrm>
           <a:prstGeom prst="rightArrow">
@@ -5082,8 +5082,8 @@
         </p:nvSpPr>
         <p:spPr>
           <a:xfrm>
-            <a:off x="7417429" y="2514600"/>
-            <a:ext cx="1875068" cy="1143000"/>
+            <a:off x="7417429" y="2286000"/>
+            <a:ext cx="1875068" cy="1051560"/>
           </a:xfrm>
           <a:prstGeom prst="roundRect">
             <a:avLst/>
@@ -5149,7 +5149,7 @@
         </p:nvSpPr>
         <p:spPr>
           <a:xfrm>
-            <a:off x="9310786" y="2994660"/>
+            <a:off x="9310786" y="2720340"/>
             <a:ext cx="347472" cy="182880"/>
           </a:xfrm>
           <a:prstGeom prst="rightArrow">
@@ -5193,8 +5193,8 @@
         </p:nvSpPr>
         <p:spPr>
           <a:xfrm>
-            <a:off x="9676546" y="2514600"/>
-            <a:ext cx="1875068" cy="1143000"/>
+            <a:off x="9676546" y="2286000"/>
+            <a:ext cx="1875068" cy="1051560"/>
           </a:xfrm>
           <a:prstGeom prst="roundRect">
             <a:avLst/>
@@ -5250,16 +5250,122 @@
           </a:p>
         </p:txBody>
       </p:sp>
-      <p:sp>
-        <p:nvSpPr>
-          <p:cNvPr id="14" name="TextBox 13"/>
+      <p:cxnSp>
+        <p:nvCxnSpPr>
+          <p:cNvPr id="14" name="Connector 13"/>
+          <p:cNvCxnSpPr/>
+          <p:nvPr/>
+        </p:nvCxnSpPr>
+        <p:spPr>
+          <a:xfrm>
+            <a:off x="10614080" y="3337560"/>
+            <a:ext cx="0" cy="640079"/>
+          </a:xfrm>
+          <a:prstGeom prst="line">
+            <a:avLst/>
+          </a:prstGeom>
+          <a:ln w="25400">
+            <a:solidFill>
+              <a:srgbClr val="B8842A"/>
+            </a:solidFill>
+          </a:ln>
+        </p:spPr>
+        <p:style>
+          <a:lnRef idx="2">
+            <a:schemeClr val="accent1"/>
+          </a:lnRef>
+          <a:fillRef idx="0">
+            <a:schemeClr val="accent1"/>
+          </a:fillRef>
+          <a:effectRef idx="1">
+            <a:schemeClr val="accent1"/>
+          </a:effectRef>
+          <a:fontRef idx="minor">
+            <a:schemeClr val="tx1"/>
+          </a:fontRef>
+        </p:style>
+      </p:cxnSp>
+      <p:cxnSp>
+        <p:nvCxnSpPr>
+          <p:cNvPr id="15" name="Connector 14"/>
+          <p:cNvCxnSpPr/>
+          <p:nvPr/>
+        </p:nvCxnSpPr>
+        <p:spPr>
+          <a:xfrm flipH="1">
+            <a:off x="8354964" y="3977639"/>
+            <a:ext cx="2259116" cy="0"/>
+          </a:xfrm>
+          <a:prstGeom prst="line">
+            <a:avLst/>
+          </a:prstGeom>
+          <a:ln w="25400">
+            <a:solidFill>
+              <a:srgbClr val="B8842A"/>
+            </a:solidFill>
+          </a:ln>
+        </p:spPr>
+        <p:style>
+          <a:lnRef idx="2">
+            <a:schemeClr val="accent1"/>
+          </a:lnRef>
+          <a:fillRef idx="0">
+            <a:schemeClr val="accent1"/>
+          </a:fillRef>
+          <a:effectRef idx="1">
+            <a:schemeClr val="accent1"/>
+          </a:effectRef>
+          <a:fontRef idx="minor">
+            <a:schemeClr val="tx1"/>
+          </a:fontRef>
+        </p:style>
+      </p:cxnSp>
+      <p:cxnSp>
+        <p:nvCxnSpPr>
+          <p:cNvPr id="16" name="Connector 15"/>
+          <p:cNvCxnSpPr/>
+          <p:nvPr/>
+        </p:nvCxnSpPr>
+        <p:spPr>
+          <a:xfrm flipV="1">
+            <a:off x="8354964" y="3337560"/>
+            <a:ext cx="0" cy="640079"/>
+          </a:xfrm>
+          <a:prstGeom prst="line">
+            <a:avLst/>
+          </a:prstGeom>
+          <a:ln w="25400">
+            <a:solidFill>
+              <a:srgbClr val="B8842A"/>
+            </a:solidFill>
+            <a:tailEnd type="triangle" w="med" len="med"/>
+          </a:ln>
+        </p:spPr>
+        <p:style>
+          <a:lnRef idx="2">
+            <a:schemeClr val="accent1"/>
+          </a:lnRef>
+          <a:fillRef idx="0">
+            <a:schemeClr val="accent1"/>
+          </a:fillRef>
+          <a:effectRef idx="1">
+            <a:schemeClr val="accent1"/>
+          </a:effectRef>
+          <a:fontRef idx="minor">
+            <a:schemeClr val="tx1"/>
+          </a:fontRef>
+        </p:style>
+      </p:cxnSp>
+      <p:sp>
+        <p:nvSpPr>
+          <p:cNvPr id="17" name="TextBox 16"/>
           <p:cNvSpPr txBox="1"/>
           <p:nvPr/>
         </p:nvSpPr>
         <p:spPr>
           <a:xfrm>
-            <a:off x="640080" y="4114800"/>
-            <a:ext cx="10881360" cy="822960"/>
+            <a:off x="640080" y="4087368"/>
+            <a:ext cx="10881360" cy="320040"/>
           </a:xfrm>
           <a:prstGeom prst="rect">
             <a:avLst/>
@@ -5272,37 +5378,29 @@
           </a:bodyPr>
           <a:lstStyle/>
           <a:p>
-            <a:r>
-              <a:rPr sz="1500" b="1" i="0">
+            <a:pPr algn="ctr"/>
+            <a:r>
+              <a:rPr sz="1300" b="1" i="0">
                 <a:solidFill>
                   <a:srgbClr val="B8842A"/>
                 </a:solidFill>
                 <a:latin typeface="Segoe UI"/>
               </a:rPr>
-              <a:t>↩  Feedback loop:  </a:t>
-            </a:r>
-            <a:r>
-              <a:rPr sz="1500" b="0" i="0">
-                <a:solidFill>
-                  <a:srgbClr val="14202B"/>
-                </a:solidFill>
-                <a:latin typeface="Segoe UI"/>
-              </a:rPr>
-              <a:t>the Evaluator bounces any unsupported claim back to the Analyst (≤ MAX_ROUNDS); survivors must pass a self-consistency gate.</a:t>
-            </a:r>
-          </a:p>
-        </p:txBody>
-      </p:sp>
-      <p:sp>
-        <p:nvSpPr>
-          <p:cNvPr id="15" name="TextBox 14"/>
+              <a:t>✗ unsupported → the Reporter revises &amp; re-cites, then re-evaluates (loops ≤ MAX_ROUNDS)</a:t>
+            </a:r>
+          </a:p>
+        </p:txBody>
+      </p:sp>
+      <p:sp>
+        <p:nvSpPr>
+          <p:cNvPr id="18" name="TextBox 17"/>
           <p:cNvSpPr txBox="1"/>
           <p:nvPr/>
         </p:nvSpPr>
         <p:spPr>
           <a:xfrm>
-            <a:off x="640080" y="5029200"/>
-            <a:ext cx="10881360" cy="914400"/>
+            <a:off x="640080" y="4453127"/>
+            <a:ext cx="10881360" cy="320040"/>
           </a:xfrm>
           <a:prstGeom prst="rect">
             <a:avLst/>
@@ -5315,21 +5413,57 @@
           </a:bodyPr>
           <a:lstStyle/>
           <a:p>
-            <a:r>
-              <a:rPr sz="1400" b="0" i="0">
+            <a:pPr algn="ctr"/>
+            <a:r>
+              <a:rPr sz="1300" b="1" i="0">
+                <a:solidFill>
+                  <a:srgbClr val="128A98"/>
+                </a:solidFill>
+                <a:latin typeface="Segoe UI"/>
+              </a:rPr>
+              <a:t>✓ the cited answer ships only when every claim passes the Evaluator</a:t>
+            </a:r>
+          </a:p>
+        </p:txBody>
+      </p:sp>
+      <p:sp>
+        <p:nvSpPr>
+          <p:cNvPr id="19" name="TextBox 18"/>
+          <p:cNvSpPr txBox="1"/>
+          <p:nvPr/>
+        </p:nvSpPr>
+        <p:spPr>
+          <a:xfrm>
+            <a:off x="640080" y="5349240"/>
+            <a:ext cx="10881360" cy="822960"/>
+          </a:xfrm>
+          <a:prstGeom prst="rect">
+            <a:avLst/>
+          </a:prstGeom>
+          <a:noFill/>
+        </p:spPr>
+        <p:txBody>
+          <a:bodyPr wrap="square" anchor="t">
+            <a:spAutoFit/>
+          </a:bodyPr>
+          <a:lstStyle/>
+          <a:p>
+            <a:pPr algn="ctr"/>
+            <a:r>
+              <a:rPr sz="1300" b="0" i="0">
                 <a:solidFill>
                   <a:srgbClr val="5B6B7A"/>
                 </a:solidFill>
                 <a:latin typeface="Segoe UI"/>
               </a:rPr>
-              <a:t>Specialized roles · separate Nemotron calls · shared H-MEM evidence memory · full trace + signed Meterless receipts.</a:t>
-            </a:r>
-          </a:p>
-        </p:txBody>
-      </p:sp>
-      <p:sp>
-        <p:nvSpPr>
-          <p:cNvPr id="16" name="Rectangle 15"/>
+              <a:t>A cycle, not a line — specialized roles · separate Nemotron calls · shared H-MEM evidence memory · full trace + signed Meterless receipts.</a:t>
+            </a:r>
+          </a:p>
+        </p:txBody>
+      </p:sp>
+      <p:sp>
+        <p:nvSpPr>
+          <p:cNvPr id="20" name="Rectangle 19"/>
           <p:cNvSpPr/>
           <p:nvPr/>
         </p:nvSpPr>
@@ -5373,7 +5507,7 @@
       </p:sp>
       <p:sp>
         <p:nvSpPr>
-          <p:cNvPr id="17" name="TextBox 16"/>
+          <p:cNvPr id="21" name="TextBox 20"/>
           <p:cNvSpPr txBox="1"/>
           <p:nvPr/>
         </p:nvSpPr>

</xml_diff>

<commit_message>
Deck redesign: dark climax + dark closer, rebalanced slides, stamp motif
Visual/story pass (VC / designer / storyteller / artist lenses):
- Slide 7 is now the climax — dark full-bleed, the false claim struck out with a
  red "✗ UNSUPPORTED" stamp and the Evaluator's reason. The money moment, shown.
- Slide 10 is a dark closer on one line ("An answer you can check.") that bookends
  the title; the vision is a subline, not a roadmap.
- content_slide bullets vertically centered — fixes the top-weighting / empty lower halves.
- A ✓/✗ rubber-stamp motif (slide 7 reject, slide 9 verified) makes the "receipts"
  thesis visual. Value rhythm now: dark → white → dark climax → white → dark close.

Co-Authored-By: Claude Opus 4.8 (1M context) <noreply@anthropic.com>
</commit_message>
<xml_diff>
--- a/deck/Evidence-Intelligence-Agent.pptx
+++ b/deck/Evidence-Intelligence-Agent.pptx
@@ -3281,7 +3281,7 @@
     <p:bg>
       <p:bgPr>
         <a:solidFill>
-          <a:srgbClr val="FFFFFF"/>
+          <a:srgbClr val="14202B"/>
         </a:solidFill>
         <a:effectLst/>
       </p:bgPr>
@@ -3301,8 +3301,8 @@
         </p:nvSpPr>
         <p:spPr>
           <a:xfrm>
-            <a:off x="640080" y="457200"/>
-            <a:ext cx="10881360" cy="365760"/>
+            <a:off x="822960" y="731520"/>
+            <a:ext cx="10515600" cy="457200"/>
           </a:xfrm>
           <a:prstGeom prst="rect">
             <a:avLst/>
@@ -3322,55 +3322,21 @@
                 </a:solidFill>
                 <a:latin typeface="Segoe UI"/>
               </a:rPr>
-              <a:t>WHERE THIS GOES · FUTURE</a:t>
-            </a:r>
-          </a:p>
-        </p:txBody>
-      </p:sp>
-      <p:sp>
-        <p:nvSpPr>
-          <p:cNvPr id="3" name="TextBox 2"/>
-          <p:cNvSpPr txBox="1"/>
-          <p:nvPr/>
-        </p:nvSpPr>
-        <p:spPr>
-          <a:xfrm>
-            <a:off x="640080" y="868680"/>
-            <a:ext cx="10972800" cy="914400"/>
-          </a:xfrm>
-          <a:prstGeom prst="rect">
-            <a:avLst/>
-          </a:prstGeom>
-          <a:noFill/>
-        </p:spPr>
-        <p:txBody>
-          <a:bodyPr wrap="square" anchor="t">
-            <a:spAutoFit/>
-          </a:bodyPr>
-          <a:lstStyle/>
-          <a:p>
-            <a:r>
-              <a:rPr sz="3000" b="1" i="0">
-                <a:solidFill>
-                  <a:srgbClr val="14202B"/>
-                </a:solidFill>
-                <a:latin typeface="Segoe UI"/>
-              </a:rPr>
-              <a:t>Where this goes</a:t>
-            </a:r>
-          </a:p>
-        </p:txBody>
-      </p:sp>
-      <p:sp>
-        <p:nvSpPr>
-          <p:cNvPr id="4" name="Rectangle 3"/>
+              <a:t>WHERE THIS GOES</a:t>
+            </a:r>
+          </a:p>
+        </p:txBody>
+      </p:sp>
+      <p:sp>
+        <p:nvSpPr>
+          <p:cNvPr id="3" name="Rectangle 2"/>
           <p:cNvSpPr/>
           <p:nvPr/>
         </p:nvSpPr>
         <p:spPr>
           <a:xfrm>
-            <a:off x="658368" y="1755648"/>
-            <a:ext cx="1005840" cy="50292"/>
+            <a:off x="841248" y="2148840"/>
+            <a:ext cx="1280160" cy="54864"/>
           </a:xfrm>
           <a:prstGeom prst="rect">
             <a:avLst/>
@@ -3407,14 +3373,14 @@
       </p:sp>
       <p:sp>
         <p:nvSpPr>
-          <p:cNvPr id="5" name="TextBox 4"/>
+          <p:cNvPr id="4" name="TextBox 3"/>
           <p:cNvSpPr txBox="1"/>
           <p:nvPr/>
         </p:nvSpPr>
         <p:spPr>
           <a:xfrm>
-            <a:off x="640080" y="2103120"/>
-            <a:ext cx="10881360" cy="4114800"/>
+            <a:off x="822960" y="2377440"/>
+            <a:ext cx="10607040" cy="1188720"/>
           </a:xfrm>
           <a:prstGeom prst="rect">
             <a:avLst/>
@@ -3427,163 +3393,28 @@
           </a:bodyPr>
           <a:lstStyle/>
           <a:p>
-            <a:pPr marL="301752" indent="-301752">
-              <a:spcAft>
-                <a:spcPts val="1200"/>
-              </a:spcAft>
-            </a:pPr>
-            <a:r>
-              <a:rPr sz="1800" b="1" i="0">
-                <a:solidFill>
-                  <a:srgbClr val="128A98"/>
-                </a:solidFill>
-                <a:latin typeface="Segoe UI"/>
-              </a:rPr>
-              <a:t>▸  </a:t>
-            </a:r>
-            <a:r>
-              <a:rPr sz="1800" b="1" i="0">
-                <a:solidFill>
-                  <a:srgbClr val="14202B"/>
-                </a:solidFill>
-                <a:latin typeface="Segoe UI"/>
-              </a:rPr>
-              <a:t>Richer indication signal.</a:t>
-            </a:r>
-            <a:r>
-              <a:rPr sz="1800" b="0" i="0">
-                <a:solidFill>
-                  <a:srgbClr val="5B6B7A"/>
-                </a:solidFill>
-                <a:latin typeface="Segoe UI"/>
-              </a:rPr>
-              <a:t> Device classification + product codes; more conditions and sources.</a:t>
-            </a:r>
-          </a:p>
-          <a:p>
-            <a:pPr marL="301752" indent="-301752">
-              <a:spcAft>
-                <a:spcPts val="1200"/>
-              </a:spcAft>
-            </a:pPr>
-            <a:r>
-              <a:rPr sz="1800" b="1" i="0">
-                <a:solidFill>
-                  <a:srgbClr val="128A98"/>
-                </a:solidFill>
-                <a:latin typeface="Segoe UI"/>
-              </a:rPr>
-              <a:t>▸  </a:t>
-            </a:r>
-            <a:r>
-              <a:rPr sz="1800" b="1" i="0">
-                <a:solidFill>
-                  <a:srgbClr val="14202B"/>
-                </a:solidFill>
-                <a:latin typeface="Segoe UI"/>
-              </a:rPr>
-              <a:t>Deeper adjudication.</a:t>
-            </a:r>
-            <a:r>
-              <a:rPr sz="1800" b="0" i="0">
-                <a:solidFill>
-                  <a:srgbClr val="5B6B7A"/>
-                </a:solidFill>
-                <a:latin typeface="Segoe UI"/>
-              </a:rPr>
-              <a:t> Multi-judge panel; live on-demand source registration.</a:t>
-            </a:r>
-          </a:p>
-          <a:p>
-            <a:pPr marL="301752" indent="-301752">
-              <a:spcAft>
-                <a:spcPts val="1200"/>
-              </a:spcAft>
-            </a:pPr>
-            <a:r>
-              <a:rPr sz="1800" b="1" i="0">
-                <a:solidFill>
-                  <a:srgbClr val="128A98"/>
-                </a:solidFill>
-                <a:latin typeface="Segoe UI"/>
-              </a:rPr>
-              <a:t>▸  </a:t>
-            </a:r>
-            <a:r>
-              <a:rPr sz="1800" b="1" i="0">
-                <a:solidFill>
-                  <a:srgbClr val="14202B"/>
-                </a:solidFill>
-                <a:latin typeface="Segoe UI"/>
-              </a:rPr>
-              <a:t>The direction medical AI has to go:</a:t>
-            </a:r>
-            <a:r>
-              <a:rPr sz="1800" b="0" i="0">
-                <a:solidFill>
-                  <a:srgbClr val="5B6B7A"/>
-                </a:solidFill>
-                <a:latin typeface="Segoe UI"/>
-              </a:rPr>
-              <a:t> trustworthy, auditable, grounded — an answer you can check.</a:t>
-            </a:r>
-          </a:p>
-        </p:txBody>
-      </p:sp>
-      <p:sp>
-        <p:nvSpPr>
-          <p:cNvPr id="6" name="Rectangle 5"/>
-          <p:cNvSpPr/>
-          <p:nvPr/>
-        </p:nvSpPr>
-        <p:spPr>
-          <a:xfrm>
-            <a:off x="640080" y="6400800"/>
-            <a:ext cx="10908792" cy="15240"/>
-          </a:xfrm>
-          <a:prstGeom prst="rect">
-            <a:avLst/>
-          </a:prstGeom>
-          <a:solidFill>
-            <a:srgbClr val="E3E9EF"/>
-          </a:solidFill>
-          <a:ln>
-            <a:noFill/>
-          </a:ln>
-          <a:effectLst/>
-        </p:spPr>
-        <p:style>
-          <a:lnRef idx="1">
-            <a:schemeClr val="accent1"/>
-          </a:lnRef>
-          <a:fillRef idx="3">
-            <a:schemeClr val="accent1"/>
-          </a:fillRef>
-          <a:effectRef idx="2">
-            <a:schemeClr val="accent1"/>
-          </a:effectRef>
-          <a:fontRef idx="minor">
-            <a:schemeClr val="lt1"/>
-          </a:fontRef>
-        </p:style>
-        <p:txBody>
-          <a:bodyPr rtlCol="0" anchor="ctr"/>
-          <a:lstStyle/>
-          <a:p>
-            <a:pPr algn="ctr"/>
-          </a:p>
-        </p:txBody>
-      </p:sp>
-      <p:sp>
-        <p:nvSpPr>
-          <p:cNvPr id="7" name="TextBox 6"/>
+            <a:r>
+              <a:rPr sz="4600" b="1" i="0">
+                <a:solidFill>
+                  <a:srgbClr val="FFFFFF"/>
+                </a:solidFill>
+                <a:latin typeface="Segoe UI"/>
+              </a:rPr>
+              <a:t>An answer you can check.</a:t>
+            </a:r>
+          </a:p>
+        </p:txBody>
+      </p:sp>
+      <p:sp>
+        <p:nvSpPr>
+          <p:cNvPr id="5" name="TextBox 4"/>
           <p:cNvSpPr txBox="1"/>
           <p:nvPr/>
         </p:nvSpPr>
         <p:spPr>
           <a:xfrm>
-            <a:off x="640080" y="6437376"/>
-            <a:ext cx="10908792" cy="320040"/>
+            <a:off x="822960" y="3840480"/>
+            <a:ext cx="10607040" cy="1005840"/>
           </a:xfrm>
           <a:prstGeom prst="rect">
             <a:avLst/>
@@ -3597,13 +3428,47 @@
           <a:lstStyle/>
           <a:p>
             <a:r>
-              <a:rPr sz="900" b="0" i="0">
-                <a:solidFill>
-                  <a:srgbClr val="5B6B7A"/>
-                </a:solidFill>
-                <a:latin typeface="Segoe UI"/>
-              </a:rPr>
-              <a:t>Evidence-Intelligence Agent · Open Agent Hackathon 2026 · Track 02 · Fylaktis Fylaktou · UCLA Semel Institute</a:t>
+              <a:rPr sz="1800" b="0" i="0">
+                <a:solidFill>
+                  <a:srgbClr val="A9B7C0"/>
+                </a:solidFill>
+                <a:latin typeface="Segoe UI"/>
+              </a:rPr>
+              <a:t>Next: richer indication signals · more conditions &amp; sources · a multi-judge panel — trustworthy, auditable AI for clinical evidence.</a:t>
+            </a:r>
+          </a:p>
+        </p:txBody>
+      </p:sp>
+      <p:sp>
+        <p:nvSpPr>
+          <p:cNvPr id="6" name="TextBox 5"/>
+          <p:cNvSpPr txBox="1"/>
+          <p:nvPr/>
+        </p:nvSpPr>
+        <p:spPr>
+          <a:xfrm>
+            <a:off x="822960" y="5943600"/>
+            <a:ext cx="10607040" cy="457200"/>
+          </a:xfrm>
+          <a:prstGeom prst="rect">
+            <a:avLst/>
+          </a:prstGeom>
+          <a:noFill/>
+        </p:spPr>
+        <p:txBody>
+          <a:bodyPr wrap="square" anchor="t">
+            <a:spAutoFit/>
+          </a:bodyPr>
+          <a:lstStyle/>
+          <a:p>
+            <a:r>
+              <a:rPr sz="1300" b="0" i="0">
+                <a:solidFill>
+                  <a:srgbClr val="A9B7C0"/>
+                </a:solidFill>
+                <a:latin typeface="Segoe UI"/>
+              </a:rPr>
+              <a:t>Fylaktis Fylaktou · UCLA Semel Institute · Open Agent Hackathon 2026 · Track 02</a:t>
             </a:r>
           </a:p>
         </p:txBody>
@@ -3754,8 +3619,8 @@
         </p:nvSpPr>
         <p:spPr>
           <a:xfrm>
-            <a:off x="640080" y="2103120"/>
-            <a:ext cx="10881360" cy="4114800"/>
+            <a:off x="640080" y="1965960"/>
+            <a:ext cx="10881360" cy="4297680"/>
           </a:xfrm>
           <a:prstGeom prst="rect">
             <a:avLst/>
@@ -3763,7 +3628,7 @@
           <a:noFill/>
         </p:spPr>
         <p:txBody>
-          <a:bodyPr wrap="square" anchor="t">
+          <a:bodyPr wrap="square" anchor="ctr">
             <a:spAutoFit/>
           </a:bodyPr>
           <a:lstStyle/>
@@ -6139,7 +6004,7 @@
     <p:bg>
       <p:bgPr>
         <a:solidFill>
-          <a:srgbClr val="FFFFFF"/>
+          <a:srgbClr val="14202B"/>
         </a:solidFill>
         <a:effectLst/>
       </p:bgPr>
@@ -6159,7 +6024,7 @@
         </p:nvSpPr>
         <p:spPr>
           <a:xfrm>
-            <a:off x="640080" y="457200"/>
+            <a:off x="640080" y="502920"/>
             <a:ext cx="10881360" cy="365760"/>
           </a:xfrm>
           <a:prstGeom prst="rect">
@@ -6176,11 +6041,11 @@
             <a:r>
               <a:rPr sz="1300" b="1" i="0">
                 <a:solidFill>
-                  <a:srgbClr val="C0392B"/>
-                </a:solidFill>
-                <a:latin typeface="Segoe UI"/>
-              </a:rPr>
-              <a:t>THE INTEGRITY MOMENT · DEMO</a:t>
+                  <a:srgbClr val="E25C4D"/>
+                </a:solidFill>
+                <a:latin typeface="Segoe UI"/>
+              </a:rPr>
+              <a:t>THE INTEGRITY MOMENT</a:t>
             </a:r>
           </a:p>
         </p:txBody>
@@ -6193,7 +6058,7 @@
         </p:nvSpPr>
         <p:spPr>
           <a:xfrm>
-            <a:off x="640080" y="868680"/>
+            <a:off x="640080" y="914400"/>
             <a:ext cx="10972800" cy="914400"/>
           </a:xfrm>
           <a:prstGeom prst="rect">
@@ -6208,13 +6073,13 @@
           <a:lstStyle/>
           <a:p>
             <a:r>
-              <a:rPr sz="3000" b="1" i="0">
-                <a:solidFill>
-                  <a:srgbClr val="14202B"/>
-                </a:solidFill>
-                <a:latin typeface="Segoe UI"/>
-              </a:rPr>
-              <a:t>It rejects what it can't prove</a:t>
+              <a:rPr sz="3600" b="1" i="0">
+                <a:solidFill>
+                  <a:srgbClr val="FFFFFF"/>
+                </a:solidFill>
+                <a:latin typeface="Segoe UI"/>
+              </a:rPr>
+              <a:t>It deletes what it can't prove.</a:t>
             </a:r>
           </a:p>
         </p:txBody>
@@ -6227,14 +6092,14 @@
         </p:nvSpPr>
         <p:spPr>
           <a:xfrm>
-            <a:off x="658368" y="1755648"/>
+            <a:off x="658368" y="1810512"/>
             <a:ext cx="1005840" cy="50292"/>
           </a:xfrm>
           <a:prstGeom prst="rect">
             <a:avLst/>
           </a:prstGeom>
           <a:solidFill>
-            <a:srgbClr val="C0392B"/>
+            <a:srgbClr val="E25C4D"/>
           </a:solidFill>
           <a:ln>
             <a:noFill/>
@@ -6271,8 +6136,8 @@
         </p:nvSpPr>
         <p:spPr>
           <a:xfrm>
-            <a:off x="640080" y="2148840"/>
-            <a:ext cx="5440680" cy="4114800"/>
+            <a:off x="640080" y="2514600"/>
+            <a:ext cx="10058400" cy="365760"/>
           </a:xfrm>
           <a:prstGeom prst="rect">
             <a:avLst/>
@@ -6285,105 +6150,14 @@
           </a:bodyPr>
           <a:lstStyle/>
           <a:p>
-            <a:pPr marL="301752" indent="-301752">
-              <a:spcAft>
-                <a:spcPts val="1400"/>
-              </a:spcAft>
-            </a:pPr>
-            <a:r>
-              <a:rPr sz="1600" b="1" i="0">
-                <a:solidFill>
-                  <a:srgbClr val="C0392B"/>
-                </a:solidFill>
-                <a:latin typeface="Segoe UI"/>
-              </a:rPr>
-              <a:t>▸  </a:t>
-            </a:r>
-            <a:r>
-              <a:rPr sz="1600" b="1" i="0">
-                <a:solidFill>
-                  <a:srgbClr val="14202B"/>
-                </a:solidFill>
-                <a:latin typeface="Segoe UI"/>
-              </a:rPr>
-              <a:t>Rejected:</a:t>
-            </a:r>
             <a:r>
               <a:rPr sz="1600" b="0" i="0">
                 <a:solidFill>
-                  <a:srgbClr val="5B6B7A"/>
-                </a:solidFill>
-                <a:latin typeface="Segoe UI"/>
-              </a:rPr>
-              <a:t> “rTMS is FDA-cleared to treat anorexia nervosa” — the devices are cleared, but no record references anorexia.</a:t>
-            </a:r>
-          </a:p>
-          <a:p>
-            <a:pPr marL="301752" indent="-301752">
-              <a:spcAft>
-                <a:spcPts val="1400"/>
-              </a:spcAft>
-            </a:pPr>
-            <a:r>
-              <a:rPr sz="1600" b="1" i="0">
-                <a:solidFill>
-                  <a:srgbClr val="C0392B"/>
-                </a:solidFill>
-                <a:latin typeface="Segoe UI"/>
-              </a:rPr>
-              <a:t>▸  </a:t>
-            </a:r>
-            <a:r>
-              <a:rPr sz="1600" b="1" i="0">
-                <a:solidFill>
-                  <a:srgbClr val="14202B"/>
-                </a:solidFill>
-                <a:latin typeface="Segoe UI"/>
-              </a:rPr>
-              <a:t>Rejected:</a:t>
-            </a:r>
-            <a:r>
-              <a:rPr sz="1600" b="0" i="0">
-                <a:solidFill>
-                  <a:srgbClr val="5B6B7A"/>
-                </a:solidFill>
-                <a:latin typeface="Segoe UI"/>
-              </a:rPr>
-              <a:t> over-broad universal negatives — scoped down to exactly what was searched.</a:t>
-            </a:r>
-          </a:p>
-          <a:p>
-            <a:pPr marL="301752" indent="-301752">
-              <a:spcAft>
-                <a:spcPts val="1400"/>
-              </a:spcAft>
-            </a:pPr>
-            <a:r>
-              <a:rPr sz="1600" b="1" i="0">
-                <a:solidFill>
-                  <a:srgbClr val="C0392B"/>
-                </a:solidFill>
-                <a:latin typeface="Segoe UI"/>
-              </a:rPr>
-              <a:t>▸  </a:t>
-            </a:r>
-            <a:r>
-              <a:rPr sz="1600" b="1" i="0">
-                <a:solidFill>
-                  <a:srgbClr val="14202B"/>
-                </a:solidFill>
-                <a:latin typeface="Segoe UI"/>
-              </a:rPr>
-              <a:t>Every rejection carries the Evaluator's reason.</a:t>
-            </a:r>
-            <a:r>
-              <a:rPr sz="1600" b="0" i="0">
-                <a:solidFill>
-                  <a:srgbClr val="5B6B7A"/>
-                </a:solidFill>
-                <a:latin typeface="Segoe UI"/>
-              </a:rPr>
-              <a:t> The anti-hallucination story, made visible.</a:t>
+                  <a:srgbClr val="A9B7C0"/>
+                </a:solidFill>
+                <a:latin typeface="Segoe UI"/>
+              </a:rPr>
+              <a:t>The agent was handed a plausible, false claim:</a:t>
             </a:r>
           </a:p>
         </p:txBody>
@@ -6396,8 +6170,8 @@
         </p:nvSpPr>
         <p:spPr>
           <a:xfrm>
-            <a:off x="6446520" y="2011680"/>
-            <a:ext cx="5120640" cy="274320"/>
+            <a:off x="640080" y="3017520"/>
+            <a:ext cx="7955279" cy="914400"/>
           </a:xfrm>
           <a:prstGeom prst="rect">
             <a:avLst/>
@@ -6411,65 +6185,36 @@
           <a:lstStyle/>
           <a:p>
             <a:r>
-              <a:rPr sz="1100" b="0" i="1">
-                <a:solidFill>
-                  <a:srgbClr val="5B6B7A"/>
-                </a:solidFill>
-                <a:latin typeface="Segoe UI"/>
-              </a:rPr>
-              <a:t>The Evaluator's actual output (live UI):</a:t>
-            </a:r>
-          </a:p>
-        </p:txBody>
-      </p:sp>
-      <p:pic>
-        <p:nvPicPr>
-          <p:cNvPr id="7" name="Picture 6" descr="ui_rejected.png"/>
-          <p:cNvPicPr>
-            <a:picLocks noChangeAspect="1"/>
-          </p:cNvPicPr>
-          <p:nvPr/>
-        </p:nvPicPr>
-        <p:blipFill>
-          <a:blip r:embed="rId2"/>
-          <a:stretch>
-            <a:fillRect/>
-          </a:stretch>
-        </p:blipFill>
-        <p:spPr>
-          <a:xfrm>
-            <a:off x="6446520" y="2331720"/>
-            <a:ext cx="5120640" cy="2309853"/>
-          </a:xfrm>
-          <a:prstGeom prst="rect">
-            <a:avLst/>
-          </a:prstGeom>
-          <a:ln w="12700">
+              <a:rPr sz="2700" b="1" i="0" strike="sngStrike">
+                <a:solidFill>
+                  <a:srgbClr val="A9B7C0"/>
+                </a:solidFill>
+                <a:latin typeface="Segoe UI"/>
+              </a:rPr>
+              <a:t>rTMS is FDA-cleared to treat anorexia nervosa</a:t>
+            </a:r>
+          </a:p>
+        </p:txBody>
+      </p:sp>
+      <p:sp>
+        <p:nvSpPr>
+          <p:cNvPr id="7" name="Rounded Rectangle 6"/>
+          <p:cNvSpPr/>
+          <p:nvPr/>
+        </p:nvSpPr>
+        <p:spPr>
+          <a:xfrm rot="21060000">
+            <a:off x="8915400" y="2788920"/>
+            <a:ext cx="2514600" cy="960120"/>
+          </a:xfrm>
+          <a:prstGeom prst="roundRect">
+            <a:avLst/>
+          </a:prstGeom>
+          <a:noFill/>
+          <a:ln w="28575">
             <a:solidFill>
-              <a:srgbClr val="E3E9EF"/>
+              <a:srgbClr val="E25C4D"/>
             </a:solidFill>
-          </a:ln>
-        </p:spPr>
-      </p:pic>
-      <p:sp>
-        <p:nvSpPr>
-          <p:cNvPr id="8" name="Rectangle 7"/>
-          <p:cNvSpPr/>
-          <p:nvPr/>
-        </p:nvSpPr>
-        <p:spPr>
-          <a:xfrm>
-            <a:off x="640080" y="6400800"/>
-            <a:ext cx="10908792" cy="15240"/>
-          </a:xfrm>
-          <a:prstGeom prst="rect">
-            <a:avLst/>
-          </a:prstGeom>
-          <a:solidFill>
-            <a:srgbClr val="E3E9EF"/>
-          </a:solidFill>
-          <a:ln>
-            <a:noFill/>
           </a:ln>
           <a:effectLst/>
         </p:spPr>
@@ -6492,19 +6237,28 @@
           <a:lstStyle/>
           <a:p>
             <a:pPr algn="ctr"/>
-          </a:p>
-        </p:txBody>
-      </p:sp>
-      <p:sp>
-        <p:nvSpPr>
-          <p:cNvPr id="9" name="TextBox 8"/>
+            <a:r>
+              <a:rPr sz="1600" b="1" i="0">
+                <a:solidFill>
+                  <a:srgbClr val="E25C4D"/>
+                </a:solidFill>
+                <a:latin typeface="Segoe UI"/>
+              </a:rPr>
+              <a:t>✗  UNSUPPORTED</a:t>
+            </a:r>
+          </a:p>
+        </p:txBody>
+      </p:sp>
+      <p:sp>
+        <p:nvSpPr>
+          <p:cNvPr id="8" name="TextBox 7"/>
           <p:cNvSpPr txBox="1"/>
           <p:nvPr/>
         </p:nvSpPr>
         <p:spPr>
           <a:xfrm>
-            <a:off x="640080" y="6437376"/>
-            <a:ext cx="10908792" cy="320040"/>
+            <a:off x="640080" y="4160520"/>
+            <a:ext cx="10424160" cy="1280160"/>
           </a:xfrm>
           <a:prstGeom prst="rect">
             <a:avLst/>
@@ -6518,13 +6272,47 @@
           <a:lstStyle/>
           <a:p>
             <a:r>
-              <a:rPr sz="900" b="0" i="0">
-                <a:solidFill>
-                  <a:srgbClr val="5B6B7A"/>
-                </a:solidFill>
-                <a:latin typeface="Segoe UI"/>
-              </a:rPr>
-              <a:t>Evidence-Intelligence Agent · Open Agent Hackathon 2026 · Track 02 · Fylaktis Fylaktou · UCLA Semel Institute</a:t>
+              <a:rPr sz="1800" b="0" i="0">
+                <a:solidFill>
+                  <a:srgbClr val="DDE6EB"/>
+                </a:solidFill>
+                <a:latin typeface="Segoe UI"/>
+              </a:rPr>
+              <a:t>The cited records show those devices are cleared — but not one references anorexia. Unsupported, so the agent refuses to say it.</a:t>
+            </a:r>
+          </a:p>
+        </p:txBody>
+      </p:sp>
+      <p:sp>
+        <p:nvSpPr>
+          <p:cNvPr id="9" name="TextBox 8"/>
+          <p:cNvSpPr txBox="1"/>
+          <p:nvPr/>
+        </p:nvSpPr>
+        <p:spPr>
+          <a:xfrm>
+            <a:off x="640080" y="5623560"/>
+            <a:ext cx="10881360" cy="457200"/>
+          </a:xfrm>
+          <a:prstGeom prst="rect">
+            <a:avLst/>
+          </a:prstGeom>
+          <a:noFill/>
+        </p:spPr>
+        <p:txBody>
+          <a:bodyPr wrap="square" anchor="t">
+            <a:spAutoFit/>
+          </a:bodyPr>
+          <a:lstStyle/>
+          <a:p>
+            <a:r>
+              <a:rPr sz="1500" b="1" i="0">
+                <a:solidFill>
+                  <a:srgbClr val="128A98"/>
+                </a:solidFill>
+                <a:latin typeface="Segoe UI"/>
+              </a:rPr>
+              <a:t>Every rejection ships with its reason — that is the “why.”</a:t>
             </a:r>
           </a:p>
         </p:txBody>
@@ -6675,8 +6463,8 @@
         </p:nvSpPr>
         <p:spPr>
           <a:xfrm>
-            <a:off x="640080" y="2103120"/>
-            <a:ext cx="10881360" cy="4114800"/>
+            <a:off x="640080" y="1965960"/>
+            <a:ext cx="10881360" cy="4297680"/>
           </a:xfrm>
           <a:prstGeom prst="rect">
             <a:avLst/>
@@ -6684,7 +6472,7 @@
           <a:noFill/>
         </p:spPr>
         <p:txBody>
-          <a:bodyPr wrap="square" anchor="t">
+          <a:bodyPr wrap="square" anchor="ctr">
             <a:spAutoFit/>
           </a:bodyPr>
           <a:lstStyle/>
@@ -7084,8 +6872,8 @@
         </p:nvSpPr>
         <p:spPr>
           <a:xfrm>
-            <a:off x="640080" y="2103120"/>
-            <a:ext cx="10881360" cy="4114800"/>
+            <a:off x="640080" y="1965960"/>
+            <a:ext cx="8321040" cy="4297680"/>
           </a:xfrm>
           <a:prstGeom prst="rect">
             <a:avLst/>
@@ -7093,7 +6881,7 @@
           <a:noFill/>
         </p:spPr>
         <p:txBody>
-          <a:bodyPr wrap="square" anchor="t">
+          <a:bodyPr wrap="square" anchor="ctr">
             <a:spAutoFit/>
           </a:bodyPr>
           <a:lstStyle/>
@@ -7237,7 +7025,60 @@
       </p:sp>
       <p:sp>
         <p:nvSpPr>
-          <p:cNvPr id="6" name="Rectangle 5"/>
+          <p:cNvPr id="6" name="Rounded Rectangle 5"/>
+          <p:cNvSpPr/>
+          <p:nvPr/>
+        </p:nvSpPr>
+        <p:spPr>
+          <a:xfrm rot="21120000">
+            <a:off x="9235440" y="2286000"/>
+            <a:ext cx="2286000" cy="914400"/>
+          </a:xfrm>
+          <a:prstGeom prst="roundRect">
+            <a:avLst/>
+          </a:prstGeom>
+          <a:noFill/>
+          <a:ln w="28575">
+            <a:solidFill>
+              <a:srgbClr val="128A98"/>
+            </a:solidFill>
+          </a:ln>
+          <a:effectLst/>
+        </p:spPr>
+        <p:style>
+          <a:lnRef idx="1">
+            <a:schemeClr val="accent1"/>
+          </a:lnRef>
+          <a:fillRef idx="3">
+            <a:schemeClr val="accent1"/>
+          </a:fillRef>
+          <a:effectRef idx="2">
+            <a:schemeClr val="accent1"/>
+          </a:effectRef>
+          <a:fontRef idx="minor">
+            <a:schemeClr val="lt1"/>
+          </a:fontRef>
+        </p:style>
+        <p:txBody>
+          <a:bodyPr rtlCol="0" anchor="ctr"/>
+          <a:lstStyle/>
+          <a:p>
+            <a:pPr algn="ctr"/>
+            <a:r>
+              <a:rPr sz="1600" b="1" i="0">
+                <a:solidFill>
+                  <a:srgbClr val="128A98"/>
+                </a:solidFill>
+                <a:latin typeface="Segoe UI"/>
+              </a:rPr>
+              <a:t>✓  VERIFIED</a:t>
+            </a:r>
+          </a:p>
+        </p:txBody>
+      </p:sp>
+      <p:sp>
+        <p:nvSpPr>
+          <p:cNvPr id="7" name="Rectangle 6"/>
           <p:cNvSpPr/>
           <p:nvPr/>
         </p:nvSpPr>
@@ -7281,7 +7122,7 @@
       </p:sp>
       <p:sp>
         <p:nvSpPr>
-          <p:cNvPr id="7" name="TextBox 6"/>
+          <p:cNvPr id="8" name="TextBox 7"/>
           <p:cNvSpPr txBox="1"/>
           <p:nvPr/>
         </p:nvSpPr>

</xml_diff>

<commit_message>
Deck: sponsor logo strip on slide 8
Added a logo strip (Zetaris · Meterless · NVIDIA · Cursor) on consistent light
cards above the "how each is used" text. NVIDIA + Zetaris are official wordmarks
(Zetaris from their site SVG, NVIDIA rasterized from the Wikimedia SVG); Cursor +
Meterless are their app icons (both sites are SPAs with no public wordmark PNG).
The generator falls back to the text list if the logo files are absent.

Co-Authored-By: Claude Opus 4.8 (1M context) <noreply@anthropic.com>
</commit_message>
<xml_diff>
--- a/deck/Evidence-Intelligence-Agent.pptx
+++ b/deck/Evidence-Intelligence-Agent.pptx
@@ -6457,14 +6457,294 @@
       </p:sp>
       <p:sp>
         <p:nvSpPr>
-          <p:cNvPr id="5" name="TextBox 4"/>
+          <p:cNvPr id="5" name="Rounded Rectangle 4"/>
+          <p:cNvSpPr/>
+          <p:nvPr/>
+        </p:nvSpPr>
+        <p:spPr>
+          <a:xfrm>
+            <a:off x="932688" y="1965960"/>
+            <a:ext cx="2416302" cy="868680"/>
+          </a:xfrm>
+          <a:prstGeom prst="roundRect">
+            <a:avLst/>
+          </a:prstGeom>
+          <a:solidFill>
+            <a:srgbClr val="FAFBFC"/>
+          </a:solidFill>
+          <a:ln w="12700">
+            <a:solidFill>
+              <a:srgbClr val="E3E9EF"/>
+            </a:solidFill>
+          </a:ln>
+          <a:effectLst/>
+        </p:spPr>
+        <p:style>
+          <a:lnRef idx="1">
+            <a:schemeClr val="accent1"/>
+          </a:lnRef>
+          <a:fillRef idx="3">
+            <a:schemeClr val="accent1"/>
+          </a:fillRef>
+          <a:effectRef idx="2">
+            <a:schemeClr val="accent1"/>
+          </a:effectRef>
+          <a:fontRef idx="minor">
+            <a:schemeClr val="lt1"/>
+          </a:fontRef>
+        </p:style>
+        <p:txBody>
+          <a:bodyPr rtlCol="0" anchor="ctr"/>
+          <a:lstStyle/>
+          <a:p>
+            <a:pPr algn="ctr"/>
+          </a:p>
+        </p:txBody>
+      </p:sp>
+      <p:pic>
+        <p:nvPicPr>
+          <p:cNvPr id="6" name="Picture 5" descr="zetaris.png"/>
+          <p:cNvPicPr>
+            <a:picLocks noChangeAspect="1"/>
+          </p:cNvPicPr>
+          <p:nvPr/>
+        </p:nvPicPr>
+        <p:blipFill>
+          <a:blip r:embed="rId2"/>
+          <a:stretch>
+            <a:fillRect/>
+          </a:stretch>
+        </p:blipFill>
+        <p:spPr>
+          <a:xfrm>
+            <a:off x="1235583" y="2148840"/>
+            <a:ext cx="1810511" cy="502919"/>
+          </a:xfrm>
+          <a:prstGeom prst="rect">
+            <a:avLst/>
+          </a:prstGeom>
+        </p:spPr>
+      </p:pic>
+      <p:sp>
+        <p:nvSpPr>
+          <p:cNvPr id="7" name="Rounded Rectangle 6"/>
+          <p:cNvSpPr/>
+          <p:nvPr/>
+        </p:nvSpPr>
+        <p:spPr>
+          <a:xfrm>
+            <a:off x="3568446" y="1965960"/>
+            <a:ext cx="2416302" cy="868680"/>
+          </a:xfrm>
+          <a:prstGeom prst="roundRect">
+            <a:avLst/>
+          </a:prstGeom>
+          <a:solidFill>
+            <a:srgbClr val="FAFBFC"/>
+          </a:solidFill>
+          <a:ln w="12700">
+            <a:solidFill>
+              <a:srgbClr val="E3E9EF"/>
+            </a:solidFill>
+          </a:ln>
+          <a:effectLst/>
+        </p:spPr>
+        <p:style>
+          <a:lnRef idx="1">
+            <a:schemeClr val="accent1"/>
+          </a:lnRef>
+          <a:fillRef idx="3">
+            <a:schemeClr val="accent1"/>
+          </a:fillRef>
+          <a:effectRef idx="2">
+            <a:schemeClr val="accent1"/>
+          </a:effectRef>
+          <a:fontRef idx="minor">
+            <a:schemeClr val="lt1"/>
+          </a:fontRef>
+        </p:style>
+        <p:txBody>
+          <a:bodyPr rtlCol="0" anchor="ctr"/>
+          <a:lstStyle/>
+          <a:p>
+            <a:pPr algn="ctr"/>
+          </a:p>
+        </p:txBody>
+      </p:sp>
+      <p:pic>
+        <p:nvPicPr>
+          <p:cNvPr id="8" name="Picture 7" descr="meterless.png"/>
+          <p:cNvPicPr>
+            <a:picLocks noChangeAspect="1"/>
+          </p:cNvPicPr>
+          <p:nvPr/>
+        </p:nvPicPr>
+        <p:blipFill>
+          <a:blip r:embed="rId3"/>
+          <a:stretch>
+            <a:fillRect/>
+          </a:stretch>
+        </p:blipFill>
+        <p:spPr>
+          <a:xfrm>
+            <a:off x="4525137" y="2148840"/>
+            <a:ext cx="502919" cy="502919"/>
+          </a:xfrm>
+          <a:prstGeom prst="rect">
+            <a:avLst/>
+          </a:prstGeom>
+        </p:spPr>
+      </p:pic>
+      <p:sp>
+        <p:nvSpPr>
+          <p:cNvPr id="9" name="Rounded Rectangle 8"/>
+          <p:cNvSpPr/>
+          <p:nvPr/>
+        </p:nvSpPr>
+        <p:spPr>
+          <a:xfrm>
+            <a:off x="6204204" y="1965960"/>
+            <a:ext cx="2416302" cy="868680"/>
+          </a:xfrm>
+          <a:prstGeom prst="roundRect">
+            <a:avLst/>
+          </a:prstGeom>
+          <a:solidFill>
+            <a:srgbClr val="FAFBFC"/>
+          </a:solidFill>
+          <a:ln w="12700">
+            <a:solidFill>
+              <a:srgbClr val="E3E9EF"/>
+            </a:solidFill>
+          </a:ln>
+          <a:effectLst/>
+        </p:spPr>
+        <p:style>
+          <a:lnRef idx="1">
+            <a:schemeClr val="accent1"/>
+          </a:lnRef>
+          <a:fillRef idx="3">
+            <a:schemeClr val="accent1"/>
+          </a:fillRef>
+          <a:effectRef idx="2">
+            <a:schemeClr val="accent1"/>
+          </a:effectRef>
+          <a:fontRef idx="minor">
+            <a:schemeClr val="lt1"/>
+          </a:fontRef>
+        </p:style>
+        <p:txBody>
+          <a:bodyPr rtlCol="0" anchor="ctr"/>
+          <a:lstStyle/>
+          <a:p>
+            <a:pPr algn="ctr"/>
+          </a:p>
+        </p:txBody>
+      </p:sp>
+      <p:pic>
+        <p:nvPicPr>
+          <p:cNvPr id="10" name="Picture 9" descr="nvidia.png"/>
+          <p:cNvPicPr>
+            <a:picLocks noChangeAspect="1"/>
+          </p:cNvPicPr>
+          <p:nvPr/>
+        </p:nvPicPr>
+        <p:blipFill>
+          <a:blip r:embed="rId4"/>
+          <a:stretch>
+            <a:fillRect/>
+          </a:stretch>
+        </p:blipFill>
+        <p:spPr>
+          <a:xfrm>
+            <a:off x="6387083" y="2208427"/>
+            <a:ext cx="2050542" cy="383744"/>
+          </a:xfrm>
+          <a:prstGeom prst="rect">
+            <a:avLst/>
+          </a:prstGeom>
+        </p:spPr>
+      </p:pic>
+      <p:sp>
+        <p:nvSpPr>
+          <p:cNvPr id="11" name="Rounded Rectangle 10"/>
+          <p:cNvSpPr/>
+          <p:nvPr/>
+        </p:nvSpPr>
+        <p:spPr>
+          <a:xfrm>
+            <a:off x="8839961" y="1965960"/>
+            <a:ext cx="2416302" cy="868680"/>
+          </a:xfrm>
+          <a:prstGeom prst="roundRect">
+            <a:avLst/>
+          </a:prstGeom>
+          <a:solidFill>
+            <a:srgbClr val="FAFBFC"/>
+          </a:solidFill>
+          <a:ln w="12700">
+            <a:solidFill>
+              <a:srgbClr val="E3E9EF"/>
+            </a:solidFill>
+          </a:ln>
+          <a:effectLst/>
+        </p:spPr>
+        <p:style>
+          <a:lnRef idx="1">
+            <a:schemeClr val="accent1"/>
+          </a:lnRef>
+          <a:fillRef idx="3">
+            <a:schemeClr val="accent1"/>
+          </a:fillRef>
+          <a:effectRef idx="2">
+            <a:schemeClr val="accent1"/>
+          </a:effectRef>
+          <a:fontRef idx="minor">
+            <a:schemeClr val="lt1"/>
+          </a:fontRef>
+        </p:style>
+        <p:txBody>
+          <a:bodyPr rtlCol="0" anchor="ctr"/>
+          <a:lstStyle/>
+          <a:p>
+            <a:pPr algn="ctr"/>
+          </a:p>
+        </p:txBody>
+      </p:sp>
+      <p:pic>
+        <p:nvPicPr>
+          <p:cNvPr id="12" name="Picture 11" descr="cursor.png"/>
+          <p:cNvPicPr>
+            <a:picLocks noChangeAspect="1"/>
+          </p:cNvPicPr>
+          <p:nvPr/>
+        </p:nvPicPr>
+        <p:blipFill>
+          <a:blip r:embed="rId5"/>
+          <a:stretch>
+            <a:fillRect/>
+          </a:stretch>
+        </p:blipFill>
+        <p:spPr>
+          <a:xfrm>
+            <a:off x="9796653" y="2148840"/>
+            <a:ext cx="502919" cy="502919"/>
+          </a:xfrm>
+          <a:prstGeom prst="rect">
+            <a:avLst/>
+          </a:prstGeom>
+        </p:spPr>
+      </p:pic>
+      <p:sp>
+        <p:nvSpPr>
+          <p:cNvPr id="13" name="TextBox 12"/>
           <p:cNvSpPr txBox="1"/>
           <p:nvPr/>
         </p:nvSpPr>
         <p:spPr>
           <a:xfrm>
-            <a:off x="640080" y="1965960"/>
-            <a:ext cx="10881360" cy="4297680"/>
+            <a:off x="640080" y="3108960"/>
+            <a:ext cx="10881360" cy="3017520"/>
           </a:xfrm>
           <a:prstGeom prst="rect">
             <a:avLst/>
@@ -6472,18 +6752,18 @@
           <a:noFill/>
         </p:spPr>
         <p:txBody>
-          <a:bodyPr wrap="square" anchor="ctr">
+          <a:bodyPr wrap="square" anchor="t">
             <a:spAutoFit/>
           </a:bodyPr>
           <a:lstStyle/>
           <a:p>
             <a:pPr marL="301752" indent="-301752">
               <a:spcAft>
-                <a:spcPts val="1200"/>
+                <a:spcPts val="1000"/>
               </a:spcAft>
             </a:pPr>
             <a:r>
-              <a:rPr sz="1800" b="1" i="0">
+              <a:rPr sz="1500" b="1" i="0">
                 <a:solidFill>
                   <a:srgbClr val="128A98"/>
                 </a:solidFill>
@@ -6492,7 +6772,7 @@
               <a:t>▸  </a:t>
             </a:r>
             <a:r>
-              <a:rPr sz="1800" b="1" i="0">
+              <a:rPr sz="1500" b="1" i="0">
                 <a:solidFill>
                   <a:srgbClr val="14202B"/>
                 </a:solidFill>
@@ -6501,7 +6781,7 @@
               <a:t>Zetaris</a:t>
             </a:r>
             <a:r>
-              <a:rPr sz="1800" b="0" i="0">
+              <a:rPr sz="1500" b="0" i="0">
                 <a:solidFill>
                   <a:srgbClr val="5B6B7A"/>
                 </a:solidFill>
@@ -6513,11 +6793,11 @@
           <a:p>
             <a:pPr marL="301752" indent="-301752">
               <a:spcAft>
-                <a:spcPts val="1200"/>
+                <a:spcPts val="1000"/>
               </a:spcAft>
             </a:pPr>
             <a:r>
-              <a:rPr sz="1800" b="1" i="0">
+              <a:rPr sz="1500" b="1" i="0">
                 <a:solidFill>
                   <a:srgbClr val="128A98"/>
                 </a:solidFill>
@@ -6526,7 +6806,7 @@
               <a:t>▸  </a:t>
             </a:r>
             <a:r>
-              <a:rPr sz="1800" b="1" i="0">
+              <a:rPr sz="1500" b="1" i="0">
                 <a:solidFill>
                   <a:srgbClr val="14202B"/>
                 </a:solidFill>
@@ -6535,7 +6815,7 @@
               <a:t>Meterless</a:t>
             </a:r>
             <a:r>
-              <a:rPr sz="1800" b="0" i="0">
+              <a:rPr sz="1500" b="0" i="0">
                 <a:solidFill>
                   <a:srgbClr val="5B6B7A"/>
                 </a:solidFill>
@@ -6547,11 +6827,11 @@
           <a:p>
             <a:pPr marL="301752" indent="-301752">
               <a:spcAft>
-                <a:spcPts val="1200"/>
+                <a:spcPts val="1000"/>
               </a:spcAft>
             </a:pPr>
             <a:r>
-              <a:rPr sz="1800" b="1" i="0">
+              <a:rPr sz="1500" b="1" i="0">
                 <a:solidFill>
                   <a:srgbClr val="128A98"/>
                 </a:solidFill>
@@ -6560,7 +6840,7 @@
               <a:t>▸  </a:t>
             </a:r>
             <a:r>
-              <a:rPr sz="1800" b="1" i="0">
+              <a:rPr sz="1500" b="1" i="0">
                 <a:solidFill>
                   <a:srgbClr val="14202B"/>
                 </a:solidFill>
@@ -6569,7 +6849,7 @@
               <a:t>NVIDIA Nemotron</a:t>
             </a:r>
             <a:r>
-              <a:rPr sz="1800" b="0" i="0">
+              <a:rPr sz="1500" b="0" i="0">
                 <a:solidFill>
                   <a:srgbClr val="5B6B7A"/>
                 </a:solidFill>
@@ -6581,11 +6861,11 @@
           <a:p>
             <a:pPr marL="301752" indent="-301752">
               <a:spcAft>
-                <a:spcPts val="1200"/>
+                <a:spcPts val="1000"/>
               </a:spcAft>
             </a:pPr>
             <a:r>
-              <a:rPr sz="1800" b="1" i="0">
+              <a:rPr sz="1500" b="1" i="0">
                 <a:solidFill>
                   <a:srgbClr val="128A98"/>
                 </a:solidFill>
@@ -6594,7 +6874,7 @@
               <a:t>▸  </a:t>
             </a:r>
             <a:r>
-              <a:rPr sz="1800" b="1" i="0">
+              <a:rPr sz="1500" b="1" i="0">
                 <a:solidFill>
                   <a:srgbClr val="14202B"/>
                 </a:solidFill>
@@ -6603,7 +6883,7 @@
               <a:t>Cursor</a:t>
             </a:r>
             <a:r>
-              <a:rPr sz="1800" b="0" i="0">
+              <a:rPr sz="1500" b="0" i="0">
                 <a:solidFill>
                   <a:srgbClr val="5B6B7A"/>
                 </a:solidFill>
@@ -6615,11 +6895,11 @@
           <a:p>
             <a:pPr marL="301752" indent="-301752">
               <a:spcAft>
-                <a:spcPts val="1200"/>
+                <a:spcPts val="1000"/>
               </a:spcAft>
             </a:pPr>
             <a:r>
-              <a:rPr sz="1800" b="1" i="0">
+              <a:rPr sz="1500" b="1" i="0">
                 <a:solidFill>
                   <a:srgbClr val="128A98"/>
                 </a:solidFill>
@@ -6628,7 +6908,7 @@
               <a:t>▸  </a:t>
             </a:r>
             <a:r>
-              <a:rPr sz="1800" b="1" i="0">
+              <a:rPr sz="1500" b="1" i="0">
                 <a:solidFill>
                   <a:srgbClr val="14202B"/>
                 </a:solidFill>
@@ -6637,7 +6917,7 @@
               <a:t>Telemetry per run:</a:t>
             </a:r>
             <a:r>
-              <a:rPr sz="1800" b="0" i="0">
+              <a:rPr sz="1500" b="0" i="0">
                 <a:solidFill>
                   <a:srgbClr val="5B6B7A"/>
                 </a:solidFill>
@@ -6650,7 +6930,7 @@
       </p:sp>
       <p:sp>
         <p:nvSpPr>
-          <p:cNvPr id="6" name="Rectangle 5"/>
+          <p:cNvPr id="14" name="Rectangle 13"/>
           <p:cNvSpPr/>
           <p:nvPr/>
         </p:nvSpPr>
@@ -6694,7 +6974,7 @@
       </p:sp>
       <p:sp>
         <p:nvSpPr>
-          <p:cNvPr id="7" name="TextBox 6"/>
+          <p:cNvPr id="15" name="TextBox 14"/>
           <p:cNvSpPr txBox="1"/>
           <p:nvPr/>
         </p:nvSpPr>

</xml_diff>

<commit_message>
Slide 5: ring/cycle layout so it can't read as a pipeline
The left-to-right row still read linear despite the return edge. Replaced it with
a ring: the five roles arranged in a loop with the flow circulating, H-MEM shared
at the hub, and the Evaluator->Reporter feedback bowed outside the ring. A circle
can't read as a line.

Co-Authored-By: Claude Opus 4.8 (1M context) <noreply@anthropic.com>
</commit_message>
<xml_diff>
--- a/deck/Evidence-Intelligence-Agent.pptx
+++ b/deck/Evidence-Intelligence-Agent.pptx
@@ -4606,16 +4606,196 @@
           </a:p>
         </p:txBody>
       </p:sp>
-      <p:sp>
-        <p:nvSpPr>
-          <p:cNvPr id="5" name="Rounded Rectangle 4"/>
+      <p:cxnSp>
+        <p:nvCxnSpPr>
+          <p:cNvPr id="5" name="Connector 4"/>
+          <p:cNvCxnSpPr/>
+          <p:nvPr/>
+        </p:nvCxnSpPr>
+        <p:spPr>
+          <a:xfrm>
+            <a:off x="6716521" y="2888181"/>
+            <a:ext cx="1861432" cy="509143"/>
+          </a:xfrm>
+          <a:prstGeom prst="line">
+            <a:avLst/>
+          </a:prstGeom>
+          <a:ln w="25400">
+            <a:solidFill>
+              <a:srgbClr val="128A98"/>
+            </a:solidFill>
+            <a:tailEnd type="triangle" w="med" len="med"/>
+          </a:ln>
+        </p:spPr>
+        <p:style>
+          <a:lnRef idx="2">
+            <a:schemeClr val="accent1"/>
+          </a:lnRef>
+          <a:fillRef idx="0">
+            <a:schemeClr val="accent1"/>
+          </a:fillRef>
+          <a:effectRef idx="1">
+            <a:schemeClr val="accent1"/>
+          </a:effectRef>
+          <a:fontRef idx="minor">
+            <a:schemeClr val="tx1"/>
+          </a:fontRef>
+        </p:style>
+      </p:cxnSp>
+      <p:cxnSp>
+        <p:nvCxnSpPr>
+          <p:cNvPr id="6" name="Connector 5"/>
+          <p:cNvCxnSpPr/>
+          <p:nvPr/>
+        </p:nvCxnSpPr>
+        <p:spPr>
+          <a:xfrm flipH="1">
+            <a:off x="8793600" y="4341084"/>
+            <a:ext cx="169060" cy="195883"/>
+          </a:xfrm>
+          <a:prstGeom prst="line">
+            <a:avLst/>
+          </a:prstGeom>
+          <a:ln w="25400">
+            <a:solidFill>
+              <a:srgbClr val="128A98"/>
+            </a:solidFill>
+            <a:tailEnd type="triangle" w="med" len="med"/>
+          </a:ln>
+        </p:spPr>
+        <p:style>
+          <a:lnRef idx="2">
+            <a:schemeClr val="accent1"/>
+          </a:lnRef>
+          <a:fillRef idx="0">
+            <a:schemeClr val="accent1"/>
+          </a:fillRef>
+          <a:effectRef idx="1">
+            <a:schemeClr val="accent1"/>
+          </a:effectRef>
+          <a:fontRef idx="minor">
+            <a:schemeClr val="tx1"/>
+          </a:fontRef>
+        </p:style>
+      </p:cxnSp>
+      <p:cxnSp>
+        <p:nvCxnSpPr>
+          <p:cNvPr id="7" name="Connector 6"/>
+          <p:cNvCxnSpPr/>
+          <p:nvPr/>
+        </p:nvCxnSpPr>
+        <p:spPr>
+          <a:xfrm flipH="1">
+            <a:off x="4573748" y="5298424"/>
+            <a:ext cx="2666551" cy="0"/>
+          </a:xfrm>
+          <a:prstGeom prst="line">
+            <a:avLst/>
+          </a:prstGeom>
+          <a:ln w="25400">
+            <a:solidFill>
+              <a:srgbClr val="128A98"/>
+            </a:solidFill>
+            <a:tailEnd type="triangle" w="med" len="med"/>
+          </a:ln>
+        </p:spPr>
+        <p:style>
+          <a:lnRef idx="2">
+            <a:schemeClr val="accent1"/>
+          </a:lnRef>
+          <a:fillRef idx="0">
+            <a:schemeClr val="accent1"/>
+          </a:fillRef>
+          <a:effectRef idx="1">
+            <a:schemeClr val="accent1"/>
+          </a:effectRef>
+          <a:fontRef idx="minor">
+            <a:schemeClr val="tx1"/>
+          </a:fontRef>
+        </p:style>
+      </p:cxnSp>
+      <p:cxnSp>
+        <p:nvCxnSpPr>
+          <p:cNvPr id="8" name="Connector 7"/>
+          <p:cNvCxnSpPr/>
+          <p:nvPr/>
+        </p:nvCxnSpPr>
+        <p:spPr>
+          <a:xfrm flipH="1" flipV="1">
+            <a:off x="2813353" y="4424152"/>
+            <a:ext cx="169060" cy="195883"/>
+          </a:xfrm>
+          <a:prstGeom prst="line">
+            <a:avLst/>
+          </a:prstGeom>
+          <a:ln w="25400">
+            <a:solidFill>
+              <a:srgbClr val="128A98"/>
+            </a:solidFill>
+            <a:tailEnd type="triangle" w="med" len="med"/>
+          </a:ln>
+        </p:spPr>
+        <p:style>
+          <a:lnRef idx="2">
+            <a:schemeClr val="accent1"/>
+          </a:lnRef>
+          <a:fillRef idx="0">
+            <a:schemeClr val="accent1"/>
+          </a:fillRef>
+          <a:effectRef idx="1">
+            <a:schemeClr val="accent1"/>
+          </a:effectRef>
+          <a:fontRef idx="minor">
+            <a:schemeClr val="tx1"/>
+          </a:fontRef>
+        </p:style>
+      </p:cxnSp>
+      <p:cxnSp>
+        <p:nvCxnSpPr>
+          <p:cNvPr id="9" name="Connector 8"/>
+          <p:cNvCxnSpPr/>
+          <p:nvPr/>
+        </p:nvCxnSpPr>
+        <p:spPr>
+          <a:xfrm>
+            <a:off x="2312475" y="4711500"/>
+            <a:ext cx="169060" cy="195882"/>
+          </a:xfrm>
+          <a:prstGeom prst="line">
+            <a:avLst/>
+          </a:prstGeom>
+          <a:ln w="28575">
+            <a:solidFill>
+              <a:srgbClr val="B8842A"/>
+            </a:solidFill>
+            <a:tailEnd type="triangle" w="med" len="med"/>
+          </a:ln>
+        </p:spPr>
+        <p:style>
+          <a:lnRef idx="2">
+            <a:schemeClr val="accent1"/>
+          </a:lnRef>
+          <a:fillRef idx="0">
+            <a:schemeClr val="accent1"/>
+          </a:fillRef>
+          <a:effectRef idx="1">
+            <a:schemeClr val="accent1"/>
+          </a:effectRef>
+          <a:fontRef idx="minor">
+            <a:schemeClr val="tx1"/>
+          </a:fontRef>
+        </p:style>
+      </p:cxnSp>
+      <p:sp>
+        <p:nvSpPr>
+          <p:cNvPr id="10" name="Rounded Rectangle 9"/>
           <p:cNvSpPr/>
           <p:nvPr/>
         </p:nvSpPr>
         <p:spPr>
           <a:xfrm>
-            <a:off x="640080" y="2286000"/>
-            <a:ext cx="1875068" cy="1051560"/>
+            <a:off x="4960620" y="2249424"/>
+            <a:ext cx="1783080" cy="804672"/>
           </a:xfrm>
           <a:prstGeom prst="roundRect">
             <a:avLst/>
@@ -4650,7 +4830,7 @@
           <a:p>
             <a:pPr algn="ctr"/>
             <a:r>
-              <a:rPr sz="1400" b="1" i="0">
+              <a:rPr sz="1350" b="1" i="0">
                 <a:solidFill>
                   <a:srgbClr val="14202B"/>
                 </a:solidFill>
@@ -4662,7 +4842,7 @@
           <a:p>
             <a:pPr algn="ctr"/>
             <a:r>
-              <a:rPr sz="950" b="0" i="0">
+              <a:rPr sz="900" b="0" i="0">
                 <a:solidFill>
                   <a:srgbClr val="5B6B7A"/>
                 </a:solidFill>
@@ -4675,58 +4855,14 @@
       </p:sp>
       <p:sp>
         <p:nvSpPr>
-          <p:cNvPr id="6" name="Right Arrow 5"/>
+          <p:cNvPr id="11" name="Rounded Rectangle 10"/>
           <p:cNvSpPr/>
           <p:nvPr/>
         </p:nvSpPr>
         <p:spPr>
           <a:xfrm>
-            <a:off x="2533436" y="2720340"/>
-            <a:ext cx="347472" cy="182880"/>
-          </a:xfrm>
-          <a:prstGeom prst="rightArrow">
-            <a:avLst/>
-          </a:prstGeom>
-          <a:solidFill>
-            <a:srgbClr val="128A98"/>
-          </a:solidFill>
-          <a:ln>
-            <a:noFill/>
-          </a:ln>
-          <a:effectLst/>
-        </p:spPr>
-        <p:style>
-          <a:lnRef idx="1">
-            <a:schemeClr val="accent1"/>
-          </a:lnRef>
-          <a:fillRef idx="3">
-            <a:schemeClr val="accent1"/>
-          </a:fillRef>
-          <a:effectRef idx="2">
-            <a:schemeClr val="accent1"/>
-          </a:effectRef>
-          <a:fontRef idx="minor">
-            <a:schemeClr val="lt1"/>
-          </a:fontRef>
-        </p:style>
-        <p:txBody>
-          <a:bodyPr rtlCol="0" anchor="ctr"/>
-          <a:lstStyle/>
-          <a:p>
-            <a:pPr algn="ctr"/>
-          </a:p>
-        </p:txBody>
-      </p:sp>
-      <p:sp>
-        <p:nvSpPr>
-          <p:cNvPr id="7" name="Rounded Rectangle 6"/>
-          <p:cNvSpPr/>
-          <p:nvPr/>
-        </p:nvSpPr>
-        <p:spPr>
-          <a:xfrm>
-            <a:off x="2899196" y="2286000"/>
-            <a:ext cx="1875068" cy="1051560"/>
+            <a:off x="8656615" y="3260359"/>
+            <a:ext cx="1783080" cy="804672"/>
           </a:xfrm>
           <a:prstGeom prst="roundRect">
             <a:avLst/>
@@ -4761,7 +4897,7 @@
           <a:p>
             <a:pPr algn="ctr"/>
             <a:r>
-              <a:rPr sz="1400" b="1" i="0">
+              <a:rPr sz="1350" b="1" i="0">
                 <a:solidFill>
                   <a:srgbClr val="14202B"/>
                 </a:solidFill>
@@ -4773,7 +4909,7 @@
           <a:p>
             <a:pPr algn="ctr"/>
             <a:r>
-              <a:rPr sz="950" b="0" i="0">
+              <a:rPr sz="900" b="0" i="0">
                 <a:solidFill>
                   <a:srgbClr val="5B6B7A"/>
                 </a:solidFill>
@@ -4786,58 +4922,14 @@
       </p:sp>
       <p:sp>
         <p:nvSpPr>
-          <p:cNvPr id="8" name="Right Arrow 7"/>
+          <p:cNvPr id="12" name="Rounded Rectangle 11"/>
           <p:cNvSpPr/>
           <p:nvPr/>
         </p:nvSpPr>
         <p:spPr>
           <a:xfrm>
-            <a:off x="4792553" y="2720340"/>
-            <a:ext cx="347472" cy="182880"/>
-          </a:xfrm>
-          <a:prstGeom prst="rightArrow">
-            <a:avLst/>
-          </a:prstGeom>
-          <a:solidFill>
-            <a:srgbClr val="128A98"/>
-          </a:solidFill>
-          <a:ln>
-            <a:noFill/>
-          </a:ln>
-          <a:effectLst/>
-        </p:spPr>
-        <p:style>
-          <a:lnRef idx="1">
-            <a:schemeClr val="accent1"/>
-          </a:lnRef>
-          <a:fillRef idx="3">
-            <a:schemeClr val="accent1"/>
-          </a:fillRef>
-          <a:effectRef idx="2">
-            <a:schemeClr val="accent1"/>
-          </a:effectRef>
-          <a:fontRef idx="minor">
-            <a:schemeClr val="lt1"/>
-          </a:fontRef>
-        </p:style>
-        <p:txBody>
-          <a:bodyPr rtlCol="0" anchor="ctr"/>
-          <a:lstStyle/>
-          <a:p>
-            <a:pPr algn="ctr"/>
-          </a:p>
-        </p:txBody>
-      </p:sp>
-      <p:sp>
-        <p:nvSpPr>
-          <p:cNvPr id="9" name="Rounded Rectangle 8"/>
-          <p:cNvSpPr/>
-          <p:nvPr/>
-        </p:nvSpPr>
-        <p:spPr>
-          <a:xfrm>
-            <a:off x="5158313" y="2286000"/>
-            <a:ext cx="1875068" cy="1051560"/>
+            <a:off x="7244871" y="4896088"/>
+            <a:ext cx="1783080" cy="804672"/>
           </a:xfrm>
           <a:prstGeom prst="roundRect">
             <a:avLst/>
@@ -4872,7 +4964,7 @@
           <a:p>
             <a:pPr algn="ctr"/>
             <a:r>
-              <a:rPr sz="1400" b="1" i="0">
+              <a:rPr sz="1350" b="1" i="0">
                 <a:solidFill>
                   <a:srgbClr val="14202B"/>
                 </a:solidFill>
@@ -4884,7 +4976,7 @@
           <a:p>
             <a:pPr algn="ctr"/>
             <a:r>
-              <a:rPr sz="950" b="0" i="0">
+              <a:rPr sz="900" b="0" i="0">
                 <a:solidFill>
                   <a:srgbClr val="5B6B7A"/>
                 </a:solidFill>
@@ -4897,58 +4989,14 @@
       </p:sp>
       <p:sp>
         <p:nvSpPr>
-          <p:cNvPr id="10" name="Right Arrow 9"/>
+          <p:cNvPr id="13" name="Rounded Rectangle 12"/>
           <p:cNvSpPr/>
           <p:nvPr/>
         </p:nvSpPr>
         <p:spPr>
           <a:xfrm>
-            <a:off x="7051669" y="2720340"/>
-            <a:ext cx="347472" cy="182880"/>
-          </a:xfrm>
-          <a:prstGeom prst="rightArrow">
-            <a:avLst/>
-          </a:prstGeom>
-          <a:solidFill>
-            <a:srgbClr val="128A98"/>
-          </a:solidFill>
-          <a:ln>
-            <a:noFill/>
-          </a:ln>
-          <a:effectLst/>
-        </p:spPr>
-        <p:style>
-          <a:lnRef idx="1">
-            <a:schemeClr val="accent1"/>
-          </a:lnRef>
-          <a:fillRef idx="3">
-            <a:schemeClr val="accent1"/>
-          </a:fillRef>
-          <a:effectRef idx="2">
-            <a:schemeClr val="accent1"/>
-          </a:effectRef>
-          <a:fontRef idx="minor">
-            <a:schemeClr val="lt1"/>
-          </a:fontRef>
-        </p:style>
-        <p:txBody>
-          <a:bodyPr rtlCol="0" anchor="ctr"/>
-          <a:lstStyle/>
-          <a:p>
-            <a:pPr algn="ctr"/>
-          </a:p>
-        </p:txBody>
-      </p:sp>
-      <p:sp>
-        <p:nvSpPr>
-          <p:cNvPr id="11" name="Rounded Rectangle 10"/>
-          <p:cNvSpPr/>
-          <p:nvPr/>
-        </p:nvSpPr>
-        <p:spPr>
-          <a:xfrm>
-            <a:off x="7417429" y="2286000"/>
-            <a:ext cx="1875068" cy="1051560"/>
+            <a:off x="2676368" y="4896088"/>
+            <a:ext cx="1783080" cy="804672"/>
           </a:xfrm>
           <a:prstGeom prst="roundRect">
             <a:avLst/>
@@ -4983,7 +5031,7 @@
           <a:p>
             <a:pPr algn="ctr"/>
             <a:r>
-              <a:rPr sz="1400" b="1" i="0">
+              <a:rPr sz="1350" b="1" i="0">
                 <a:solidFill>
                   <a:srgbClr val="14202B"/>
                 </a:solidFill>
@@ -4995,7 +5043,7 @@
           <a:p>
             <a:pPr algn="ctr"/>
             <a:r>
-              <a:rPr sz="950" b="0" i="0">
+              <a:rPr sz="900" b="0" i="0">
                 <a:solidFill>
                   <a:srgbClr val="5B6B7A"/>
                 </a:solidFill>
@@ -5008,16 +5056,16 @@
       </p:sp>
       <p:sp>
         <p:nvSpPr>
-          <p:cNvPr id="12" name="Right Arrow 11"/>
+          <p:cNvPr id="14" name="Rounded Rectangle 13"/>
           <p:cNvSpPr/>
           <p:nvPr/>
         </p:nvSpPr>
         <p:spPr>
           <a:xfrm>
-            <a:off x="9310786" y="2720340"/>
-            <a:ext cx="347472" cy="182880"/>
-          </a:xfrm>
-          <a:prstGeom prst="rightArrow">
+            <a:off x="1264624" y="3260359"/>
+            <a:ext cx="1783080" cy="804672"/>
+          </a:xfrm>
+          <a:prstGeom prst="roundRect">
             <a:avLst/>
           </a:prstGeom>
           <a:solidFill>
@@ -5043,32 +5091,55 @@
           </a:fontRef>
         </p:style>
         <p:txBody>
-          <a:bodyPr rtlCol="0" anchor="ctr"/>
+          <a:bodyPr rtlCol="0" anchor="ctr" wrap="square"/>
           <a:lstStyle/>
           <a:p>
             <a:pPr algn="ctr"/>
-          </a:p>
-        </p:txBody>
-      </p:sp>
-      <p:sp>
-        <p:nvSpPr>
-          <p:cNvPr id="13" name="Rounded Rectangle 12"/>
+            <a:r>
+              <a:rPr sz="1350" b="1" i="0">
+                <a:solidFill>
+                  <a:srgbClr val="FFFFFF"/>
+                </a:solidFill>
+                <a:latin typeface="Segoe UI"/>
+              </a:rPr>
+              <a:t>Evaluator</a:t>
+            </a:r>
+          </a:p>
+          <a:p>
+            <a:pPr algn="ctr"/>
+            <a:r>
+              <a:rPr sz="900" b="0" i="0">
+                <a:solidFill>
+                  <a:srgbClr val="DDF0F2"/>
+                </a:solidFill>
+                <a:latin typeface="Segoe UI"/>
+              </a:rPr>
+              <a:t>verify / reject</a:t>
+            </a:r>
+          </a:p>
+        </p:txBody>
+      </p:sp>
+      <p:sp>
+        <p:nvSpPr>
+          <p:cNvPr id="15" name="Rounded Rectangle 14"/>
           <p:cNvSpPr/>
           <p:nvPr/>
         </p:nvSpPr>
         <p:spPr>
           <a:xfrm>
-            <a:off x="9676546" y="2286000"/>
-            <a:ext cx="1875068" cy="1051560"/>
+            <a:off x="4892040" y="3712463"/>
+            <a:ext cx="1920240" cy="804672"/>
           </a:xfrm>
           <a:prstGeom prst="roundRect">
             <a:avLst/>
           </a:prstGeom>
           <a:solidFill>
-            <a:srgbClr val="128A98"/>
+            <a:srgbClr val="FDF3E3"/>
           </a:solidFill>
-          <a:ln>
-            <a:noFill/>
+          <a:ln w="15875">
+            <a:solidFill>
+              <a:srgbClr val="B8842A"/>
+            </a:solidFill>
           </a:ln>
           <a:effectLst/>
         </p:spPr>
@@ -5087,150 +5158,44 @@
           </a:fontRef>
         </p:style>
         <p:txBody>
-          <a:bodyPr rtlCol="0" anchor="ctr" wrap="square"/>
+          <a:bodyPr rtlCol="0" anchor="ctr"/>
           <a:lstStyle/>
           <a:p>
             <a:pPr algn="ctr"/>
             <a:r>
-              <a:rPr sz="1400" b="1" i="0">
-                <a:solidFill>
-                  <a:srgbClr val="FFFFFF"/>
-                </a:solidFill>
-                <a:latin typeface="Segoe UI"/>
-              </a:rPr>
-              <a:t>Evaluator</a:t>
+              <a:rPr sz="1200" b="1" i="0">
+                <a:solidFill>
+                  <a:srgbClr val="B8842A"/>
+                </a:solidFill>
+                <a:latin typeface="Segoe UI"/>
+              </a:rPr>
+              <a:t>H-MEM</a:t>
             </a:r>
           </a:p>
           <a:p>
             <a:pPr algn="ctr"/>
             <a:r>
-              <a:rPr sz="950" b="0" i="0">
-                <a:solidFill>
-                  <a:srgbClr val="DDF0F2"/>
-                </a:solidFill>
-                <a:latin typeface="Segoe UI"/>
-              </a:rPr>
-              <a:t>verify / reject</a:t>
-            </a:r>
-          </a:p>
-        </p:txBody>
-      </p:sp>
-      <p:cxnSp>
-        <p:nvCxnSpPr>
-          <p:cNvPr id="14" name="Connector 13"/>
-          <p:cNvCxnSpPr/>
-          <p:nvPr/>
-        </p:nvCxnSpPr>
-        <p:spPr>
-          <a:xfrm>
-            <a:off x="10614080" y="3337560"/>
-            <a:ext cx="0" cy="640079"/>
-          </a:xfrm>
-          <a:prstGeom prst="line">
-            <a:avLst/>
-          </a:prstGeom>
-          <a:ln w="25400">
-            <a:solidFill>
-              <a:srgbClr val="B8842A"/>
-            </a:solidFill>
-          </a:ln>
-        </p:spPr>
-        <p:style>
-          <a:lnRef idx="2">
-            <a:schemeClr val="accent1"/>
-          </a:lnRef>
-          <a:fillRef idx="0">
-            <a:schemeClr val="accent1"/>
-          </a:fillRef>
-          <a:effectRef idx="1">
-            <a:schemeClr val="accent1"/>
-          </a:effectRef>
-          <a:fontRef idx="minor">
-            <a:schemeClr val="tx1"/>
-          </a:fontRef>
-        </p:style>
-      </p:cxnSp>
-      <p:cxnSp>
-        <p:nvCxnSpPr>
-          <p:cNvPr id="15" name="Connector 14"/>
-          <p:cNvCxnSpPr/>
-          <p:nvPr/>
-        </p:nvCxnSpPr>
-        <p:spPr>
-          <a:xfrm flipH="1">
-            <a:off x="8354964" y="3977639"/>
-            <a:ext cx="2259116" cy="0"/>
-          </a:xfrm>
-          <a:prstGeom prst="line">
-            <a:avLst/>
-          </a:prstGeom>
-          <a:ln w="25400">
-            <a:solidFill>
-              <a:srgbClr val="B8842A"/>
-            </a:solidFill>
-          </a:ln>
-        </p:spPr>
-        <p:style>
-          <a:lnRef idx="2">
-            <a:schemeClr val="accent1"/>
-          </a:lnRef>
-          <a:fillRef idx="0">
-            <a:schemeClr val="accent1"/>
-          </a:fillRef>
-          <a:effectRef idx="1">
-            <a:schemeClr val="accent1"/>
-          </a:effectRef>
-          <a:fontRef idx="minor">
-            <a:schemeClr val="tx1"/>
-          </a:fontRef>
-        </p:style>
-      </p:cxnSp>
-      <p:cxnSp>
-        <p:nvCxnSpPr>
-          <p:cNvPr id="16" name="Connector 15"/>
-          <p:cNvCxnSpPr/>
-          <p:nvPr/>
-        </p:nvCxnSpPr>
-        <p:spPr>
-          <a:xfrm flipV="1">
-            <a:off x="8354964" y="3337560"/>
-            <a:ext cx="0" cy="640079"/>
-          </a:xfrm>
-          <a:prstGeom prst="line">
-            <a:avLst/>
-          </a:prstGeom>
-          <a:ln w="25400">
-            <a:solidFill>
-              <a:srgbClr val="B8842A"/>
-            </a:solidFill>
-            <a:tailEnd type="triangle" w="med" len="med"/>
-          </a:ln>
-        </p:spPr>
-        <p:style>
-          <a:lnRef idx="2">
-            <a:schemeClr val="accent1"/>
-          </a:lnRef>
-          <a:fillRef idx="0">
-            <a:schemeClr val="accent1"/>
-          </a:fillRef>
-          <a:effectRef idx="1">
-            <a:schemeClr val="accent1"/>
-          </a:effectRef>
-          <a:fontRef idx="minor">
-            <a:schemeClr val="tx1"/>
-          </a:fontRef>
-        </p:style>
-      </p:cxnSp>
-      <p:sp>
-        <p:nvSpPr>
-          <p:cNvPr id="17" name="TextBox 16"/>
+              <a:rPr sz="850" b="0" i="0">
+                <a:solidFill>
+                  <a:srgbClr val="5B6B7A"/>
+                </a:solidFill>
+                <a:latin typeface="Segoe UI"/>
+              </a:rPr>
+              <a:t>shared evidence · provenance</a:t>
+            </a:r>
+          </a:p>
+        </p:txBody>
+      </p:sp>
+      <p:sp>
+        <p:nvSpPr>
+          <p:cNvPr id="16" name="TextBox 15"/>
           <p:cNvSpPr txBox="1"/>
           <p:nvPr/>
         </p:nvSpPr>
         <p:spPr>
           <a:xfrm>
-            <a:off x="640080" y="4087368"/>
-            <a:ext cx="10881360" cy="320040"/>
+            <a:off x="502920" y="4892040"/>
+            <a:ext cx="2103120" cy="274320"/>
           </a:xfrm>
           <a:prstGeom prst="rect">
             <a:avLst/>
@@ -5245,27 +5210,27 @@
           <a:p>
             <a:pPr algn="ctr"/>
             <a:r>
-              <a:rPr sz="1300" b="1" i="0">
+              <a:rPr sz="1100" b="1" i="0">
                 <a:solidFill>
                   <a:srgbClr val="B8842A"/>
                 </a:solidFill>
                 <a:latin typeface="Segoe UI"/>
               </a:rPr>
-              <a:t>✗ unsupported → the Reporter revises &amp; re-cites, then re-evaluates (loops ≤ MAX_ROUNDS)</a:t>
-            </a:r>
-          </a:p>
-        </p:txBody>
-      </p:sp>
-      <p:sp>
-        <p:nvSpPr>
-          <p:cNvPr id="18" name="TextBox 17"/>
+              <a:t>✗ revise &amp; re-cite</a:t>
+            </a:r>
+          </a:p>
+        </p:txBody>
+      </p:sp>
+      <p:sp>
+        <p:nvSpPr>
+          <p:cNvPr id="17" name="TextBox 16"/>
           <p:cNvSpPr txBox="1"/>
           <p:nvPr/>
         </p:nvSpPr>
         <p:spPr>
           <a:xfrm>
-            <a:off x="640080" y="4453127"/>
-            <a:ext cx="10881360" cy="320040"/>
+            <a:off x="640080" y="5989320"/>
+            <a:ext cx="10881360" cy="411480"/>
           </a:xfrm>
           <a:prstGeom prst="rect">
             <a:avLst/>
@@ -5280,55 +5245,20 @@
           <a:p>
             <a:pPr algn="ctr"/>
             <a:r>
-              <a:rPr sz="1300" b="1" i="0">
-                <a:solidFill>
-                  <a:srgbClr val="128A98"/>
-                </a:solidFill>
-                <a:latin typeface="Segoe UI"/>
-              </a:rPr>
-              <a:t>✓ the cited answer ships only when every claim passes the Evaluator</a:t>
-            </a:r>
-          </a:p>
-        </p:txBody>
-      </p:sp>
-      <p:sp>
-        <p:nvSpPr>
-          <p:cNvPr id="19" name="TextBox 18"/>
-          <p:cNvSpPr txBox="1"/>
-          <p:nvPr/>
-        </p:nvSpPr>
-        <p:spPr>
-          <a:xfrm>
-            <a:off x="640080" y="5349240"/>
-            <a:ext cx="10881360" cy="822960"/>
-          </a:xfrm>
-          <a:prstGeom prst="rect">
-            <a:avLst/>
-          </a:prstGeom>
-          <a:noFill/>
-        </p:spPr>
-        <p:txBody>
-          <a:bodyPr wrap="square" anchor="t">
-            <a:spAutoFit/>
-          </a:bodyPr>
-          <a:lstStyle/>
-          <a:p>
-            <a:pPr algn="ctr"/>
-            <a:r>
-              <a:rPr sz="1300" b="0" i="0">
+              <a:rPr sz="1200" b="0" i="0">
                 <a:solidFill>
                   <a:srgbClr val="5B6B7A"/>
                 </a:solidFill>
                 <a:latin typeface="Segoe UI"/>
               </a:rPr>
-              <a:t>A cycle, not a line — specialized roles · separate Nemotron calls · shared H-MEM evidence memory · full trace + signed Meterless receipts.</a:t>
-            </a:r>
-          </a:p>
-        </p:txBody>
-      </p:sp>
-      <p:sp>
-        <p:nvSpPr>
-          <p:cNvPr id="20" name="Rectangle 19"/>
+              <a:t>A cycle, not a line — specialized roles · separate Nemotron calls · the Evaluator loops unsupported claims back (≤ MAX_ROUNDS) and ships only when every claim is backed.</a:t>
+            </a:r>
+          </a:p>
+        </p:txBody>
+      </p:sp>
+      <p:sp>
+        <p:nvSpPr>
+          <p:cNvPr id="18" name="Rectangle 17"/>
           <p:cNvSpPr/>
           <p:nvPr/>
         </p:nvSpPr>
@@ -5372,7 +5302,7 @@
       </p:sp>
       <p:sp>
         <p:nvSpPr>
-          <p:cNvPr id="21" name="TextBox 20"/>
+          <p:cNvPr id="19" name="TextBox 18"/>
           <p:cNvSpPr txBox="1"/>
           <p:nvPr/>
         </p:nvSpPr>

</xml_diff>

<commit_message>
Slide 5: connect H-MEM (write/read spokes) — depict the shared-memory trait
H-MEM was floating in the hub. Added directional spokes showing the real data
flow: Analyst & cross_source write evidence into H-MEM; Reporter & Evaluator
read from it. The hub is now wired, and the diagram shows the "shared memory"
strong-agent criterion instead of merely claiming it.

Co-Authored-By: Claude Opus 4.8 (1M context) <noreply@anthropic.com>
</commit_message>
<xml_diff>
--- a/deck/Evidence-Intelligence-Agent.pptx
+++ b/deck/Evidence-Intelligence-Agent.pptx
@@ -4786,9 +4786,153 @@
           </a:fontRef>
         </p:style>
       </p:cxnSp>
-      <p:sp>
-        <p:nvSpPr>
-          <p:cNvPr id="10" name="Rounded Rectangle 9"/>
+      <p:cxnSp>
+        <p:nvCxnSpPr>
+          <p:cNvPr id="10" name="Connector 9"/>
+          <p:cNvCxnSpPr/>
+          <p:nvPr/>
+        </p:nvCxnSpPr>
+        <p:spPr>
+          <a:xfrm flipH="1">
+            <a:off x="6941321" y="3773720"/>
+            <a:ext cx="1699200" cy="207850"/>
+          </a:xfrm>
+          <a:prstGeom prst="line">
+            <a:avLst/>
+          </a:prstGeom>
+          <a:ln w="15875">
+            <a:solidFill>
+              <a:srgbClr val="9AA7B2"/>
+            </a:solidFill>
+            <a:tailEnd type="triangle" w="med" len="med"/>
+          </a:ln>
+        </p:spPr>
+        <p:style>
+          <a:lnRef idx="2">
+            <a:schemeClr val="accent1"/>
+          </a:lnRef>
+          <a:fillRef idx="0">
+            <a:schemeClr val="accent1"/>
+          </a:fillRef>
+          <a:effectRef idx="1">
+            <a:schemeClr val="accent1"/>
+          </a:effectRef>
+          <a:fontRef idx="minor">
+            <a:schemeClr val="tx1"/>
+          </a:fontRef>
+        </p:style>
+      </p:cxnSp>
+      <p:cxnSp>
+        <p:nvCxnSpPr>
+          <p:cNvPr id="11" name="Connector 10"/>
+          <p:cNvCxnSpPr/>
+          <p:nvPr/>
+        </p:nvCxnSpPr>
+        <p:spPr>
+          <a:xfrm flipH="1" flipV="1">
+            <a:off x="6826415" y="4619627"/>
+            <a:ext cx="498116" cy="258107"/>
+          </a:xfrm>
+          <a:prstGeom prst="line">
+            <a:avLst/>
+          </a:prstGeom>
+          <a:ln w="15875">
+            <a:solidFill>
+              <a:srgbClr val="9AA7B2"/>
+            </a:solidFill>
+            <a:tailEnd type="triangle" w="med" len="med"/>
+          </a:ln>
+        </p:spPr>
+        <p:style>
+          <a:lnRef idx="2">
+            <a:schemeClr val="accent1"/>
+          </a:lnRef>
+          <a:fillRef idx="0">
+            <a:schemeClr val="accent1"/>
+          </a:fillRef>
+          <a:effectRef idx="1">
+            <a:schemeClr val="accent1"/>
+          </a:effectRef>
+          <a:fontRef idx="minor">
+            <a:schemeClr val="tx1"/>
+          </a:fontRef>
+        </p:style>
+      </p:cxnSp>
+      <p:cxnSp>
+        <p:nvCxnSpPr>
+          <p:cNvPr id="12" name="Connector 11"/>
+          <p:cNvCxnSpPr/>
+          <p:nvPr/>
+        </p:nvCxnSpPr>
+        <p:spPr>
+          <a:xfrm flipH="1">
+            <a:off x="4379788" y="4619627"/>
+            <a:ext cx="498116" cy="258107"/>
+          </a:xfrm>
+          <a:prstGeom prst="line">
+            <a:avLst/>
+          </a:prstGeom>
+          <a:ln w="15875">
+            <a:solidFill>
+              <a:srgbClr val="9AA7B2"/>
+            </a:solidFill>
+            <a:tailEnd type="triangle" w="med" len="med"/>
+          </a:ln>
+        </p:spPr>
+        <p:style>
+          <a:lnRef idx="2">
+            <a:schemeClr val="accent1"/>
+          </a:lnRef>
+          <a:fillRef idx="0">
+            <a:schemeClr val="accent1"/>
+          </a:fillRef>
+          <a:effectRef idx="1">
+            <a:schemeClr val="accent1"/>
+          </a:effectRef>
+          <a:fontRef idx="minor">
+            <a:schemeClr val="tx1"/>
+          </a:fontRef>
+        </p:style>
+      </p:cxnSp>
+      <p:cxnSp>
+        <p:nvCxnSpPr>
+          <p:cNvPr id="13" name="Connector 12"/>
+          <p:cNvCxnSpPr/>
+          <p:nvPr/>
+        </p:nvCxnSpPr>
+        <p:spPr>
+          <a:xfrm flipH="1" flipV="1">
+            <a:off x="3063798" y="3773720"/>
+            <a:ext cx="1699200" cy="207850"/>
+          </a:xfrm>
+          <a:prstGeom prst="line">
+            <a:avLst/>
+          </a:prstGeom>
+          <a:ln w="15875">
+            <a:solidFill>
+              <a:srgbClr val="9AA7B2"/>
+            </a:solidFill>
+            <a:tailEnd type="triangle" w="med" len="med"/>
+          </a:ln>
+        </p:spPr>
+        <p:style>
+          <a:lnRef idx="2">
+            <a:schemeClr val="accent1"/>
+          </a:lnRef>
+          <a:fillRef idx="0">
+            <a:schemeClr val="accent1"/>
+          </a:fillRef>
+          <a:effectRef idx="1">
+            <a:schemeClr val="accent1"/>
+          </a:effectRef>
+          <a:fontRef idx="minor">
+            <a:schemeClr val="tx1"/>
+          </a:fontRef>
+        </p:style>
+      </p:cxnSp>
+      <p:sp>
+        <p:nvSpPr>
+          <p:cNvPr id="14" name="Rounded Rectangle 13"/>
           <p:cNvSpPr/>
           <p:nvPr/>
         </p:nvSpPr>
@@ -4855,7 +4999,7 @@
       </p:sp>
       <p:sp>
         <p:nvSpPr>
-          <p:cNvPr id="11" name="Rounded Rectangle 10"/>
+          <p:cNvPr id="15" name="Rounded Rectangle 14"/>
           <p:cNvSpPr/>
           <p:nvPr/>
         </p:nvSpPr>
@@ -4922,7 +5066,7 @@
       </p:sp>
       <p:sp>
         <p:nvSpPr>
-          <p:cNvPr id="12" name="Rounded Rectangle 11"/>
+          <p:cNvPr id="16" name="Rounded Rectangle 15"/>
           <p:cNvSpPr/>
           <p:nvPr/>
         </p:nvSpPr>
@@ -4989,7 +5133,7 @@
       </p:sp>
       <p:sp>
         <p:nvSpPr>
-          <p:cNvPr id="13" name="Rounded Rectangle 12"/>
+          <p:cNvPr id="17" name="Rounded Rectangle 16"/>
           <p:cNvSpPr/>
           <p:nvPr/>
         </p:nvSpPr>
@@ -5056,7 +5200,7 @@
       </p:sp>
       <p:sp>
         <p:nvSpPr>
-          <p:cNvPr id="14" name="Rounded Rectangle 13"/>
+          <p:cNvPr id="18" name="Rounded Rectangle 17"/>
           <p:cNvSpPr/>
           <p:nvPr/>
         </p:nvSpPr>
@@ -5121,7 +5265,7 @@
       </p:sp>
       <p:sp>
         <p:nvSpPr>
-          <p:cNvPr id="15" name="Rounded Rectangle 14"/>
+          <p:cNvPr id="19" name="Rounded Rectangle 18"/>
           <p:cNvSpPr/>
           <p:nvPr/>
         </p:nvSpPr>
@@ -5188,7 +5332,7 @@
       </p:sp>
       <p:sp>
         <p:nvSpPr>
-          <p:cNvPr id="16" name="TextBox 15"/>
+          <p:cNvPr id="20" name="TextBox 19"/>
           <p:cNvSpPr txBox="1"/>
           <p:nvPr/>
         </p:nvSpPr>
@@ -5223,7 +5367,7 @@
       </p:sp>
       <p:sp>
         <p:nvSpPr>
-          <p:cNvPr id="17" name="TextBox 16"/>
+          <p:cNvPr id="21" name="TextBox 20"/>
           <p:cNvSpPr txBox="1"/>
           <p:nvPr/>
         </p:nvSpPr>
@@ -5251,14 +5395,14 @@
                 </a:solidFill>
                 <a:latin typeface="Segoe UI"/>
               </a:rPr>
-              <a:t>A cycle, not a line — specialized roles · separate Nemotron calls · the Evaluator loops unsupported claims back (≤ MAX_ROUNDS) and ships only when every claim is backed.</a:t>
-            </a:r>
-          </a:p>
-        </p:txBody>
-      </p:sp>
-      <p:sp>
-        <p:nvSpPr>
-          <p:cNvPr id="18" name="Rectangle 17"/>
+              <a:t>A cycle, not a line — roles share evidence through H-MEM (gatherers write · Reporter/Evaluator read); unsupported claims loop back to revise (≤ MAX_ROUNDS).</a:t>
+            </a:r>
+          </a:p>
+        </p:txBody>
+      </p:sp>
+      <p:sp>
+        <p:nvSpPr>
+          <p:cNvPr id="22" name="Rectangle 21"/>
           <p:cNvSpPr/>
           <p:nvPr/>
         </p:nvSpPr>
@@ -5302,7 +5446,7 @@
       </p:sp>
       <p:sp>
         <p:nvSpPr>
-          <p:cNvPr id="19" name="TextBox 18"/>
+          <p:cNvPr id="23" name="TextBox 22"/>
           <p:cNvSpPr txBox="1"/>
           <p:nvPr/>
         </p:nvSpPr>

</xml_diff>

<commit_message>
Slide 5: left-to-right layout with a shared-memory lane + feedback loop
Per request, laid out left-to-right for natural reading, but kept it from reading
as a bare pipeline: a feedback loop arcs Evaluator->Reporter over the row, and a
shared H-MEM lane sits below it — Analyst & cross_source write in, Reporter &
Evaluator read out. Row + loop + shared memory = the strong-agent traits, L-R.

Co-Authored-By: Claude Opus 4.8 (1M context) <noreply@anthropic.com>
</commit_message>
<xml_diff>
--- a/deck/Evidence-Intelligence-Agent.pptx
+++ b/deck/Evidence-Intelligence-Agent.pptx
@@ -4606,340 +4606,16 @@
           </a:p>
         </p:txBody>
       </p:sp>
-      <p:cxnSp>
-        <p:nvCxnSpPr>
-          <p:cNvPr id="5" name="Connector 4"/>
-          <p:cNvCxnSpPr/>
-          <p:nvPr/>
-        </p:nvCxnSpPr>
-        <p:spPr>
-          <a:xfrm>
-            <a:off x="6716521" y="2888181"/>
-            <a:ext cx="1861432" cy="509143"/>
-          </a:xfrm>
-          <a:prstGeom prst="line">
-            <a:avLst/>
-          </a:prstGeom>
-          <a:ln w="25400">
-            <a:solidFill>
-              <a:srgbClr val="128A98"/>
-            </a:solidFill>
-            <a:tailEnd type="triangle" w="med" len="med"/>
-          </a:ln>
-        </p:spPr>
-        <p:style>
-          <a:lnRef idx="2">
-            <a:schemeClr val="accent1"/>
-          </a:lnRef>
-          <a:fillRef idx="0">
-            <a:schemeClr val="accent1"/>
-          </a:fillRef>
-          <a:effectRef idx="1">
-            <a:schemeClr val="accent1"/>
-          </a:effectRef>
-          <a:fontRef idx="minor">
-            <a:schemeClr val="tx1"/>
-          </a:fontRef>
-        </p:style>
-      </p:cxnSp>
-      <p:cxnSp>
-        <p:nvCxnSpPr>
-          <p:cNvPr id="6" name="Connector 5"/>
-          <p:cNvCxnSpPr/>
-          <p:nvPr/>
-        </p:nvCxnSpPr>
-        <p:spPr>
-          <a:xfrm flipH="1">
-            <a:off x="8793600" y="4341084"/>
-            <a:ext cx="169060" cy="195883"/>
-          </a:xfrm>
-          <a:prstGeom prst="line">
-            <a:avLst/>
-          </a:prstGeom>
-          <a:ln w="25400">
-            <a:solidFill>
-              <a:srgbClr val="128A98"/>
-            </a:solidFill>
-            <a:tailEnd type="triangle" w="med" len="med"/>
-          </a:ln>
-        </p:spPr>
-        <p:style>
-          <a:lnRef idx="2">
-            <a:schemeClr val="accent1"/>
-          </a:lnRef>
-          <a:fillRef idx="0">
-            <a:schemeClr val="accent1"/>
-          </a:fillRef>
-          <a:effectRef idx="1">
-            <a:schemeClr val="accent1"/>
-          </a:effectRef>
-          <a:fontRef idx="minor">
-            <a:schemeClr val="tx1"/>
-          </a:fontRef>
-        </p:style>
-      </p:cxnSp>
-      <p:cxnSp>
-        <p:nvCxnSpPr>
-          <p:cNvPr id="7" name="Connector 6"/>
-          <p:cNvCxnSpPr/>
-          <p:nvPr/>
-        </p:nvCxnSpPr>
-        <p:spPr>
-          <a:xfrm flipH="1">
-            <a:off x="4573748" y="5298424"/>
-            <a:ext cx="2666551" cy="0"/>
-          </a:xfrm>
-          <a:prstGeom prst="line">
-            <a:avLst/>
-          </a:prstGeom>
-          <a:ln w="25400">
-            <a:solidFill>
-              <a:srgbClr val="128A98"/>
-            </a:solidFill>
-            <a:tailEnd type="triangle" w="med" len="med"/>
-          </a:ln>
-        </p:spPr>
-        <p:style>
-          <a:lnRef idx="2">
-            <a:schemeClr val="accent1"/>
-          </a:lnRef>
-          <a:fillRef idx="0">
-            <a:schemeClr val="accent1"/>
-          </a:fillRef>
-          <a:effectRef idx="1">
-            <a:schemeClr val="accent1"/>
-          </a:effectRef>
-          <a:fontRef idx="minor">
-            <a:schemeClr val="tx1"/>
-          </a:fontRef>
-        </p:style>
-      </p:cxnSp>
-      <p:cxnSp>
-        <p:nvCxnSpPr>
-          <p:cNvPr id="8" name="Connector 7"/>
-          <p:cNvCxnSpPr/>
-          <p:nvPr/>
-        </p:nvCxnSpPr>
-        <p:spPr>
-          <a:xfrm flipH="1" flipV="1">
-            <a:off x="2813353" y="4424152"/>
-            <a:ext cx="169060" cy="195883"/>
-          </a:xfrm>
-          <a:prstGeom prst="line">
-            <a:avLst/>
-          </a:prstGeom>
-          <a:ln w="25400">
-            <a:solidFill>
-              <a:srgbClr val="128A98"/>
-            </a:solidFill>
-            <a:tailEnd type="triangle" w="med" len="med"/>
-          </a:ln>
-        </p:spPr>
-        <p:style>
-          <a:lnRef idx="2">
-            <a:schemeClr val="accent1"/>
-          </a:lnRef>
-          <a:fillRef idx="0">
-            <a:schemeClr val="accent1"/>
-          </a:fillRef>
-          <a:effectRef idx="1">
-            <a:schemeClr val="accent1"/>
-          </a:effectRef>
-          <a:fontRef idx="minor">
-            <a:schemeClr val="tx1"/>
-          </a:fontRef>
-        </p:style>
-      </p:cxnSp>
-      <p:cxnSp>
-        <p:nvCxnSpPr>
-          <p:cNvPr id="9" name="Connector 8"/>
-          <p:cNvCxnSpPr/>
-          <p:nvPr/>
-        </p:nvCxnSpPr>
-        <p:spPr>
-          <a:xfrm>
-            <a:off x="2312475" y="4711500"/>
-            <a:ext cx="169060" cy="195882"/>
-          </a:xfrm>
-          <a:prstGeom prst="line">
-            <a:avLst/>
-          </a:prstGeom>
-          <a:ln w="28575">
-            <a:solidFill>
-              <a:srgbClr val="B8842A"/>
-            </a:solidFill>
-            <a:tailEnd type="triangle" w="med" len="med"/>
-          </a:ln>
-        </p:spPr>
-        <p:style>
-          <a:lnRef idx="2">
-            <a:schemeClr val="accent1"/>
-          </a:lnRef>
-          <a:fillRef idx="0">
-            <a:schemeClr val="accent1"/>
-          </a:fillRef>
-          <a:effectRef idx="1">
-            <a:schemeClr val="accent1"/>
-          </a:effectRef>
-          <a:fontRef idx="minor">
-            <a:schemeClr val="tx1"/>
-          </a:fontRef>
-        </p:style>
-      </p:cxnSp>
-      <p:cxnSp>
-        <p:nvCxnSpPr>
-          <p:cNvPr id="10" name="Connector 9"/>
-          <p:cNvCxnSpPr/>
-          <p:nvPr/>
-        </p:nvCxnSpPr>
-        <p:spPr>
-          <a:xfrm flipH="1">
-            <a:off x="6941321" y="3773720"/>
-            <a:ext cx="1699200" cy="207850"/>
-          </a:xfrm>
-          <a:prstGeom prst="line">
-            <a:avLst/>
-          </a:prstGeom>
-          <a:ln w="15875">
-            <a:solidFill>
-              <a:srgbClr val="9AA7B2"/>
-            </a:solidFill>
-            <a:tailEnd type="triangle" w="med" len="med"/>
-          </a:ln>
-        </p:spPr>
-        <p:style>
-          <a:lnRef idx="2">
-            <a:schemeClr val="accent1"/>
-          </a:lnRef>
-          <a:fillRef idx="0">
-            <a:schemeClr val="accent1"/>
-          </a:fillRef>
-          <a:effectRef idx="1">
-            <a:schemeClr val="accent1"/>
-          </a:effectRef>
-          <a:fontRef idx="minor">
-            <a:schemeClr val="tx1"/>
-          </a:fontRef>
-        </p:style>
-      </p:cxnSp>
-      <p:cxnSp>
-        <p:nvCxnSpPr>
-          <p:cNvPr id="11" name="Connector 10"/>
-          <p:cNvCxnSpPr/>
-          <p:nvPr/>
-        </p:nvCxnSpPr>
-        <p:spPr>
-          <a:xfrm flipH="1" flipV="1">
-            <a:off x="6826415" y="4619627"/>
-            <a:ext cx="498116" cy="258107"/>
-          </a:xfrm>
-          <a:prstGeom prst="line">
-            <a:avLst/>
-          </a:prstGeom>
-          <a:ln w="15875">
-            <a:solidFill>
-              <a:srgbClr val="9AA7B2"/>
-            </a:solidFill>
-            <a:tailEnd type="triangle" w="med" len="med"/>
-          </a:ln>
-        </p:spPr>
-        <p:style>
-          <a:lnRef idx="2">
-            <a:schemeClr val="accent1"/>
-          </a:lnRef>
-          <a:fillRef idx="0">
-            <a:schemeClr val="accent1"/>
-          </a:fillRef>
-          <a:effectRef idx="1">
-            <a:schemeClr val="accent1"/>
-          </a:effectRef>
-          <a:fontRef idx="minor">
-            <a:schemeClr val="tx1"/>
-          </a:fontRef>
-        </p:style>
-      </p:cxnSp>
-      <p:cxnSp>
-        <p:nvCxnSpPr>
-          <p:cNvPr id="12" name="Connector 11"/>
-          <p:cNvCxnSpPr/>
-          <p:nvPr/>
-        </p:nvCxnSpPr>
-        <p:spPr>
-          <a:xfrm flipH="1">
-            <a:off x="4379788" y="4619627"/>
-            <a:ext cx="498116" cy="258107"/>
-          </a:xfrm>
-          <a:prstGeom prst="line">
-            <a:avLst/>
-          </a:prstGeom>
-          <a:ln w="15875">
-            <a:solidFill>
-              <a:srgbClr val="9AA7B2"/>
-            </a:solidFill>
-            <a:tailEnd type="triangle" w="med" len="med"/>
-          </a:ln>
-        </p:spPr>
-        <p:style>
-          <a:lnRef idx="2">
-            <a:schemeClr val="accent1"/>
-          </a:lnRef>
-          <a:fillRef idx="0">
-            <a:schemeClr val="accent1"/>
-          </a:fillRef>
-          <a:effectRef idx="1">
-            <a:schemeClr val="accent1"/>
-          </a:effectRef>
-          <a:fontRef idx="minor">
-            <a:schemeClr val="tx1"/>
-          </a:fontRef>
-        </p:style>
-      </p:cxnSp>
-      <p:cxnSp>
-        <p:nvCxnSpPr>
-          <p:cNvPr id="13" name="Connector 12"/>
-          <p:cNvCxnSpPr/>
-          <p:nvPr/>
-        </p:nvCxnSpPr>
-        <p:spPr>
-          <a:xfrm flipH="1" flipV="1">
-            <a:off x="3063798" y="3773720"/>
-            <a:ext cx="1699200" cy="207850"/>
-          </a:xfrm>
-          <a:prstGeom prst="line">
-            <a:avLst/>
-          </a:prstGeom>
-          <a:ln w="15875">
-            <a:solidFill>
-              <a:srgbClr val="9AA7B2"/>
-            </a:solidFill>
-            <a:tailEnd type="triangle" w="med" len="med"/>
-          </a:ln>
-        </p:spPr>
-        <p:style>
-          <a:lnRef idx="2">
-            <a:schemeClr val="accent1"/>
-          </a:lnRef>
-          <a:fillRef idx="0">
-            <a:schemeClr val="accent1"/>
-          </a:fillRef>
-          <a:effectRef idx="1">
-            <a:schemeClr val="accent1"/>
-          </a:effectRef>
-          <a:fontRef idx="minor">
-            <a:schemeClr val="tx1"/>
-          </a:fontRef>
-        </p:style>
-      </p:cxnSp>
-      <p:sp>
-        <p:nvSpPr>
-          <p:cNvPr id="14" name="Rounded Rectangle 13"/>
+      <p:sp>
+        <p:nvSpPr>
+          <p:cNvPr id="5" name="Rounded Rectangle 4"/>
           <p:cNvSpPr/>
           <p:nvPr/>
         </p:nvSpPr>
         <p:spPr>
           <a:xfrm>
-            <a:off x="4960620" y="2249424"/>
-            <a:ext cx="1783080" cy="804672"/>
+            <a:off x="640080" y="2697480"/>
+            <a:ext cx="1845807" cy="914400"/>
           </a:xfrm>
           <a:prstGeom prst="roundRect">
             <a:avLst/>
@@ -4999,14 +4675,58 @@
       </p:sp>
       <p:sp>
         <p:nvSpPr>
-          <p:cNvPr id="15" name="Rounded Rectangle 14"/>
+          <p:cNvPr id="6" name="Right Arrow 5"/>
           <p:cNvSpPr/>
           <p:nvPr/>
         </p:nvSpPr>
         <p:spPr>
           <a:xfrm>
-            <a:off x="8656615" y="3260359"/>
-            <a:ext cx="1783080" cy="804672"/>
+            <a:off x="2531607" y="3063240"/>
+            <a:ext cx="329184" cy="182880"/>
+          </a:xfrm>
+          <a:prstGeom prst="rightArrow">
+            <a:avLst/>
+          </a:prstGeom>
+          <a:solidFill>
+            <a:srgbClr val="128A98"/>
+          </a:solidFill>
+          <a:ln>
+            <a:noFill/>
+          </a:ln>
+          <a:effectLst/>
+        </p:spPr>
+        <p:style>
+          <a:lnRef idx="1">
+            <a:schemeClr val="accent1"/>
+          </a:lnRef>
+          <a:fillRef idx="3">
+            <a:schemeClr val="accent1"/>
+          </a:fillRef>
+          <a:effectRef idx="2">
+            <a:schemeClr val="accent1"/>
+          </a:effectRef>
+          <a:fontRef idx="minor">
+            <a:schemeClr val="lt1"/>
+          </a:fontRef>
+        </p:style>
+        <p:txBody>
+          <a:bodyPr rtlCol="0" anchor="ctr"/>
+          <a:lstStyle/>
+          <a:p>
+            <a:pPr algn="ctr"/>
+          </a:p>
+        </p:txBody>
+      </p:sp>
+      <p:sp>
+        <p:nvSpPr>
+          <p:cNvPr id="7" name="Rounded Rectangle 6"/>
+          <p:cNvSpPr/>
+          <p:nvPr/>
+        </p:nvSpPr>
+        <p:spPr>
+          <a:xfrm>
+            <a:off x="2906511" y="2697480"/>
+            <a:ext cx="1845807" cy="914400"/>
           </a:xfrm>
           <a:prstGeom prst="roundRect">
             <a:avLst/>
@@ -5066,14 +4786,58 @@
       </p:sp>
       <p:sp>
         <p:nvSpPr>
-          <p:cNvPr id="16" name="Rounded Rectangle 15"/>
+          <p:cNvPr id="8" name="Right Arrow 7"/>
           <p:cNvSpPr/>
           <p:nvPr/>
         </p:nvSpPr>
         <p:spPr>
           <a:xfrm>
-            <a:off x="7244871" y="4896088"/>
-            <a:ext cx="1783080" cy="804672"/>
+            <a:off x="4798039" y="3063240"/>
+            <a:ext cx="329184" cy="182880"/>
+          </a:xfrm>
+          <a:prstGeom prst="rightArrow">
+            <a:avLst/>
+          </a:prstGeom>
+          <a:solidFill>
+            <a:srgbClr val="128A98"/>
+          </a:solidFill>
+          <a:ln>
+            <a:noFill/>
+          </a:ln>
+          <a:effectLst/>
+        </p:spPr>
+        <p:style>
+          <a:lnRef idx="1">
+            <a:schemeClr val="accent1"/>
+          </a:lnRef>
+          <a:fillRef idx="3">
+            <a:schemeClr val="accent1"/>
+          </a:fillRef>
+          <a:effectRef idx="2">
+            <a:schemeClr val="accent1"/>
+          </a:effectRef>
+          <a:fontRef idx="minor">
+            <a:schemeClr val="lt1"/>
+          </a:fontRef>
+        </p:style>
+        <p:txBody>
+          <a:bodyPr rtlCol="0" anchor="ctr"/>
+          <a:lstStyle/>
+          <a:p>
+            <a:pPr algn="ctr"/>
+          </a:p>
+        </p:txBody>
+      </p:sp>
+      <p:sp>
+        <p:nvSpPr>
+          <p:cNvPr id="9" name="Rounded Rectangle 8"/>
+          <p:cNvSpPr/>
+          <p:nvPr/>
+        </p:nvSpPr>
+        <p:spPr>
+          <a:xfrm>
+            <a:off x="5172943" y="2697480"/>
+            <a:ext cx="1845807" cy="914400"/>
           </a:xfrm>
           <a:prstGeom prst="roundRect">
             <a:avLst/>
@@ -5133,14 +4897,58 @@
       </p:sp>
       <p:sp>
         <p:nvSpPr>
-          <p:cNvPr id="17" name="Rounded Rectangle 16"/>
+          <p:cNvPr id="10" name="Right Arrow 9"/>
           <p:cNvSpPr/>
           <p:nvPr/>
         </p:nvSpPr>
         <p:spPr>
           <a:xfrm>
-            <a:off x="2676368" y="4896088"/>
-            <a:ext cx="1783080" cy="804672"/>
+            <a:off x="7064471" y="3063240"/>
+            <a:ext cx="329184" cy="182880"/>
+          </a:xfrm>
+          <a:prstGeom prst="rightArrow">
+            <a:avLst/>
+          </a:prstGeom>
+          <a:solidFill>
+            <a:srgbClr val="128A98"/>
+          </a:solidFill>
+          <a:ln>
+            <a:noFill/>
+          </a:ln>
+          <a:effectLst/>
+        </p:spPr>
+        <p:style>
+          <a:lnRef idx="1">
+            <a:schemeClr val="accent1"/>
+          </a:lnRef>
+          <a:fillRef idx="3">
+            <a:schemeClr val="accent1"/>
+          </a:fillRef>
+          <a:effectRef idx="2">
+            <a:schemeClr val="accent1"/>
+          </a:effectRef>
+          <a:fontRef idx="minor">
+            <a:schemeClr val="lt1"/>
+          </a:fontRef>
+        </p:style>
+        <p:txBody>
+          <a:bodyPr rtlCol="0" anchor="ctr"/>
+          <a:lstStyle/>
+          <a:p>
+            <a:pPr algn="ctr"/>
+          </a:p>
+        </p:txBody>
+      </p:sp>
+      <p:sp>
+        <p:nvSpPr>
+          <p:cNvPr id="11" name="Rounded Rectangle 10"/>
+          <p:cNvSpPr/>
+          <p:nvPr/>
+        </p:nvSpPr>
+        <p:spPr>
+          <a:xfrm>
+            <a:off x="7439375" y="2697480"/>
+            <a:ext cx="1845807" cy="914400"/>
           </a:xfrm>
           <a:prstGeom prst="roundRect">
             <a:avLst/>
@@ -5200,16 +5008,16 @@
       </p:sp>
       <p:sp>
         <p:nvSpPr>
-          <p:cNvPr id="18" name="Rounded Rectangle 17"/>
+          <p:cNvPr id="12" name="Right Arrow 11"/>
           <p:cNvSpPr/>
           <p:nvPr/>
         </p:nvSpPr>
         <p:spPr>
           <a:xfrm>
-            <a:off x="1264624" y="3260359"/>
-            <a:ext cx="1783080" cy="804672"/>
-          </a:xfrm>
-          <a:prstGeom prst="roundRect">
+            <a:off x="9330903" y="3063240"/>
+            <a:ext cx="329184" cy="182880"/>
+          </a:xfrm>
+          <a:prstGeom prst="rightArrow">
             <a:avLst/>
           </a:prstGeom>
           <a:solidFill>
@@ -5235,6 +5043,50 @@
           </a:fontRef>
         </p:style>
         <p:txBody>
+          <a:bodyPr rtlCol="0" anchor="ctr"/>
+          <a:lstStyle/>
+          <a:p>
+            <a:pPr algn="ctr"/>
+          </a:p>
+        </p:txBody>
+      </p:sp>
+      <p:sp>
+        <p:nvSpPr>
+          <p:cNvPr id="13" name="Rounded Rectangle 12"/>
+          <p:cNvSpPr/>
+          <p:nvPr/>
+        </p:nvSpPr>
+        <p:spPr>
+          <a:xfrm>
+            <a:off x="9705807" y="2697480"/>
+            <a:ext cx="1845807" cy="914400"/>
+          </a:xfrm>
+          <a:prstGeom prst="roundRect">
+            <a:avLst/>
+          </a:prstGeom>
+          <a:solidFill>
+            <a:srgbClr val="128A98"/>
+          </a:solidFill>
+          <a:ln>
+            <a:noFill/>
+          </a:ln>
+          <a:effectLst/>
+        </p:spPr>
+        <p:style>
+          <a:lnRef idx="1">
+            <a:schemeClr val="accent1"/>
+          </a:lnRef>
+          <a:fillRef idx="3">
+            <a:schemeClr val="accent1"/>
+          </a:fillRef>
+          <a:effectRef idx="2">
+            <a:schemeClr val="accent1"/>
+          </a:effectRef>
+          <a:fontRef idx="minor">
+            <a:schemeClr val="lt1"/>
+          </a:fontRef>
+        </p:style>
+        <p:txBody>
           <a:bodyPr rtlCol="0" anchor="ctr" wrap="square"/>
           <a:lstStyle/>
           <a:p>
@@ -5263,16 +5115,157 @@
           </a:p>
         </p:txBody>
       </p:sp>
-      <p:sp>
-        <p:nvSpPr>
-          <p:cNvPr id="19" name="Rounded Rectangle 18"/>
+      <p:cxnSp>
+        <p:nvCxnSpPr>
+          <p:cNvPr id="14" name="Connector 13"/>
+          <p:cNvCxnSpPr/>
+          <p:nvPr/>
+        </p:nvCxnSpPr>
+        <p:spPr>
+          <a:xfrm flipV="1">
+            <a:off x="10628711" y="2240280"/>
+            <a:ext cx="0" cy="457200"/>
+          </a:xfrm>
+          <a:prstGeom prst="line">
+            <a:avLst/>
+          </a:prstGeom>
+          <a:ln w="28575">
+            <a:solidFill>
+              <a:srgbClr val="B8842A"/>
+            </a:solidFill>
+          </a:ln>
+        </p:spPr>
+        <p:style>
+          <a:lnRef idx="2">
+            <a:schemeClr val="accent1"/>
+          </a:lnRef>
+          <a:fillRef idx="0">
+            <a:schemeClr val="accent1"/>
+          </a:fillRef>
+          <a:effectRef idx="1">
+            <a:schemeClr val="accent1"/>
+          </a:effectRef>
+          <a:fontRef idx="minor">
+            <a:schemeClr val="tx1"/>
+          </a:fontRef>
+        </p:style>
+      </p:cxnSp>
+      <p:cxnSp>
+        <p:nvCxnSpPr>
+          <p:cNvPr id="15" name="Connector 14"/>
+          <p:cNvCxnSpPr/>
+          <p:nvPr/>
+        </p:nvCxnSpPr>
+        <p:spPr>
+          <a:xfrm flipH="1">
+            <a:off x="8362279" y="2240280"/>
+            <a:ext cx="2266432" cy="0"/>
+          </a:xfrm>
+          <a:prstGeom prst="line">
+            <a:avLst/>
+          </a:prstGeom>
+          <a:ln w="28575">
+            <a:solidFill>
+              <a:srgbClr val="B8842A"/>
+            </a:solidFill>
+          </a:ln>
+        </p:spPr>
+        <p:style>
+          <a:lnRef idx="2">
+            <a:schemeClr val="accent1"/>
+          </a:lnRef>
+          <a:fillRef idx="0">
+            <a:schemeClr val="accent1"/>
+          </a:fillRef>
+          <a:effectRef idx="1">
+            <a:schemeClr val="accent1"/>
+          </a:effectRef>
+          <a:fontRef idx="minor">
+            <a:schemeClr val="tx1"/>
+          </a:fontRef>
+        </p:style>
+      </p:cxnSp>
+      <p:cxnSp>
+        <p:nvCxnSpPr>
+          <p:cNvPr id="16" name="Connector 15"/>
+          <p:cNvCxnSpPr/>
+          <p:nvPr/>
+        </p:nvCxnSpPr>
+        <p:spPr>
+          <a:xfrm>
+            <a:off x="8362279" y="2240280"/>
+            <a:ext cx="0" cy="457200"/>
+          </a:xfrm>
+          <a:prstGeom prst="line">
+            <a:avLst/>
+          </a:prstGeom>
+          <a:ln w="28575">
+            <a:solidFill>
+              <a:srgbClr val="B8842A"/>
+            </a:solidFill>
+            <a:tailEnd type="triangle" w="med" len="med"/>
+          </a:ln>
+        </p:spPr>
+        <p:style>
+          <a:lnRef idx="2">
+            <a:schemeClr val="accent1"/>
+          </a:lnRef>
+          <a:fillRef idx="0">
+            <a:schemeClr val="accent1"/>
+          </a:fillRef>
+          <a:effectRef idx="1">
+            <a:schemeClr val="accent1"/>
+          </a:effectRef>
+          <a:fontRef idx="minor">
+            <a:schemeClr val="tx1"/>
+          </a:fontRef>
+        </p:style>
+      </p:cxnSp>
+      <p:sp>
+        <p:nvSpPr>
+          <p:cNvPr id="17" name="TextBox 16"/>
+          <p:cNvSpPr txBox="1"/>
+          <p:nvPr/>
+        </p:nvSpPr>
+        <p:spPr>
+          <a:xfrm>
+            <a:off x="7905079" y="1892808"/>
+            <a:ext cx="3180831" cy="274320"/>
+          </a:xfrm>
+          <a:prstGeom prst="rect">
+            <a:avLst/>
+          </a:prstGeom>
+          <a:noFill/>
+        </p:spPr>
+        <p:txBody>
+          <a:bodyPr wrap="square" anchor="t">
+            <a:spAutoFit/>
+          </a:bodyPr>
+          <a:lstStyle/>
+          <a:p>
+            <a:pPr algn="ctr"/>
+            <a:r>
+              <a:rPr sz="1100" b="1" i="0">
+                <a:solidFill>
+                  <a:srgbClr val="B8842A"/>
+                </a:solidFill>
+                <a:latin typeface="Segoe UI"/>
+              </a:rPr>
+              <a:t>✗ revise · re-cite  (≤ MAX_ROUNDS)</a:t>
+            </a:r>
+          </a:p>
+        </p:txBody>
+      </p:sp>
+      <p:sp>
+        <p:nvSpPr>
+          <p:cNvPr id="18" name="Rounded Rectangle 17"/>
           <p:cNvSpPr/>
           <p:nvPr/>
         </p:nvSpPr>
         <p:spPr>
           <a:xfrm>
-            <a:off x="4892040" y="3712463"/>
-            <a:ext cx="1920240" cy="804672"/>
+            <a:off x="2906511" y="4297680"/>
+            <a:ext cx="8645103" cy="731520"/>
           </a:xfrm>
           <a:prstGeom prst="roundRect">
             <a:avLst/>
@@ -5307,39 +5300,171 @@
           <a:p>
             <a:pPr algn="ctr"/>
             <a:r>
-              <a:rPr sz="1200" b="1" i="0">
+              <a:rPr sz="1250" b="1" i="0">
                 <a:solidFill>
                   <a:srgbClr val="B8842A"/>
                 </a:solidFill>
                 <a:latin typeface="Segoe UI"/>
               </a:rPr>
-              <a:t>H-MEM</a:t>
-            </a:r>
-          </a:p>
-          <a:p>
-            <a:pPr algn="ctr"/>
-            <a:r>
-              <a:rPr sz="850" b="0" i="0">
-                <a:solidFill>
-                  <a:srgbClr val="5B6B7A"/>
-                </a:solidFill>
-                <a:latin typeface="Segoe UI"/>
-              </a:rPr>
-              <a:t>shared evidence · provenance</a:t>
-            </a:r>
-          </a:p>
-        </p:txBody>
-      </p:sp>
-      <p:sp>
-        <p:nvSpPr>
-          <p:cNvPr id="20" name="TextBox 19"/>
+              <a:t>H-MEM — shared evidence memory  ·  source · provenance</a:t>
+            </a:r>
+          </a:p>
+        </p:txBody>
+      </p:sp>
+      <p:cxnSp>
+        <p:nvCxnSpPr>
+          <p:cNvPr id="19" name="Connector 18"/>
+          <p:cNvCxnSpPr/>
+          <p:nvPr/>
+        </p:nvCxnSpPr>
+        <p:spPr>
+          <a:xfrm>
+            <a:off x="3829415" y="3611880"/>
+            <a:ext cx="0" cy="685800"/>
+          </a:xfrm>
+          <a:prstGeom prst="line">
+            <a:avLst/>
+          </a:prstGeom>
+          <a:ln w="19050">
+            <a:solidFill>
+              <a:srgbClr val="9AA7B2"/>
+            </a:solidFill>
+            <a:tailEnd type="triangle" w="med" len="med"/>
+          </a:ln>
+        </p:spPr>
+        <p:style>
+          <a:lnRef idx="2">
+            <a:schemeClr val="accent1"/>
+          </a:lnRef>
+          <a:fillRef idx="0">
+            <a:schemeClr val="accent1"/>
+          </a:fillRef>
+          <a:effectRef idx="1">
+            <a:schemeClr val="accent1"/>
+          </a:effectRef>
+          <a:fontRef idx="minor">
+            <a:schemeClr val="tx1"/>
+          </a:fontRef>
+        </p:style>
+      </p:cxnSp>
+      <p:cxnSp>
+        <p:nvCxnSpPr>
+          <p:cNvPr id="20" name="Connector 19"/>
+          <p:cNvCxnSpPr/>
+          <p:nvPr/>
+        </p:nvCxnSpPr>
+        <p:spPr>
+          <a:xfrm>
+            <a:off x="6095847" y="3611880"/>
+            <a:ext cx="0" cy="685800"/>
+          </a:xfrm>
+          <a:prstGeom prst="line">
+            <a:avLst/>
+          </a:prstGeom>
+          <a:ln w="19050">
+            <a:solidFill>
+              <a:srgbClr val="9AA7B2"/>
+            </a:solidFill>
+            <a:tailEnd type="triangle" w="med" len="med"/>
+          </a:ln>
+        </p:spPr>
+        <p:style>
+          <a:lnRef idx="2">
+            <a:schemeClr val="accent1"/>
+          </a:lnRef>
+          <a:fillRef idx="0">
+            <a:schemeClr val="accent1"/>
+          </a:fillRef>
+          <a:effectRef idx="1">
+            <a:schemeClr val="accent1"/>
+          </a:effectRef>
+          <a:fontRef idx="minor">
+            <a:schemeClr val="tx1"/>
+          </a:fontRef>
+        </p:style>
+      </p:cxnSp>
+      <p:cxnSp>
+        <p:nvCxnSpPr>
+          <p:cNvPr id="21" name="Connector 20"/>
+          <p:cNvCxnSpPr/>
+          <p:nvPr/>
+        </p:nvCxnSpPr>
+        <p:spPr>
+          <a:xfrm flipV="1">
+            <a:off x="8362279" y="3611880"/>
+            <a:ext cx="0" cy="685800"/>
+          </a:xfrm>
+          <a:prstGeom prst="line">
+            <a:avLst/>
+          </a:prstGeom>
+          <a:ln w="19050">
+            <a:solidFill>
+              <a:srgbClr val="9AA7B2"/>
+            </a:solidFill>
+            <a:tailEnd type="triangle" w="med" len="med"/>
+          </a:ln>
+        </p:spPr>
+        <p:style>
+          <a:lnRef idx="2">
+            <a:schemeClr val="accent1"/>
+          </a:lnRef>
+          <a:fillRef idx="0">
+            <a:schemeClr val="accent1"/>
+          </a:fillRef>
+          <a:effectRef idx="1">
+            <a:schemeClr val="accent1"/>
+          </a:effectRef>
+          <a:fontRef idx="minor">
+            <a:schemeClr val="tx1"/>
+          </a:fontRef>
+        </p:style>
+      </p:cxnSp>
+      <p:cxnSp>
+        <p:nvCxnSpPr>
+          <p:cNvPr id="22" name="Connector 21"/>
+          <p:cNvCxnSpPr/>
+          <p:nvPr/>
+        </p:nvCxnSpPr>
+        <p:spPr>
+          <a:xfrm flipV="1">
+            <a:off x="10628711" y="3611880"/>
+            <a:ext cx="0" cy="685800"/>
+          </a:xfrm>
+          <a:prstGeom prst="line">
+            <a:avLst/>
+          </a:prstGeom>
+          <a:ln w="19050">
+            <a:solidFill>
+              <a:srgbClr val="9AA7B2"/>
+            </a:solidFill>
+            <a:tailEnd type="triangle" w="med" len="med"/>
+          </a:ln>
+        </p:spPr>
+        <p:style>
+          <a:lnRef idx="2">
+            <a:schemeClr val="accent1"/>
+          </a:lnRef>
+          <a:fillRef idx="0">
+            <a:schemeClr val="accent1"/>
+          </a:fillRef>
+          <a:effectRef idx="1">
+            <a:schemeClr val="accent1"/>
+          </a:effectRef>
+          <a:fontRef idx="minor">
+            <a:schemeClr val="tx1"/>
+          </a:fontRef>
+        </p:style>
+      </p:cxnSp>
+      <p:sp>
+        <p:nvSpPr>
+          <p:cNvPr id="23" name="TextBox 22"/>
           <p:cNvSpPr txBox="1"/>
           <p:nvPr/>
         </p:nvSpPr>
         <p:spPr>
           <a:xfrm>
-            <a:off x="502920" y="4892040"/>
-            <a:ext cx="2103120" cy="274320"/>
+            <a:off x="640080" y="5257800"/>
+            <a:ext cx="10881360" cy="457200"/>
           </a:xfrm>
           <a:prstGeom prst="rect">
             <a:avLst/>
@@ -5354,55 +5479,20 @@
           <a:p>
             <a:pPr algn="ctr"/>
             <a:r>
-              <a:rPr sz="1100" b="1" i="0">
-                <a:solidFill>
-                  <a:srgbClr val="B8842A"/>
-                </a:solidFill>
-                <a:latin typeface="Segoe UI"/>
-              </a:rPr>
-              <a:t>✗ revise &amp; re-cite</a:t>
-            </a:r>
-          </a:p>
-        </p:txBody>
-      </p:sp>
-      <p:sp>
-        <p:nvSpPr>
-          <p:cNvPr id="21" name="TextBox 20"/>
-          <p:cNvSpPr txBox="1"/>
-          <p:nvPr/>
-        </p:nvSpPr>
-        <p:spPr>
-          <a:xfrm>
-            <a:off x="640080" y="5989320"/>
-            <a:ext cx="10881360" cy="411480"/>
-          </a:xfrm>
-          <a:prstGeom prst="rect">
-            <a:avLst/>
-          </a:prstGeom>
-          <a:noFill/>
-        </p:spPr>
-        <p:txBody>
-          <a:bodyPr wrap="square" anchor="t">
-            <a:spAutoFit/>
-          </a:bodyPr>
-          <a:lstStyle/>
-          <a:p>
-            <a:pPr algn="ctr"/>
-            <a:r>
               <a:rPr sz="1200" b="0" i="0">
                 <a:solidFill>
                   <a:srgbClr val="5B6B7A"/>
                 </a:solidFill>
                 <a:latin typeface="Segoe UI"/>
               </a:rPr>
-              <a:t>A cycle, not a line — roles share evidence through H-MEM (gatherers write · Reporter/Evaluator read); unsupported claims loop back to revise (≤ MAX_ROUNDS).</a:t>
-            </a:r>
-          </a:p>
-        </p:txBody>
-      </p:sp>
-      <p:sp>
-        <p:nvSpPr>
-          <p:cNvPr id="22" name="Rectangle 21"/>
+              <a:t>Left to right, but not a pipeline — specialized roles share a common memory (gatherers write · consumers read), with a verify-and-revise feedback loop.</a:t>
+            </a:r>
+          </a:p>
+        </p:txBody>
+      </p:sp>
+      <p:sp>
+        <p:nvSpPr>
+          <p:cNvPr id="24" name="Rectangle 23"/>
           <p:cNvSpPr/>
           <p:nvPr/>
         </p:nvSpPr>
@@ -5446,7 +5536,7 @@
       </p:sp>
       <p:sp>
         <p:nvSpPr>
-          <p:cNvPr id="23" name="TextBox 22"/>
+          <p:cNvPr id="25" name="TextBox 24"/>
           <p:cNvSpPr txBox="1"/>
           <p:nvPr/>
         </p:nvSpPr>

</xml_diff>

<commit_message>
Slide 5 as parallel gather lanes + re-record sample on the parallel run
- build_deck.py: redraw Slide 5 — Planner fans out into parallel gatherer lanes
  (Analyst sub-questions + cross_source), shown in a dashed group, converging
  into the shared H-MEM hub, then Reporter -> Evaluator with the feedback loop.
  Matches the orchestrator's parallel fan-out. (Fixed a bad pptx.enum.line
  import; the dashed group is drawn via a prstDash XML element.)
- data/sample_run.json: re-recorded live on the parallel version (meterless x26,
  overclaim + scoped negatives all rejected). Eval sample scorecard still 8/8.
- deck/assets/ui_*.png: re-captured so the Slide 4 hero reflects the new run.

Co-Authored-By: Claude Opus 4.8 (1M context) <noreply@anthropic.com>
</commit_message>
<xml_diff>
--- a/deck/Evidence-Intelligence-Agent.pptx
+++ b/deck/Evidence-Intelligence-Agent.pptx
@@ -4378,7 +4378,7 @@
         <p:spPr>
           <a:xfrm>
             <a:off x="6446520" y="2011680"/>
-            <a:ext cx="3384331" cy="4160520"/>
+            <a:ext cx="3954213" cy="4160520"/>
           </a:xfrm>
           <a:prstGeom prst="rect">
             <a:avLst/>
@@ -4614,19 +4614,20 @@
         </p:nvSpPr>
         <p:spPr>
           <a:xfrm>
-            <a:off x="640080" y="2697480"/>
-            <a:ext cx="1845807" cy="914400"/>
+            <a:off x="2011680" y="2176272"/>
+            <a:ext cx="2743200" cy="2596896"/>
           </a:xfrm>
           <a:prstGeom prst="roundRect">
             <a:avLst/>
           </a:prstGeom>
           <a:solidFill>
-            <a:srgbClr val="FFFFFF"/>
+            <a:srgbClr val="F6F9FB"/>
           </a:solidFill>
-          <a:ln w="19050">
+          <a:ln>
             <a:solidFill>
-              <a:srgbClr val="128A98"/>
+              <a:srgbClr val="BFCFD8"/>
             </a:solidFill>
+            <a:prstDash val="dash"/>
           </a:ln>
           <a:effectLst/>
         </p:spPr>
@@ -4645,44 +4646,275 @@
           </a:fontRef>
         </p:style>
         <p:txBody>
-          <a:bodyPr rtlCol="0" anchor="ctr" wrap="square"/>
+          <a:bodyPr rtlCol="0" anchor="ctr"/>
           <a:lstStyle/>
           <a:p>
             <a:pPr algn="ctr"/>
-            <a:r>
-              <a:rPr sz="1350" b="1" i="0">
-                <a:solidFill>
-                  <a:srgbClr val="14202B"/>
-                </a:solidFill>
-                <a:latin typeface="Segoe UI"/>
-              </a:rPr>
-              <a:t>Planner</a:t>
-            </a:r>
-          </a:p>
-          <a:p>
-            <a:pPr algn="ctr"/>
-            <a:r>
-              <a:rPr sz="900" b="0" i="0">
-                <a:solidFill>
-                  <a:srgbClr val="5B6B7A"/>
-                </a:solidFill>
-                <a:latin typeface="Segoe UI"/>
-              </a:rPr>
-              <a:t>decompose</a:t>
-            </a:r>
-          </a:p>
-        </p:txBody>
-      </p:sp>
-      <p:sp>
-        <p:nvSpPr>
-          <p:cNvPr id="6" name="Right Arrow 5"/>
+          </a:p>
+        </p:txBody>
+      </p:sp>
+      <p:cxnSp>
+        <p:nvCxnSpPr>
+          <p:cNvPr id="6" name="Connector 5"/>
+          <p:cNvCxnSpPr/>
+          <p:nvPr/>
+        </p:nvCxnSpPr>
+        <p:spPr>
+          <a:xfrm flipV="1">
+            <a:off x="1943100" y="2651760"/>
+            <a:ext cx="251460" cy="822960"/>
+          </a:xfrm>
+          <a:prstGeom prst="line">
+            <a:avLst/>
+          </a:prstGeom>
+          <a:ln w="22225">
+            <a:solidFill>
+              <a:srgbClr val="128A98"/>
+            </a:solidFill>
+            <a:tailEnd type="triangle" w="med" len="med"/>
+          </a:ln>
+        </p:spPr>
+        <p:style>
+          <a:lnRef idx="2">
+            <a:schemeClr val="accent1"/>
+          </a:lnRef>
+          <a:fillRef idx="0">
+            <a:schemeClr val="accent1"/>
+          </a:fillRef>
+          <a:effectRef idx="1">
+            <a:schemeClr val="accent1"/>
+          </a:effectRef>
+          <a:fontRef idx="minor">
+            <a:schemeClr val="tx1"/>
+          </a:fontRef>
+        </p:style>
+      </p:cxnSp>
+      <p:cxnSp>
+        <p:nvCxnSpPr>
+          <p:cNvPr id="7" name="Connector 6"/>
+          <p:cNvCxnSpPr/>
+          <p:nvPr/>
+        </p:nvCxnSpPr>
+        <p:spPr>
+          <a:xfrm>
+            <a:off x="1943100" y="3474720"/>
+            <a:ext cx="251460" cy="0"/>
+          </a:xfrm>
+          <a:prstGeom prst="line">
+            <a:avLst/>
+          </a:prstGeom>
+          <a:ln w="22225">
+            <a:solidFill>
+              <a:srgbClr val="128A98"/>
+            </a:solidFill>
+            <a:tailEnd type="triangle" w="med" len="med"/>
+          </a:ln>
+        </p:spPr>
+        <p:style>
+          <a:lnRef idx="2">
+            <a:schemeClr val="accent1"/>
+          </a:lnRef>
+          <a:fillRef idx="0">
+            <a:schemeClr val="accent1"/>
+          </a:fillRef>
+          <a:effectRef idx="1">
+            <a:schemeClr val="accent1"/>
+          </a:effectRef>
+          <a:fontRef idx="minor">
+            <a:schemeClr val="tx1"/>
+          </a:fontRef>
+        </p:style>
+      </p:cxnSp>
+      <p:cxnSp>
+        <p:nvCxnSpPr>
+          <p:cNvPr id="8" name="Connector 7"/>
+          <p:cNvCxnSpPr/>
+          <p:nvPr/>
+        </p:nvCxnSpPr>
+        <p:spPr>
+          <a:xfrm>
+            <a:off x="1943100" y="3474720"/>
+            <a:ext cx="251460" cy="822960"/>
+          </a:xfrm>
+          <a:prstGeom prst="line">
+            <a:avLst/>
+          </a:prstGeom>
+          <a:ln w="22225">
+            <a:solidFill>
+              <a:srgbClr val="128A98"/>
+            </a:solidFill>
+            <a:tailEnd type="triangle" w="med" len="med"/>
+          </a:ln>
+        </p:spPr>
+        <p:style>
+          <a:lnRef idx="2">
+            <a:schemeClr val="accent1"/>
+          </a:lnRef>
+          <a:fillRef idx="0">
+            <a:schemeClr val="accent1"/>
+          </a:fillRef>
+          <a:effectRef idx="1">
+            <a:schemeClr val="accent1"/>
+          </a:effectRef>
+          <a:fontRef idx="minor">
+            <a:schemeClr val="tx1"/>
+          </a:fontRef>
+        </p:style>
+      </p:cxnSp>
+      <p:cxnSp>
+        <p:nvCxnSpPr>
+          <p:cNvPr id="9" name="Connector 8"/>
+          <p:cNvCxnSpPr/>
+          <p:nvPr/>
+        </p:nvCxnSpPr>
+        <p:spPr>
+          <a:xfrm>
+            <a:off x="4572000" y="2651760"/>
+            <a:ext cx="914400" cy="822960"/>
+          </a:xfrm>
+          <a:prstGeom prst="line">
+            <a:avLst/>
+          </a:prstGeom>
+          <a:ln w="22225">
+            <a:solidFill>
+              <a:srgbClr val="128A98"/>
+            </a:solidFill>
+            <a:tailEnd type="triangle" w="med" len="med"/>
+          </a:ln>
+        </p:spPr>
+        <p:style>
+          <a:lnRef idx="2">
+            <a:schemeClr val="accent1"/>
+          </a:lnRef>
+          <a:fillRef idx="0">
+            <a:schemeClr val="accent1"/>
+          </a:fillRef>
+          <a:effectRef idx="1">
+            <a:schemeClr val="accent1"/>
+          </a:effectRef>
+          <a:fontRef idx="minor">
+            <a:schemeClr val="tx1"/>
+          </a:fontRef>
+        </p:style>
+      </p:cxnSp>
+      <p:cxnSp>
+        <p:nvCxnSpPr>
+          <p:cNvPr id="10" name="Connector 9"/>
+          <p:cNvCxnSpPr/>
+          <p:nvPr/>
+        </p:nvCxnSpPr>
+        <p:spPr>
+          <a:xfrm>
+            <a:off x="4572000" y="3474720"/>
+            <a:ext cx="914400" cy="0"/>
+          </a:xfrm>
+          <a:prstGeom prst="line">
+            <a:avLst/>
+          </a:prstGeom>
+          <a:ln w="22225">
+            <a:solidFill>
+              <a:srgbClr val="128A98"/>
+            </a:solidFill>
+            <a:tailEnd type="triangle" w="med" len="med"/>
+          </a:ln>
+        </p:spPr>
+        <p:style>
+          <a:lnRef idx="2">
+            <a:schemeClr val="accent1"/>
+          </a:lnRef>
+          <a:fillRef idx="0">
+            <a:schemeClr val="accent1"/>
+          </a:fillRef>
+          <a:effectRef idx="1">
+            <a:schemeClr val="accent1"/>
+          </a:effectRef>
+          <a:fontRef idx="minor">
+            <a:schemeClr val="tx1"/>
+          </a:fontRef>
+        </p:style>
+      </p:cxnSp>
+      <p:cxnSp>
+        <p:nvCxnSpPr>
+          <p:cNvPr id="11" name="Connector 10"/>
+          <p:cNvCxnSpPr/>
+          <p:nvPr/>
+        </p:nvCxnSpPr>
+        <p:spPr>
+          <a:xfrm flipV="1">
+            <a:off x="4572000" y="3474720"/>
+            <a:ext cx="914400" cy="822960"/>
+          </a:xfrm>
+          <a:prstGeom prst="line">
+            <a:avLst/>
+          </a:prstGeom>
+          <a:ln w="22225">
+            <a:solidFill>
+              <a:srgbClr val="128A98"/>
+            </a:solidFill>
+            <a:tailEnd type="triangle" w="med" len="med"/>
+          </a:ln>
+        </p:spPr>
+        <p:style>
+          <a:lnRef idx="2">
+            <a:schemeClr val="accent1"/>
+          </a:lnRef>
+          <a:fillRef idx="0">
+            <a:schemeClr val="accent1"/>
+          </a:fillRef>
+          <a:effectRef idx="1">
+            <a:schemeClr val="accent1"/>
+          </a:effectRef>
+          <a:fontRef idx="minor">
+            <a:schemeClr val="tx1"/>
+          </a:fontRef>
+        </p:style>
+      </p:cxnSp>
+      <p:cxnSp>
+        <p:nvCxnSpPr>
+          <p:cNvPr id="12" name="Connector 11"/>
+          <p:cNvCxnSpPr/>
+          <p:nvPr/>
+        </p:nvCxnSpPr>
+        <p:spPr>
+          <a:xfrm>
+            <a:off x="6949440" y="3474720"/>
+            <a:ext cx="525780" cy="0"/>
+          </a:xfrm>
+          <a:prstGeom prst="line">
+            <a:avLst/>
+          </a:prstGeom>
+          <a:ln w="25400">
+            <a:solidFill>
+              <a:srgbClr val="128A98"/>
+            </a:solidFill>
+            <a:tailEnd type="triangle" w="med" len="med"/>
+          </a:ln>
+        </p:spPr>
+        <p:style>
+          <a:lnRef idx="2">
+            <a:schemeClr val="accent1"/>
+          </a:lnRef>
+          <a:fillRef idx="0">
+            <a:schemeClr val="accent1"/>
+          </a:fillRef>
+          <a:effectRef idx="1">
+            <a:schemeClr val="accent1"/>
+          </a:effectRef>
+          <a:fontRef idx="minor">
+            <a:schemeClr val="tx1"/>
+          </a:fontRef>
+        </p:style>
+      </p:cxnSp>
+      <p:sp>
+        <p:nvSpPr>
+          <p:cNvPr id="13" name="Right Arrow 12"/>
           <p:cNvSpPr/>
           <p:nvPr/>
         </p:nvSpPr>
         <p:spPr>
           <a:xfrm>
-            <a:off x="2531607" y="3063240"/>
-            <a:ext cx="329184" cy="182880"/>
+            <a:off x="9011411" y="3383279"/>
+            <a:ext cx="356616" cy="182880"/>
           </a:xfrm>
           <a:prstGeom prst="rightArrow">
             <a:avLst/>
@@ -4717,404 +4949,6 @@
           </a:p>
         </p:txBody>
       </p:sp>
-      <p:sp>
-        <p:nvSpPr>
-          <p:cNvPr id="7" name="Rounded Rectangle 6"/>
-          <p:cNvSpPr/>
-          <p:nvPr/>
-        </p:nvSpPr>
-        <p:spPr>
-          <a:xfrm>
-            <a:off x="2906511" y="2697480"/>
-            <a:ext cx="1845807" cy="914400"/>
-          </a:xfrm>
-          <a:prstGeom prst="roundRect">
-            <a:avLst/>
-          </a:prstGeom>
-          <a:solidFill>
-            <a:srgbClr val="FFFFFF"/>
-          </a:solidFill>
-          <a:ln w="19050">
-            <a:solidFill>
-              <a:srgbClr val="128A98"/>
-            </a:solidFill>
-          </a:ln>
-          <a:effectLst/>
-        </p:spPr>
-        <p:style>
-          <a:lnRef idx="1">
-            <a:schemeClr val="accent1"/>
-          </a:lnRef>
-          <a:fillRef idx="3">
-            <a:schemeClr val="accent1"/>
-          </a:fillRef>
-          <a:effectRef idx="2">
-            <a:schemeClr val="accent1"/>
-          </a:effectRef>
-          <a:fontRef idx="minor">
-            <a:schemeClr val="lt1"/>
-          </a:fontRef>
-        </p:style>
-        <p:txBody>
-          <a:bodyPr rtlCol="0" anchor="ctr" wrap="square"/>
-          <a:lstStyle/>
-          <a:p>
-            <a:pPr algn="ctr"/>
-            <a:r>
-              <a:rPr sz="1350" b="1" i="0">
-                <a:solidFill>
-                  <a:srgbClr val="14202B"/>
-                </a:solidFill>
-                <a:latin typeface="Segoe UI"/>
-              </a:rPr>
-              <a:t>Analyst</a:t>
-            </a:r>
-          </a:p>
-          <a:p>
-            <a:pPr algn="ctr"/>
-            <a:r>
-              <a:rPr sz="900" b="0" i="0">
-                <a:solidFill>
-                  <a:srgbClr val="5B6B7A"/>
-                </a:solidFill>
-                <a:latin typeface="Segoe UI"/>
-              </a:rPr>
-              <a:t>SQL → evidence</a:t>
-            </a:r>
-          </a:p>
-        </p:txBody>
-      </p:sp>
-      <p:sp>
-        <p:nvSpPr>
-          <p:cNvPr id="8" name="Right Arrow 7"/>
-          <p:cNvSpPr/>
-          <p:nvPr/>
-        </p:nvSpPr>
-        <p:spPr>
-          <a:xfrm>
-            <a:off x="4798039" y="3063240"/>
-            <a:ext cx="329184" cy="182880"/>
-          </a:xfrm>
-          <a:prstGeom prst="rightArrow">
-            <a:avLst/>
-          </a:prstGeom>
-          <a:solidFill>
-            <a:srgbClr val="128A98"/>
-          </a:solidFill>
-          <a:ln>
-            <a:noFill/>
-          </a:ln>
-          <a:effectLst/>
-        </p:spPr>
-        <p:style>
-          <a:lnRef idx="1">
-            <a:schemeClr val="accent1"/>
-          </a:lnRef>
-          <a:fillRef idx="3">
-            <a:schemeClr val="accent1"/>
-          </a:fillRef>
-          <a:effectRef idx="2">
-            <a:schemeClr val="accent1"/>
-          </a:effectRef>
-          <a:fontRef idx="minor">
-            <a:schemeClr val="lt1"/>
-          </a:fontRef>
-        </p:style>
-        <p:txBody>
-          <a:bodyPr rtlCol="0" anchor="ctr"/>
-          <a:lstStyle/>
-          <a:p>
-            <a:pPr algn="ctr"/>
-          </a:p>
-        </p:txBody>
-      </p:sp>
-      <p:sp>
-        <p:nvSpPr>
-          <p:cNvPr id="9" name="Rounded Rectangle 8"/>
-          <p:cNvSpPr/>
-          <p:nvPr/>
-        </p:nvSpPr>
-        <p:spPr>
-          <a:xfrm>
-            <a:off x="5172943" y="2697480"/>
-            <a:ext cx="1845807" cy="914400"/>
-          </a:xfrm>
-          <a:prstGeom prst="roundRect">
-            <a:avLst/>
-          </a:prstGeom>
-          <a:solidFill>
-            <a:srgbClr val="FFFFFF"/>
-          </a:solidFill>
-          <a:ln w="19050">
-            <a:solidFill>
-              <a:srgbClr val="128A98"/>
-            </a:solidFill>
-          </a:ln>
-          <a:effectLst/>
-        </p:spPr>
-        <p:style>
-          <a:lnRef idx="1">
-            <a:schemeClr val="accent1"/>
-          </a:lnRef>
-          <a:fillRef idx="3">
-            <a:schemeClr val="accent1"/>
-          </a:fillRef>
-          <a:effectRef idx="2">
-            <a:schemeClr val="accent1"/>
-          </a:effectRef>
-          <a:fontRef idx="minor">
-            <a:schemeClr val="lt1"/>
-          </a:fontRef>
-        </p:style>
-        <p:txBody>
-          <a:bodyPr rtlCol="0" anchor="ctr" wrap="square"/>
-          <a:lstStyle/>
-          <a:p>
-            <a:pPr algn="ctr"/>
-            <a:r>
-              <a:rPr sz="1350" b="1" i="0">
-                <a:solidFill>
-                  <a:srgbClr val="14202B"/>
-                </a:solidFill>
-                <a:latin typeface="Segoe UI"/>
-              </a:rPr>
-              <a:t>cross_source</a:t>
-            </a:r>
-          </a:p>
-          <a:p>
-            <a:pPr algn="ctr"/>
-            <a:r>
-              <a:rPr sz="900" b="0" i="0">
-                <a:solidFill>
-                  <a:srgbClr val="5B6B7A"/>
-                </a:solidFill>
-                <a:latin typeface="Segoe UI"/>
-              </a:rPr>
-              <a:t>trialed × cleared</a:t>
-            </a:r>
-          </a:p>
-        </p:txBody>
-      </p:sp>
-      <p:sp>
-        <p:nvSpPr>
-          <p:cNvPr id="10" name="Right Arrow 9"/>
-          <p:cNvSpPr/>
-          <p:nvPr/>
-        </p:nvSpPr>
-        <p:spPr>
-          <a:xfrm>
-            <a:off x="7064471" y="3063240"/>
-            <a:ext cx="329184" cy="182880"/>
-          </a:xfrm>
-          <a:prstGeom prst="rightArrow">
-            <a:avLst/>
-          </a:prstGeom>
-          <a:solidFill>
-            <a:srgbClr val="128A98"/>
-          </a:solidFill>
-          <a:ln>
-            <a:noFill/>
-          </a:ln>
-          <a:effectLst/>
-        </p:spPr>
-        <p:style>
-          <a:lnRef idx="1">
-            <a:schemeClr val="accent1"/>
-          </a:lnRef>
-          <a:fillRef idx="3">
-            <a:schemeClr val="accent1"/>
-          </a:fillRef>
-          <a:effectRef idx="2">
-            <a:schemeClr val="accent1"/>
-          </a:effectRef>
-          <a:fontRef idx="minor">
-            <a:schemeClr val="lt1"/>
-          </a:fontRef>
-        </p:style>
-        <p:txBody>
-          <a:bodyPr rtlCol="0" anchor="ctr"/>
-          <a:lstStyle/>
-          <a:p>
-            <a:pPr algn="ctr"/>
-          </a:p>
-        </p:txBody>
-      </p:sp>
-      <p:sp>
-        <p:nvSpPr>
-          <p:cNvPr id="11" name="Rounded Rectangle 10"/>
-          <p:cNvSpPr/>
-          <p:nvPr/>
-        </p:nvSpPr>
-        <p:spPr>
-          <a:xfrm>
-            <a:off x="7439375" y="2697480"/>
-            <a:ext cx="1845807" cy="914400"/>
-          </a:xfrm>
-          <a:prstGeom prst="roundRect">
-            <a:avLst/>
-          </a:prstGeom>
-          <a:solidFill>
-            <a:srgbClr val="FFFFFF"/>
-          </a:solidFill>
-          <a:ln w="19050">
-            <a:solidFill>
-              <a:srgbClr val="128A98"/>
-            </a:solidFill>
-          </a:ln>
-          <a:effectLst/>
-        </p:spPr>
-        <p:style>
-          <a:lnRef idx="1">
-            <a:schemeClr val="accent1"/>
-          </a:lnRef>
-          <a:fillRef idx="3">
-            <a:schemeClr val="accent1"/>
-          </a:fillRef>
-          <a:effectRef idx="2">
-            <a:schemeClr val="accent1"/>
-          </a:effectRef>
-          <a:fontRef idx="minor">
-            <a:schemeClr val="lt1"/>
-          </a:fontRef>
-        </p:style>
-        <p:txBody>
-          <a:bodyPr rtlCol="0" anchor="ctr" wrap="square"/>
-          <a:lstStyle/>
-          <a:p>
-            <a:pPr algn="ctr"/>
-            <a:r>
-              <a:rPr sz="1350" b="1" i="0">
-                <a:solidFill>
-                  <a:srgbClr val="14202B"/>
-                </a:solidFill>
-                <a:latin typeface="Segoe UI"/>
-              </a:rPr>
-              <a:t>Reporter</a:t>
-            </a:r>
-          </a:p>
-          <a:p>
-            <a:pPr algn="ctr"/>
-            <a:r>
-              <a:rPr sz="900" b="0" i="0">
-                <a:solidFill>
-                  <a:srgbClr val="5B6B7A"/>
-                </a:solidFill>
-                <a:latin typeface="Segoe UI"/>
-              </a:rPr>
-              <a:t>cite claims</a:t>
-            </a:r>
-          </a:p>
-        </p:txBody>
-      </p:sp>
-      <p:sp>
-        <p:nvSpPr>
-          <p:cNvPr id="12" name="Right Arrow 11"/>
-          <p:cNvSpPr/>
-          <p:nvPr/>
-        </p:nvSpPr>
-        <p:spPr>
-          <a:xfrm>
-            <a:off x="9330903" y="3063240"/>
-            <a:ext cx="329184" cy="182880"/>
-          </a:xfrm>
-          <a:prstGeom prst="rightArrow">
-            <a:avLst/>
-          </a:prstGeom>
-          <a:solidFill>
-            <a:srgbClr val="128A98"/>
-          </a:solidFill>
-          <a:ln>
-            <a:noFill/>
-          </a:ln>
-          <a:effectLst/>
-        </p:spPr>
-        <p:style>
-          <a:lnRef idx="1">
-            <a:schemeClr val="accent1"/>
-          </a:lnRef>
-          <a:fillRef idx="3">
-            <a:schemeClr val="accent1"/>
-          </a:fillRef>
-          <a:effectRef idx="2">
-            <a:schemeClr val="accent1"/>
-          </a:effectRef>
-          <a:fontRef idx="minor">
-            <a:schemeClr val="lt1"/>
-          </a:fontRef>
-        </p:style>
-        <p:txBody>
-          <a:bodyPr rtlCol="0" anchor="ctr"/>
-          <a:lstStyle/>
-          <a:p>
-            <a:pPr algn="ctr"/>
-          </a:p>
-        </p:txBody>
-      </p:sp>
-      <p:sp>
-        <p:nvSpPr>
-          <p:cNvPr id="13" name="Rounded Rectangle 12"/>
-          <p:cNvSpPr/>
-          <p:nvPr/>
-        </p:nvSpPr>
-        <p:spPr>
-          <a:xfrm>
-            <a:off x="9705807" y="2697480"/>
-            <a:ext cx="1845807" cy="914400"/>
-          </a:xfrm>
-          <a:prstGeom prst="roundRect">
-            <a:avLst/>
-          </a:prstGeom>
-          <a:solidFill>
-            <a:srgbClr val="128A98"/>
-          </a:solidFill>
-          <a:ln>
-            <a:noFill/>
-          </a:ln>
-          <a:effectLst/>
-        </p:spPr>
-        <p:style>
-          <a:lnRef idx="1">
-            <a:schemeClr val="accent1"/>
-          </a:lnRef>
-          <a:fillRef idx="3">
-            <a:schemeClr val="accent1"/>
-          </a:fillRef>
-          <a:effectRef idx="2">
-            <a:schemeClr val="accent1"/>
-          </a:effectRef>
-          <a:fontRef idx="minor">
-            <a:schemeClr val="lt1"/>
-          </a:fontRef>
-        </p:style>
-        <p:txBody>
-          <a:bodyPr rtlCol="0" anchor="ctr" wrap="square"/>
-          <a:lstStyle/>
-          <a:p>
-            <a:pPr algn="ctr"/>
-            <a:r>
-              <a:rPr sz="1350" b="1" i="0">
-                <a:solidFill>
-                  <a:srgbClr val="FFFFFF"/>
-                </a:solidFill>
-                <a:latin typeface="Segoe UI"/>
-              </a:rPr>
-              <a:t>Evaluator</a:t>
-            </a:r>
-          </a:p>
-          <a:p>
-            <a:pPr algn="ctr"/>
-            <a:r>
-              <a:rPr sz="900" b="0" i="0">
-                <a:solidFill>
-                  <a:srgbClr val="DDF0F2"/>
-                </a:solidFill>
-                <a:latin typeface="Segoe UI"/>
-              </a:rPr>
-              <a:t>verify / reject</a:t>
-            </a:r>
-          </a:p>
-        </p:txBody>
-      </p:sp>
       <p:cxnSp>
         <p:nvCxnSpPr>
           <p:cNvPr id="14" name="Connector 13"/>
@@ -5123,8 +4957,8 @@
         </p:nvCxnSpPr>
         <p:spPr>
           <a:xfrm flipV="1">
-            <a:off x="10628711" y="2240280"/>
-            <a:ext cx="0" cy="457200"/>
+            <a:off x="10149840" y="2628899"/>
+            <a:ext cx="0" cy="411480"/>
           </a:xfrm>
           <a:prstGeom prst="line">
             <a:avLst/>
@@ -5158,8 +4992,8 @@
         </p:nvCxnSpPr>
         <p:spPr>
           <a:xfrm flipH="1">
-            <a:off x="8362279" y="2240280"/>
-            <a:ext cx="2266432" cy="0"/>
+            <a:off x="8229600" y="2628899"/>
+            <a:ext cx="1920240" cy="0"/>
           </a:xfrm>
           <a:prstGeom prst="line">
             <a:avLst/>
@@ -5193,8 +5027,8 @@
         </p:nvCxnSpPr>
         <p:spPr>
           <a:xfrm>
-            <a:off x="8362279" y="2240280"/>
-            <a:ext cx="0" cy="457200"/>
+            <a:off x="8229600" y="2628899"/>
+            <a:ext cx="0" cy="411480"/>
           </a:xfrm>
           <a:prstGeom prst="line">
             <a:avLst/>
@@ -5223,35 +5057,67 @@
       </p:cxnSp>
       <p:sp>
         <p:nvSpPr>
-          <p:cNvPr id="17" name="TextBox 16"/>
-          <p:cNvSpPr txBox="1"/>
-          <p:nvPr/>
-        </p:nvSpPr>
-        <p:spPr>
-          <a:xfrm>
-            <a:off x="7905079" y="1892808"/>
-            <a:ext cx="3180831" cy="274320"/>
-          </a:xfrm>
-          <a:prstGeom prst="rect">
-            <a:avLst/>
-          </a:prstGeom>
-          <a:noFill/>
-        </p:spPr>
-        <p:txBody>
-          <a:bodyPr wrap="square" anchor="t">
-            <a:spAutoFit/>
-          </a:bodyPr>
+          <p:cNvPr id="17" name="Rounded Rectangle 16"/>
+          <p:cNvSpPr/>
+          <p:nvPr/>
+        </p:nvSpPr>
+        <p:spPr>
+          <a:xfrm>
+            <a:off x="434340" y="3040379"/>
+            <a:ext cx="1508760" cy="868680"/>
+          </a:xfrm>
+          <a:prstGeom prst="roundRect">
+            <a:avLst/>
+          </a:prstGeom>
+          <a:solidFill>
+            <a:srgbClr val="FFFFFF"/>
+          </a:solidFill>
+          <a:ln w="19050">
+            <a:solidFill>
+              <a:srgbClr val="128A98"/>
+            </a:solidFill>
+          </a:ln>
+          <a:effectLst/>
+        </p:spPr>
+        <p:style>
+          <a:lnRef idx="1">
+            <a:schemeClr val="accent1"/>
+          </a:lnRef>
+          <a:fillRef idx="3">
+            <a:schemeClr val="accent1"/>
+          </a:fillRef>
+          <a:effectRef idx="2">
+            <a:schemeClr val="accent1"/>
+          </a:effectRef>
+          <a:fontRef idx="minor">
+            <a:schemeClr val="lt1"/>
+          </a:fontRef>
+        </p:style>
+        <p:txBody>
+          <a:bodyPr rtlCol="0" anchor="ctr" wrap="square"/>
           <a:lstStyle/>
           <a:p>
             <a:pPr algn="ctr"/>
             <a:r>
-              <a:rPr sz="1100" b="1" i="0">
-                <a:solidFill>
-                  <a:srgbClr val="B8842A"/>
-                </a:solidFill>
-                <a:latin typeface="Segoe UI"/>
-              </a:rPr>
-              <a:t>✗ revise · re-cite  (≤ MAX_ROUNDS)</a:t>
+              <a:rPr sz="1300" b="1" i="0">
+                <a:solidFill>
+                  <a:srgbClr val="14202B"/>
+                </a:solidFill>
+                <a:latin typeface="Segoe UI"/>
+              </a:rPr>
+              <a:t>Planner</a:t>
+            </a:r>
+          </a:p>
+          <a:p>
+            <a:pPr algn="ctr"/>
+            <a:r>
+              <a:rPr sz="900" b="0" i="0">
+                <a:solidFill>
+                  <a:srgbClr val="5B6B7A"/>
+                </a:solidFill>
+                <a:latin typeface="Segoe UI"/>
+              </a:rPr>
+              <a:t>decompose</a:t>
             </a:r>
           </a:p>
         </p:txBody>
@@ -5264,8 +5130,209 @@
         </p:nvSpPr>
         <p:spPr>
           <a:xfrm>
-            <a:off x="2906511" y="4297680"/>
-            <a:ext cx="8645103" cy="731520"/>
+            <a:off x="2194560" y="2322576"/>
+            <a:ext cx="2377440" cy="658368"/>
+          </a:xfrm>
+          <a:prstGeom prst="roundRect">
+            <a:avLst/>
+          </a:prstGeom>
+          <a:solidFill>
+            <a:srgbClr val="FFFFFF"/>
+          </a:solidFill>
+          <a:ln w="19050">
+            <a:solidFill>
+              <a:srgbClr val="128A98"/>
+            </a:solidFill>
+          </a:ln>
+          <a:effectLst/>
+        </p:spPr>
+        <p:style>
+          <a:lnRef idx="1">
+            <a:schemeClr val="accent1"/>
+          </a:lnRef>
+          <a:fillRef idx="3">
+            <a:schemeClr val="accent1"/>
+          </a:fillRef>
+          <a:effectRef idx="2">
+            <a:schemeClr val="accent1"/>
+          </a:effectRef>
+          <a:fontRef idx="minor">
+            <a:schemeClr val="lt1"/>
+          </a:fontRef>
+        </p:style>
+        <p:txBody>
+          <a:bodyPr rtlCol="0" anchor="ctr" wrap="square"/>
+          <a:lstStyle/>
+          <a:p>
+            <a:pPr algn="ctr"/>
+            <a:r>
+              <a:rPr sz="1250" b="1" i="0">
+                <a:solidFill>
+                  <a:srgbClr val="14202B"/>
+                </a:solidFill>
+                <a:latin typeface="Segoe UI"/>
+              </a:rPr>
+              <a:t>Analyst</a:t>
+            </a:r>
+          </a:p>
+          <a:p>
+            <a:pPr algn="ctr"/>
+            <a:r>
+              <a:rPr sz="850" b="0" i="0">
+                <a:solidFill>
+                  <a:srgbClr val="5B6B7A"/>
+                </a:solidFill>
+                <a:latin typeface="Segoe UI"/>
+              </a:rPr>
+              <a:t>sub-question</a:t>
+            </a:r>
+          </a:p>
+        </p:txBody>
+      </p:sp>
+      <p:sp>
+        <p:nvSpPr>
+          <p:cNvPr id="19" name="Rounded Rectangle 18"/>
+          <p:cNvSpPr/>
+          <p:nvPr/>
+        </p:nvSpPr>
+        <p:spPr>
+          <a:xfrm>
+            <a:off x="2194560" y="3145536"/>
+            <a:ext cx="2377440" cy="658368"/>
+          </a:xfrm>
+          <a:prstGeom prst="roundRect">
+            <a:avLst/>
+          </a:prstGeom>
+          <a:solidFill>
+            <a:srgbClr val="FFFFFF"/>
+          </a:solidFill>
+          <a:ln w="19050">
+            <a:solidFill>
+              <a:srgbClr val="128A98"/>
+            </a:solidFill>
+          </a:ln>
+          <a:effectLst/>
+        </p:spPr>
+        <p:style>
+          <a:lnRef idx="1">
+            <a:schemeClr val="accent1"/>
+          </a:lnRef>
+          <a:fillRef idx="3">
+            <a:schemeClr val="accent1"/>
+          </a:fillRef>
+          <a:effectRef idx="2">
+            <a:schemeClr val="accent1"/>
+          </a:effectRef>
+          <a:fontRef idx="minor">
+            <a:schemeClr val="lt1"/>
+          </a:fontRef>
+        </p:style>
+        <p:txBody>
+          <a:bodyPr rtlCol="0" anchor="ctr" wrap="square"/>
+          <a:lstStyle/>
+          <a:p>
+            <a:pPr algn="ctr"/>
+            <a:r>
+              <a:rPr sz="1250" b="1" i="0">
+                <a:solidFill>
+                  <a:srgbClr val="14202B"/>
+                </a:solidFill>
+                <a:latin typeface="Segoe UI"/>
+              </a:rPr>
+              <a:t>Analyst</a:t>
+            </a:r>
+          </a:p>
+          <a:p>
+            <a:pPr algn="ctr"/>
+            <a:r>
+              <a:rPr sz="850" b="0" i="0">
+                <a:solidFill>
+                  <a:srgbClr val="5B6B7A"/>
+                </a:solidFill>
+                <a:latin typeface="Segoe UI"/>
+              </a:rPr>
+              <a:t>sub-question</a:t>
+            </a:r>
+          </a:p>
+        </p:txBody>
+      </p:sp>
+      <p:sp>
+        <p:nvSpPr>
+          <p:cNvPr id="20" name="Rounded Rectangle 19"/>
+          <p:cNvSpPr/>
+          <p:nvPr/>
+        </p:nvSpPr>
+        <p:spPr>
+          <a:xfrm>
+            <a:off x="2194560" y="3968496"/>
+            <a:ext cx="2377440" cy="658368"/>
+          </a:xfrm>
+          <a:prstGeom prst="roundRect">
+            <a:avLst/>
+          </a:prstGeom>
+          <a:solidFill>
+            <a:srgbClr val="FFFFFF"/>
+          </a:solidFill>
+          <a:ln w="19050">
+            <a:solidFill>
+              <a:srgbClr val="128A98"/>
+            </a:solidFill>
+          </a:ln>
+          <a:effectLst/>
+        </p:spPr>
+        <p:style>
+          <a:lnRef idx="1">
+            <a:schemeClr val="accent1"/>
+          </a:lnRef>
+          <a:fillRef idx="3">
+            <a:schemeClr val="accent1"/>
+          </a:fillRef>
+          <a:effectRef idx="2">
+            <a:schemeClr val="accent1"/>
+          </a:effectRef>
+          <a:fontRef idx="minor">
+            <a:schemeClr val="lt1"/>
+          </a:fontRef>
+        </p:style>
+        <p:txBody>
+          <a:bodyPr rtlCol="0" anchor="ctr" wrap="square"/>
+          <a:lstStyle/>
+          <a:p>
+            <a:pPr algn="ctr"/>
+            <a:r>
+              <a:rPr sz="1250" b="1" i="0">
+                <a:solidFill>
+                  <a:srgbClr val="14202B"/>
+                </a:solidFill>
+                <a:latin typeface="Segoe UI"/>
+              </a:rPr>
+              <a:t>cross_source</a:t>
+            </a:r>
+          </a:p>
+          <a:p>
+            <a:pPr algn="ctr"/>
+            <a:r>
+              <a:rPr sz="850" b="0" i="0">
+                <a:solidFill>
+                  <a:srgbClr val="5B6B7A"/>
+                </a:solidFill>
+                <a:latin typeface="Segoe UI"/>
+              </a:rPr>
+              <a:t>trialed × cleared</a:t>
+            </a:r>
+          </a:p>
+        </p:txBody>
+      </p:sp>
+      <p:sp>
+        <p:nvSpPr>
+          <p:cNvPr id="21" name="Rounded Rectangle 20"/>
+          <p:cNvSpPr/>
+          <p:nvPr/>
+        </p:nvSpPr>
+        <p:spPr>
+          <a:xfrm>
+            <a:off x="5486400" y="2880360"/>
+            <a:ext cx="1463040" cy="1188720"/>
           </a:xfrm>
           <a:prstGeom prst="roundRect">
             <a:avLst/>
@@ -5273,7 +5340,7 @@
           <a:solidFill>
             <a:srgbClr val="FDF3E3"/>
           </a:solidFill>
-          <a:ln w="15875">
+          <a:ln w="19050">
             <a:solidFill>
               <a:srgbClr val="B8842A"/>
             </a:solidFill>
@@ -5295,176 +5362,178 @@
           </a:fontRef>
         </p:style>
         <p:txBody>
-          <a:bodyPr rtlCol="0" anchor="ctr"/>
+          <a:bodyPr rtlCol="0" anchor="ctr" wrap="square"/>
           <a:lstStyle/>
           <a:p>
             <a:pPr algn="ctr"/>
             <a:r>
-              <a:rPr sz="1250" b="1" i="0">
+              <a:rPr sz="1200" b="1" i="0">
                 <a:solidFill>
                   <a:srgbClr val="B8842A"/>
                 </a:solidFill>
                 <a:latin typeface="Segoe UI"/>
               </a:rPr>
-              <a:t>H-MEM — shared evidence memory  ·  source · provenance</a:t>
-            </a:r>
-          </a:p>
-        </p:txBody>
-      </p:sp>
-      <p:cxnSp>
-        <p:nvCxnSpPr>
-          <p:cNvPr id="19" name="Connector 18"/>
-          <p:cNvCxnSpPr/>
-          <p:nvPr/>
-        </p:nvCxnSpPr>
-        <p:spPr>
-          <a:xfrm>
-            <a:off x="3829415" y="3611880"/>
-            <a:ext cx="0" cy="685800"/>
-          </a:xfrm>
-          <a:prstGeom prst="line">
-            <a:avLst/>
-          </a:prstGeom>
+              <a:t>H-MEM</a:t>
+            </a:r>
+          </a:p>
+          <a:p>
+            <a:pPr algn="ctr"/>
+            <a:r>
+              <a:rPr sz="800" b="0" i="0">
+                <a:solidFill>
+                  <a:srgbClr val="5B6B7A"/>
+                </a:solidFill>
+                <a:latin typeface="Segoe UI"/>
+              </a:rPr>
+              <a:t>shared evidence · provenance</a:t>
+            </a:r>
+          </a:p>
+        </p:txBody>
+      </p:sp>
+      <p:sp>
+        <p:nvSpPr>
+          <p:cNvPr id="22" name="Rounded Rectangle 21"/>
+          <p:cNvSpPr/>
+          <p:nvPr/>
+        </p:nvSpPr>
+        <p:spPr>
+          <a:xfrm>
+            <a:off x="7475220" y="3040379"/>
+            <a:ext cx="1508760" cy="868680"/>
+          </a:xfrm>
+          <a:prstGeom prst="roundRect">
+            <a:avLst/>
+          </a:prstGeom>
+          <a:solidFill>
+            <a:srgbClr val="FFFFFF"/>
+          </a:solidFill>
           <a:ln w="19050">
             <a:solidFill>
-              <a:srgbClr val="9AA7B2"/>
+              <a:srgbClr val="128A98"/>
             </a:solidFill>
-            <a:tailEnd type="triangle" w="med" len="med"/>
           </a:ln>
+          <a:effectLst/>
         </p:spPr>
         <p:style>
-          <a:lnRef idx="2">
+          <a:lnRef idx="1">
             <a:schemeClr val="accent1"/>
           </a:lnRef>
-          <a:fillRef idx="0">
+          <a:fillRef idx="3">
             <a:schemeClr val="accent1"/>
           </a:fillRef>
-          <a:effectRef idx="1">
+          <a:effectRef idx="2">
             <a:schemeClr val="accent1"/>
           </a:effectRef>
           <a:fontRef idx="minor">
-            <a:schemeClr val="tx1"/>
+            <a:schemeClr val="lt1"/>
           </a:fontRef>
         </p:style>
-      </p:cxnSp>
-      <p:cxnSp>
-        <p:nvCxnSpPr>
-          <p:cNvPr id="20" name="Connector 19"/>
-          <p:cNvCxnSpPr/>
-          <p:nvPr/>
-        </p:nvCxnSpPr>
-        <p:spPr>
-          <a:xfrm>
-            <a:off x="6095847" y="3611880"/>
-            <a:ext cx="0" cy="685800"/>
-          </a:xfrm>
-          <a:prstGeom prst="line">
-            <a:avLst/>
-          </a:prstGeom>
+        <p:txBody>
+          <a:bodyPr rtlCol="0" anchor="ctr" wrap="square"/>
+          <a:lstStyle/>
+          <a:p>
+            <a:pPr algn="ctr"/>
+            <a:r>
+              <a:rPr sz="1300" b="1" i="0">
+                <a:solidFill>
+                  <a:srgbClr val="14202B"/>
+                </a:solidFill>
+                <a:latin typeface="Segoe UI"/>
+              </a:rPr>
+              <a:t>Reporter</a:t>
+            </a:r>
+          </a:p>
+          <a:p>
+            <a:pPr algn="ctr"/>
+            <a:r>
+              <a:rPr sz="900" b="0" i="0">
+                <a:solidFill>
+                  <a:srgbClr val="5B6B7A"/>
+                </a:solidFill>
+                <a:latin typeface="Segoe UI"/>
+              </a:rPr>
+              <a:t>cite claims</a:t>
+            </a:r>
+          </a:p>
+        </p:txBody>
+      </p:sp>
+      <p:sp>
+        <p:nvSpPr>
+          <p:cNvPr id="23" name="Rounded Rectangle 22"/>
+          <p:cNvSpPr/>
+          <p:nvPr/>
+        </p:nvSpPr>
+        <p:spPr>
+          <a:xfrm>
+            <a:off x="9395460" y="3040379"/>
+            <a:ext cx="1508760" cy="868680"/>
+          </a:xfrm>
+          <a:prstGeom prst="roundRect">
+            <a:avLst/>
+          </a:prstGeom>
+          <a:solidFill>
+            <a:srgbClr val="128A98"/>
+          </a:solidFill>
           <a:ln w="19050">
             <a:solidFill>
-              <a:srgbClr val="9AA7B2"/>
+              <a:srgbClr val="128A98"/>
             </a:solidFill>
-            <a:tailEnd type="triangle" w="med" len="med"/>
           </a:ln>
+          <a:effectLst/>
         </p:spPr>
         <p:style>
-          <a:lnRef idx="2">
+          <a:lnRef idx="1">
             <a:schemeClr val="accent1"/>
           </a:lnRef>
-          <a:fillRef idx="0">
+          <a:fillRef idx="3">
             <a:schemeClr val="accent1"/>
           </a:fillRef>
-          <a:effectRef idx="1">
+          <a:effectRef idx="2">
             <a:schemeClr val="accent1"/>
           </a:effectRef>
           <a:fontRef idx="minor">
-            <a:schemeClr val="tx1"/>
+            <a:schemeClr val="lt1"/>
           </a:fontRef>
         </p:style>
-      </p:cxnSp>
-      <p:cxnSp>
-        <p:nvCxnSpPr>
-          <p:cNvPr id="21" name="Connector 20"/>
-          <p:cNvCxnSpPr/>
-          <p:nvPr/>
-        </p:nvCxnSpPr>
-        <p:spPr>
-          <a:xfrm flipV="1">
-            <a:off x="8362279" y="3611880"/>
-            <a:ext cx="0" cy="685800"/>
-          </a:xfrm>
-          <a:prstGeom prst="line">
-            <a:avLst/>
-          </a:prstGeom>
-          <a:ln w="19050">
-            <a:solidFill>
-              <a:srgbClr val="9AA7B2"/>
-            </a:solidFill>
-            <a:tailEnd type="triangle" w="med" len="med"/>
-          </a:ln>
-        </p:spPr>
-        <p:style>
-          <a:lnRef idx="2">
-            <a:schemeClr val="accent1"/>
-          </a:lnRef>
-          <a:fillRef idx="0">
-            <a:schemeClr val="accent1"/>
-          </a:fillRef>
-          <a:effectRef idx="1">
-            <a:schemeClr val="accent1"/>
-          </a:effectRef>
-          <a:fontRef idx="minor">
-            <a:schemeClr val="tx1"/>
-          </a:fontRef>
-        </p:style>
-      </p:cxnSp>
-      <p:cxnSp>
-        <p:nvCxnSpPr>
-          <p:cNvPr id="22" name="Connector 21"/>
-          <p:cNvCxnSpPr/>
-          <p:nvPr/>
-        </p:nvCxnSpPr>
-        <p:spPr>
-          <a:xfrm flipV="1">
-            <a:off x="10628711" y="3611880"/>
-            <a:ext cx="0" cy="685800"/>
-          </a:xfrm>
-          <a:prstGeom prst="line">
-            <a:avLst/>
-          </a:prstGeom>
-          <a:ln w="19050">
-            <a:solidFill>
-              <a:srgbClr val="9AA7B2"/>
-            </a:solidFill>
-            <a:tailEnd type="triangle" w="med" len="med"/>
-          </a:ln>
-        </p:spPr>
-        <p:style>
-          <a:lnRef idx="2">
-            <a:schemeClr val="accent1"/>
-          </a:lnRef>
-          <a:fillRef idx="0">
-            <a:schemeClr val="accent1"/>
-          </a:fillRef>
-          <a:effectRef idx="1">
-            <a:schemeClr val="accent1"/>
-          </a:effectRef>
-          <a:fontRef idx="minor">
-            <a:schemeClr val="tx1"/>
-          </a:fontRef>
-        </p:style>
-      </p:cxnSp>
-      <p:sp>
-        <p:nvSpPr>
-          <p:cNvPr id="23" name="TextBox 22"/>
+        <p:txBody>
+          <a:bodyPr rtlCol="0" anchor="ctr" wrap="square"/>
+          <a:lstStyle/>
+          <a:p>
+            <a:pPr algn="ctr"/>
+            <a:r>
+              <a:rPr sz="1300" b="1" i="0">
+                <a:solidFill>
+                  <a:srgbClr val="FFFFFF"/>
+                </a:solidFill>
+                <a:latin typeface="Segoe UI"/>
+              </a:rPr>
+              <a:t>Evaluator</a:t>
+            </a:r>
+          </a:p>
+          <a:p>
+            <a:pPr algn="ctr"/>
+            <a:r>
+              <a:rPr sz="900" b="0" i="0">
+                <a:solidFill>
+                  <a:srgbClr val="DDF0F2"/>
+                </a:solidFill>
+                <a:latin typeface="Segoe UI"/>
+              </a:rPr>
+              <a:t>verify / reject</a:t>
+            </a:r>
+          </a:p>
+        </p:txBody>
+      </p:sp>
+      <p:sp>
+        <p:nvSpPr>
+          <p:cNvPr id="24" name="TextBox 23"/>
           <p:cNvSpPr txBox="1"/>
           <p:nvPr/>
         </p:nvSpPr>
         <p:spPr>
           <a:xfrm>
-            <a:off x="640080" y="5257800"/>
-            <a:ext cx="10881360" cy="457200"/>
+            <a:off x="2011680" y="1847088"/>
+            <a:ext cx="2743200" cy="274320"/>
           </a:xfrm>
           <a:prstGeom prst="rect">
             <a:avLst/>
@@ -5479,20 +5548,90 @@
           <a:p>
             <a:pPr algn="ctr"/>
             <a:r>
+              <a:rPr sz="1100" b="1" i="0">
+                <a:solidFill>
+                  <a:srgbClr val="128A98"/>
+                </a:solidFill>
+                <a:latin typeface="Segoe UI"/>
+              </a:rPr>
+              <a:t>sub-questions · in parallel</a:t>
+            </a:r>
+          </a:p>
+        </p:txBody>
+      </p:sp>
+      <p:sp>
+        <p:nvSpPr>
+          <p:cNvPr id="25" name="TextBox 24"/>
+          <p:cNvSpPr txBox="1"/>
+          <p:nvPr/>
+        </p:nvSpPr>
+        <p:spPr>
+          <a:xfrm>
+            <a:off x="7909560" y="2391155"/>
+            <a:ext cx="2560320" cy="274320"/>
+          </a:xfrm>
+          <a:prstGeom prst="rect">
+            <a:avLst/>
+          </a:prstGeom>
+          <a:noFill/>
+        </p:spPr>
+        <p:txBody>
+          <a:bodyPr wrap="square" anchor="t">
+            <a:spAutoFit/>
+          </a:bodyPr>
+          <a:lstStyle/>
+          <a:p>
+            <a:pPr algn="ctr"/>
+            <a:r>
+              <a:rPr sz="1100" b="1" i="0">
+                <a:solidFill>
+                  <a:srgbClr val="B8842A"/>
+                </a:solidFill>
+                <a:latin typeface="Segoe UI"/>
+              </a:rPr>
+              <a:t>✗ revise (≤ MAX_ROUNDS)</a:t>
+            </a:r>
+          </a:p>
+        </p:txBody>
+      </p:sp>
+      <p:sp>
+        <p:nvSpPr>
+          <p:cNvPr id="26" name="TextBox 25"/>
+          <p:cNvSpPr txBox="1"/>
+          <p:nvPr/>
+        </p:nvSpPr>
+        <p:spPr>
+          <a:xfrm>
+            <a:off x="640080" y="5120640"/>
+            <a:ext cx="10881360" cy="640080"/>
+          </a:xfrm>
+          <a:prstGeom prst="rect">
+            <a:avLst/>
+          </a:prstGeom>
+          <a:noFill/>
+        </p:spPr>
+        <p:txBody>
+          <a:bodyPr wrap="square" anchor="t">
+            <a:spAutoFit/>
+          </a:bodyPr>
+          <a:lstStyle/>
+          <a:p>
+            <a:pPr algn="ctr"/>
+            <a:r>
               <a:rPr sz="1200" b="0" i="0">
                 <a:solidFill>
                   <a:srgbClr val="5B6B7A"/>
                 </a:solidFill>
                 <a:latin typeface="Segoe UI"/>
               </a:rPr>
-              <a:t>Left to right, but not a pipeline — specialized roles share a common memory (gatherers write · consumers read), with a verify-and-revise feedback loop.</a:t>
-            </a:r>
-          </a:p>
-        </p:txBody>
-      </p:sp>
-      <p:sp>
-        <p:nvSpPr>
-          <p:cNvPr id="24" name="Rectangle 23"/>
+              <a:t>Planner fans out into parallel gatherer agents that write to shared memory; Reporter &amp; Evaluator read it, and the Evaluator loops rejections back to revise.</a:t>
+            </a:r>
+          </a:p>
+        </p:txBody>
+      </p:sp>
+      <p:sp>
+        <p:nvSpPr>
+          <p:cNvPr id="27" name="Rectangle 26"/>
           <p:cNvSpPr/>
           <p:nvPr/>
         </p:nvSpPr>
@@ -5536,7 +5675,7 @@
       </p:sp>
       <p:sp>
         <p:nvSpPr>
-          <p:cNvPr id="25" name="TextBox 24"/>
+          <p:cNvPr id="28" name="TextBox 27"/>
           <p:cNvSpPr txBox="1"/>
           <p:nvPr/>
         </p:nvSpPr>

</xml_diff>

<commit_message>
Deck: concrete Cursor sponsor bullet + sync telemetry to the re-recorded run
- Slide 8 Cursor bullet: "dev environment" -> "its Composer agent built the
  /healthz stack-health endpoint" (honest, specific — stronger for Sponsor Tech).
- Synced "Telemetry per run" to the re-recorded parallel run (26 calls / 46,989
  tokens) so Slide 8 matches Slide 4's hero; same fix in docs/judge-qa.md.
- SESSION-LOG.md: marked Cursor done (all four sponsor techs genuinely used).

Co-Authored-By: Claude Opus 4.8 (1M context) <noreply@anthropic.com>
</commit_message>
<xml_diff>
--- a/deck/Evidence-Intelligence-Agent.pptx
+++ b/deck/Evidence-Intelligence-Agent.pptx
@@ -7192,7 +7192,7 @@
                 </a:solidFill>
                 <a:latin typeface="Segoe UI"/>
               </a:rPr>
-              <a:t> — development environment.</a:t>
+              <a:t> — dev environment; its Composer agent built the /healthz stack-health endpoint.</a:t>
             </a:r>
           </a:p>
           <a:p>
@@ -7226,7 +7226,7 @@
                 </a:solidFill>
                 <a:latin typeface="Segoe UI"/>
               </a:rPr>
-              <a:t> 24 Meterless-routed calls · 41,480 tokens · signed receipts.</a:t>
+              <a:t> 26 Meterless-routed calls · 46,989 tokens · signed receipts.</a:t>
             </a:r>
           </a:p>
         </p:txBody>

</xml_diff>